<commit_message>
ajusta reparto y presentacion a la pauta de la EP2
</commit_message>
<xml_diff>
--- a/presentation/archivos/Sign_Language_MNIST_CNN_EP2.pptx
+++ b/presentation/archivos/Sign_Language_MNIST_CNN_EP2.pptx
@@ -2,22 +2,22 @@
 <file path=ppt/presentation.xml><?xml version="1.0" encoding="utf-8"?>
 <p:presentation xmlns:p="http://schemas.openxmlformats.org/presentationml/2006/main">
   <p:sldMasterIdLst>
-    <p:sldMasterId xmlns:r="http://schemas.openxmlformats.org/officeDocument/2006/relationships" id="2147483648" r:id="Red3212fcb5234b07"/>
+    <p:sldMasterId xmlns:r="http://schemas.openxmlformats.org/officeDocument/2006/relationships" id="2147483648" r:id="R90f979c29b7d4e92"/>
   </p:sldMasterIdLst>
   <p:notesMasterIdLst>
-    <p:notesMasterId xmlns:r="http://schemas.openxmlformats.org/officeDocument/2006/relationships" r:id="R0c1f444a096945dd"/>
+    <p:notesMasterId xmlns:r="http://schemas.openxmlformats.org/officeDocument/2006/relationships" r:id="R741a856add254dde"/>
   </p:notesMasterIdLst>
   <p:sldIdLst>
-    <p:sldId xmlns:r="http://schemas.openxmlformats.org/officeDocument/2006/relationships" id="256" r:id="R9670410e5d2a46fc"/>
-    <p:sldId xmlns:r="http://schemas.openxmlformats.org/officeDocument/2006/relationships" id="257" r:id="Rede07bc9507941ae"/>
-    <p:sldId xmlns:r="http://schemas.openxmlformats.org/officeDocument/2006/relationships" id="258" r:id="R128369c727e248b4"/>
-    <p:sldId xmlns:r="http://schemas.openxmlformats.org/officeDocument/2006/relationships" id="259" r:id="R5a53b5e2e1d64a34"/>
-    <p:sldId xmlns:r="http://schemas.openxmlformats.org/officeDocument/2006/relationships" id="260" r:id="R6701eaf135614e3d"/>
-    <p:sldId xmlns:r="http://schemas.openxmlformats.org/officeDocument/2006/relationships" id="261" r:id="Rf48bb5fba0a64d2a"/>
-    <p:sldId xmlns:r="http://schemas.openxmlformats.org/officeDocument/2006/relationships" id="262" r:id="Raf69628eeb114d96"/>
-    <p:sldId xmlns:r="http://schemas.openxmlformats.org/officeDocument/2006/relationships" id="263" r:id="Rf9e4216c9eab4f94"/>
-    <p:sldId xmlns:r="http://schemas.openxmlformats.org/officeDocument/2006/relationships" id="264" r:id="R49b97e5b4a5e4ea0"/>
-    <p:sldId xmlns:r="http://schemas.openxmlformats.org/officeDocument/2006/relationships" id="265" r:id="R5d366409ac24435e"/>
+    <p:sldId xmlns:r="http://schemas.openxmlformats.org/officeDocument/2006/relationships" id="256" r:id="R60a4bb9e3a9441bf"/>
+    <p:sldId xmlns:r="http://schemas.openxmlformats.org/officeDocument/2006/relationships" id="257" r:id="R8daaa208960341ac"/>
+    <p:sldId xmlns:r="http://schemas.openxmlformats.org/officeDocument/2006/relationships" id="258" r:id="R3c8281954dc0414f"/>
+    <p:sldId xmlns:r="http://schemas.openxmlformats.org/officeDocument/2006/relationships" id="259" r:id="Ra699eb8221fa443f"/>
+    <p:sldId xmlns:r="http://schemas.openxmlformats.org/officeDocument/2006/relationships" id="260" r:id="Rcddd2d9b42524157"/>
+    <p:sldId xmlns:r="http://schemas.openxmlformats.org/officeDocument/2006/relationships" id="261" r:id="R97e23080d8114ab3"/>
+    <p:sldId xmlns:r="http://schemas.openxmlformats.org/officeDocument/2006/relationships" id="262" r:id="R5152a901ed324e61"/>
+    <p:sldId xmlns:r="http://schemas.openxmlformats.org/officeDocument/2006/relationships" id="263" r:id="Re48d762f43854370"/>
+    <p:sldId xmlns:r="http://schemas.openxmlformats.org/officeDocument/2006/relationships" id="264" r:id="R25ee2e3cf1b44449"/>
+    <p:sldId xmlns:r="http://schemas.openxmlformats.org/officeDocument/2006/relationships" id="265" r:id="R6d893923f4d34fb0"/>
   </p:sldIdLst>
   <p:sldSz cx="12192000" cy="6858000"/>
   <p:notesSz cx="6858000" cy="9144000"/>
@@ -626,7 +626,7 @@
           </a:p>
           <a:p xmlns:a="http://schemas.openxmlformats.org/drawingml/2006/main">
             <a:r>
-              <a:t>El dataset contiene imágenes de 28 por 28 píxeles en escala de grises. Hay 27.455 imágenes en el archivo de entrenamiento y 7.172 en el test oficial. Trabajamos con 24 clases. J y Z no aparecen porque sus señas requieren movimiento y el dataset es estático. El gráfico muestra cantidades parecidas entre clases, aunque no exactamente iguales.</a:t>
+              <a:t>No repetimos la limpieza de la EP1. Reutilizamos el mismo dataset ya validado, las mismas 24 clases, las mismas particiones y la semilla 42. Así la comparación es objetiva. Lo que cambia es el modelo: el MLP recibe un vector plano de 784 valores y la CNN recibe un tensor de 28 por 28 por 1 para aprovechar la estructura espacial.</a:t>
             </a:r>
           </a:p>
           <a:p xmlns:a="http://schemas.openxmlformats.org/drawingml/2006/main">
@@ -636,7 +636,7 @@
           </a:p>
           <a:p xmlns:a="http://schemas.openxmlformats.org/drawingml/2006/main">
             <a:r>
-              <a:t>Fuente: data/raw/sign_mnist_train.csv, data/raw/sign_mnist_test.csv e images/gonzalo_class_distribution.png</a:t>
+              <a:t>Fuente: README.md, src/sign_mlp/data.py y reports/mlp_cnn_comparison.csv</a:t>
             </a:r>
           </a:p>
         </p:txBody>
@@ -711,7 +711,7 @@
           </a:p>
           <a:p xmlns:a="http://schemas.openxmlformats.org/drawingml/2006/main">
             <a:r>
-              <a:t>Cada fila del CSV tiene 784 valores porque 28 por 28 es 784. Para la CNN reconstruimos la imagen como un tensor de 28 por 28 por 1: alto, ancho y un canal de gris. Dividimos los píxeles por 255 porque es la intensidad máxima de 8 bits y así el rango queda entre 0 y 1. Conservamos 21.964 imágenes para entrenar, 5.491 para validar y 7.172 para test.</a:t>
+              <a:t>Cada fila del CSV tiene 784 valores porque 28 por 28 es 784. Para la CNN reconstruimos la imagen como un tensor de 28 por 28 por 1: alto, ancho y un canal de gris. Dividimos los píxeles por 255 porque es la intensidad máxima de 8 bits y así el rango queda entre 0 y 1. Esta es la adaptación principal de datos de la EP2, no una nueva limpieza. Conservamos 21.964 imágenes para entrenar, 5.491 para validar y 7.172 para test.</a:t>
             </a:r>
           </a:p>
           <a:p xmlns:a="http://schemas.openxmlformats.org/drawingml/2006/main">
@@ -1278,7 +1278,7 @@
           <p:cNvPr id="3" name="Title">
             <a:extLst xmlns:a="http://schemas.openxmlformats.org/drawingml/2006/main">
               <a:ext uri="{FF2B5EF4-FFF2-40B4-BE49-F238E27FC236}">
-                <a16:creationId xmlns:a16="http://schemas.microsoft.com/office/drawing/2014/main" id="{0878A9A3-216D-4DC5-9735-58919DCA5B9F}"/>
+                <a16:creationId xmlns:a16="http://schemas.microsoft.com/office/drawing/2014/main" id="{73D43AD6-F5F8-4B65-A409-164C0705205F}"/>
               </a:ext>
             </a:extLst>
           </p:cNvPr>
@@ -1507,7 +1507,7 @@
           <p:cNvPr id="2" name="Subtitle">
             <a:extLst xmlns:a="http://schemas.openxmlformats.org/drawingml/2006/main">
               <a:ext uri="{FF2B5EF4-FFF2-40B4-BE49-F238E27FC236}">
-                <a16:creationId xmlns:a16="http://schemas.microsoft.com/office/drawing/2014/main" id="{2DDF89A7-6EE8-48B3-A87A-314FE40E6394}"/>
+                <a16:creationId xmlns:a16="http://schemas.microsoft.com/office/drawing/2014/main" id="{618B1D9A-16D7-46F4-81BA-C12001922008}"/>
               </a:ext>
             </a:extLst>
           </p:cNvPr>
@@ -1753,7 +1753,7 @@
           <p:cNvPr id="2" name="Section title">
             <a:extLst xmlns:a="http://schemas.openxmlformats.org/drawingml/2006/main">
               <a:ext uri="{FF2B5EF4-FFF2-40B4-BE49-F238E27FC236}">
-                <a16:creationId xmlns:a16="http://schemas.microsoft.com/office/drawing/2014/main" id="{FAE677FD-FB89-437F-91BC-34050F8AA6FA}"/>
+                <a16:creationId xmlns:a16="http://schemas.microsoft.com/office/drawing/2014/main" id="{705822C6-50C0-458F-8E23-5FF6398986C9}"/>
               </a:ext>
             </a:extLst>
           </p:cNvPr>
@@ -1999,7 +1999,7 @@
           <p:cNvPr id="3" name="Title">
             <a:extLst xmlns:a="http://schemas.openxmlformats.org/drawingml/2006/main">
               <a:ext uri="{FF2B5EF4-FFF2-40B4-BE49-F238E27FC236}">
-                <a16:creationId xmlns:a16="http://schemas.microsoft.com/office/drawing/2014/main" id="{9B53F017-67EC-4CF8-A38D-E0B006960459}"/>
+                <a16:creationId xmlns:a16="http://schemas.microsoft.com/office/drawing/2014/main" id="{44ABDE50-7014-4AE1-AC4D-19AE36946870}"/>
               </a:ext>
             </a:extLst>
           </p:cNvPr>
@@ -2228,7 +2228,7 @@
           <p:cNvPr id="2" name="Body">
             <a:extLst xmlns:a="http://schemas.openxmlformats.org/drawingml/2006/main">
               <a:ext uri="{FF2B5EF4-FFF2-40B4-BE49-F238E27FC236}">
-                <a16:creationId xmlns:a16="http://schemas.microsoft.com/office/drawing/2014/main" id="{F7263A96-728A-40E1-AC9E-7CDC30DF9D23}"/>
+                <a16:creationId xmlns:a16="http://schemas.microsoft.com/office/drawing/2014/main" id="{C25CDDEB-091E-4D44-B821-F08F7CA13FE2}"/>
               </a:ext>
             </a:extLst>
           </p:cNvPr>
@@ -2474,7 +2474,7 @@
           <p:cNvPr id="4" name="Title">
             <a:extLst xmlns:a="http://schemas.openxmlformats.org/drawingml/2006/main">
               <a:ext uri="{FF2B5EF4-FFF2-40B4-BE49-F238E27FC236}">
-                <a16:creationId xmlns:a16="http://schemas.microsoft.com/office/drawing/2014/main" id="{D410FED4-2EA0-437D-BB27-696ADDE813EC}"/>
+                <a16:creationId xmlns:a16="http://schemas.microsoft.com/office/drawing/2014/main" id="{E443357B-CC19-4452-85D5-4B66BCF50769}"/>
               </a:ext>
             </a:extLst>
           </p:cNvPr>
@@ -2703,7 +2703,7 @@
           <p:cNvPr id="2" name="Left column">
             <a:extLst xmlns:a="http://schemas.openxmlformats.org/drawingml/2006/main">
               <a:ext uri="{FF2B5EF4-FFF2-40B4-BE49-F238E27FC236}">
-                <a16:creationId xmlns:a16="http://schemas.microsoft.com/office/drawing/2014/main" id="{4A3B37D4-8F22-49D4-B451-C74497DAAAC3}"/>
+                <a16:creationId xmlns:a16="http://schemas.microsoft.com/office/drawing/2014/main" id="{0C636B71-192B-4CE8-BB9B-05D28D659E29}"/>
               </a:ext>
             </a:extLst>
           </p:cNvPr>
@@ -2932,7 +2932,7 @@
           <p:cNvPr id="3" name="Right column">
             <a:extLst xmlns:a="http://schemas.openxmlformats.org/drawingml/2006/main">
               <a:ext uri="{FF2B5EF4-FFF2-40B4-BE49-F238E27FC236}">
-                <a16:creationId xmlns:a16="http://schemas.microsoft.com/office/drawing/2014/main" id="{A813EE09-7309-4707-9CE9-36AED2A98420}"/>
+                <a16:creationId xmlns:a16="http://schemas.microsoft.com/office/drawing/2014/main" id="{80F44569-F286-4ED3-BACD-31D9B99C6F54}"/>
               </a:ext>
             </a:extLst>
           </p:cNvPr>
@@ -3178,7 +3178,7 @@
           <p:cNvPr id="3" name="Title">
             <a:extLst xmlns:a="http://schemas.openxmlformats.org/drawingml/2006/main">
               <a:ext uri="{FF2B5EF4-FFF2-40B4-BE49-F238E27FC236}">
-                <a16:creationId xmlns:a16="http://schemas.microsoft.com/office/drawing/2014/main" id="{9FEFC26C-A09C-436E-A98B-0C2C395B04F4}"/>
+                <a16:creationId xmlns:a16="http://schemas.microsoft.com/office/drawing/2014/main" id="{C8D62547-AFCE-4301-BA62-08B153AD7B72}"/>
               </a:ext>
             </a:extLst>
           </p:cNvPr>
@@ -3407,7 +3407,7 @@
           <p:cNvPr id="2" name="Left column">
             <a:extLst xmlns:a="http://schemas.openxmlformats.org/drawingml/2006/main">
               <a:ext uri="{FF2B5EF4-FFF2-40B4-BE49-F238E27FC236}">
-                <a16:creationId xmlns:a16="http://schemas.microsoft.com/office/drawing/2014/main" id="{47DDA654-48FE-4083-8526-F005CE66BD63}"/>
+                <a16:creationId xmlns:a16="http://schemas.microsoft.com/office/drawing/2014/main" id="{77F9E21A-9C68-4176-AB65-47EF295EE01B}"/>
               </a:ext>
             </a:extLst>
           </p:cNvPr>
@@ -3674,12 +3674,12 @@
   </p:cSld>
   <p:clrMap bg1="lt1" tx1="dk1" bg2="lt2" tx2="dk2" accent1="accent1" accent2="accent2" accent3="accent3" accent4="accent4" accent5="accent5" accent6="accent6" hlink="hlink" folHlink="folHlink"/>
   <p:sldLayoutIdLst>
-    <p:sldLayoutId xmlns:r="http://schemas.openxmlformats.org/officeDocument/2006/relationships" id="2147483649" r:id="R7f5a637352a448ed"/>
-    <p:sldLayoutId xmlns:r="http://schemas.openxmlformats.org/officeDocument/2006/relationships" id="2147483650" r:id="R3a0d3a4e3563455d"/>
-    <p:sldLayoutId xmlns:r="http://schemas.openxmlformats.org/officeDocument/2006/relationships" id="2147483651" r:id="R4a4cd6181eb24ad8"/>
-    <p:sldLayoutId xmlns:r="http://schemas.openxmlformats.org/officeDocument/2006/relationships" id="2147483652" r:id="R85b60c9300864122"/>
-    <p:sldLayoutId xmlns:r="http://schemas.openxmlformats.org/officeDocument/2006/relationships" id="2147483653" r:id="Re83385c970cf401f"/>
-    <p:sldLayoutId xmlns:r="http://schemas.openxmlformats.org/officeDocument/2006/relationships" id="2147483654" r:id="R05bf6172a4534092"/>
+    <p:sldLayoutId xmlns:r="http://schemas.openxmlformats.org/officeDocument/2006/relationships" id="2147483649" r:id="Rc329850a4720445e"/>
+    <p:sldLayoutId xmlns:r="http://schemas.openxmlformats.org/officeDocument/2006/relationships" id="2147483650" r:id="R9537d23e761b4bda"/>
+    <p:sldLayoutId xmlns:r="http://schemas.openxmlformats.org/officeDocument/2006/relationships" id="2147483651" r:id="R19e835686b3f4e36"/>
+    <p:sldLayoutId xmlns:r="http://schemas.openxmlformats.org/officeDocument/2006/relationships" id="2147483652" r:id="R7e9ae8918fd24bd4"/>
+    <p:sldLayoutId xmlns:r="http://schemas.openxmlformats.org/officeDocument/2006/relationships" id="2147483653" r:id="R93f53d45171445b9"/>
+    <p:sldLayoutId xmlns:r="http://schemas.openxmlformats.org/officeDocument/2006/relationships" id="2147483654" r:id="R34b12a2e1a984aad"/>
   </p:sldLayoutIdLst>
   <p:txStyles>
     <p:titleStyle>
@@ -4487,7 +4487,7 @@
           <p:cNvPr id="6" name="">
             <a:extLst xmlns:a="http://schemas.openxmlformats.org/drawingml/2006/main">
               <a:ext uri="{FF2B5EF4-FFF2-40B4-BE49-F238E27FC236}">
-                <a16:creationId xmlns:a16="http://schemas.microsoft.com/office/drawing/2014/main" id="{AC516077-B93A-4770-8113-AB1270851D67}"/>
+                <a16:creationId xmlns:a16="http://schemas.microsoft.com/office/drawing/2014/main" id="{BFAB79D3-46A7-4721-96B0-B6435D6E429A}"/>
               </a:ext>
             </a:extLst>
           </p:cNvPr>
@@ -4667,7 +4667,7 @@
           <p:cNvPr id="2" name="">
             <a:extLst xmlns:a="http://schemas.openxmlformats.org/drawingml/2006/main">
               <a:ext uri="{FF2B5EF4-FFF2-40B4-BE49-F238E27FC236}">
-                <a16:creationId xmlns:a16="http://schemas.microsoft.com/office/drawing/2014/main" id="{921E6A63-FC99-46C6-8823-E749242861E1}"/>
+                <a16:creationId xmlns:a16="http://schemas.microsoft.com/office/drawing/2014/main" id="{BA559C2C-5153-49BC-9DE8-DD804E9564D0}"/>
               </a:ext>
             </a:extLst>
           </p:cNvPr>
@@ -4824,7 +4824,7 @@
           <p:cNvPr id="3" name="">
             <a:extLst xmlns:a="http://schemas.openxmlformats.org/drawingml/2006/main">
               <a:ext uri="{FF2B5EF4-FFF2-40B4-BE49-F238E27FC236}">
-                <a16:creationId xmlns:a16="http://schemas.microsoft.com/office/drawing/2014/main" id="{0123174A-0F3D-4AE3-89B2-FB1DD271EE29}"/>
+                <a16:creationId xmlns:a16="http://schemas.microsoft.com/office/drawing/2014/main" id="{71C709C3-7D58-4F09-975B-55C330F8D60B}"/>
               </a:ext>
             </a:extLst>
           </p:cNvPr>
@@ -4981,7 +4981,7 @@
           <p:cNvPr id="4" name="">
             <a:extLst xmlns:a="http://schemas.openxmlformats.org/drawingml/2006/main">
               <a:ext uri="{FF2B5EF4-FFF2-40B4-BE49-F238E27FC236}">
-                <a16:creationId xmlns:a16="http://schemas.microsoft.com/office/drawing/2014/main" id="{8E11BB30-DE53-46DD-AAE1-99603673EEDE}"/>
+                <a16:creationId xmlns:a16="http://schemas.microsoft.com/office/drawing/2014/main" id="{7C38D848-FF71-4C44-945A-B2976EA0DE28}"/>
               </a:ext>
             </a:extLst>
           </p:cNvPr>
@@ -5161,7 +5161,7 @@
           <p:cNvPr id="5" name="">
             <a:extLst xmlns:a="http://schemas.openxmlformats.org/drawingml/2006/main">
               <a:ext uri="{FF2B5EF4-FFF2-40B4-BE49-F238E27FC236}">
-                <a16:creationId xmlns:a16="http://schemas.microsoft.com/office/drawing/2014/main" id="{F5D26FC3-AABC-43B8-8214-7D8EFE632AB8}"/>
+                <a16:creationId xmlns:a16="http://schemas.microsoft.com/office/drawing/2014/main" id="{4D46B760-F9BD-4FF1-AA46-F0BF0DC3CAEC}"/>
               </a:ext>
             </a:extLst>
           </p:cNvPr>
@@ -5171,7 +5171,7 @@
           <p:nvPr/>
         </p:nvPicPr>
         <p:blipFill>
-          <a:blip xmlns:r="http://schemas.openxmlformats.org/officeDocument/2006/relationships" xmlns:a="http://schemas.openxmlformats.org/drawingml/2006/main" r:embed="Rc1cc6e0dce034a6f"/>
+          <a:blip xmlns:r="http://schemas.openxmlformats.org/officeDocument/2006/relationships" xmlns:a="http://schemas.openxmlformats.org/drawingml/2006/main" r:embed="R3772c06fdd0e4774"/>
           <a:stretch xmlns:a="http://schemas.openxmlformats.org/drawingml/2006/main"/>
         </p:blipFill>
         <p:spPr>
@@ -5187,7 +5187,7 @@
     </p:spTree>
     <p:extLst>
       <p:ext uri="{BB962C8B-B14F-4D97-AF65-F5344CB8AC3E}">
-        <p14:creationId xmlns:p14="http://schemas.microsoft.com/office/powerpoint/2010/main" val="837812396"/>
+        <p14:creationId xmlns:p14="http://schemas.microsoft.com/office/powerpoint/2010/main" val="807841116"/>
       </p:ext>
     </p:extLst>
   </p:cSld>
@@ -5218,7 +5218,7 @@
           <p:cNvPr id="12" name="">
             <a:extLst xmlns:a="http://schemas.openxmlformats.org/drawingml/2006/main">
               <a:ext uri="{FF2B5EF4-FFF2-40B4-BE49-F238E27FC236}">
-                <a16:creationId xmlns:a16="http://schemas.microsoft.com/office/drawing/2014/main" id="{F8059DE6-82ED-49D2-AEF2-C899176B3279}"/>
+                <a16:creationId xmlns:a16="http://schemas.microsoft.com/office/drawing/2014/main" id="{1A5E7B50-9759-4DC8-B258-90E47128F320}"/>
               </a:ext>
             </a:extLst>
           </p:cNvPr>
@@ -5375,7 +5375,7 @@
           <p:cNvPr id="2" name="">
             <a:extLst xmlns:a="http://schemas.openxmlformats.org/drawingml/2006/main">
               <a:ext uri="{FF2B5EF4-FFF2-40B4-BE49-F238E27FC236}">
-                <a16:creationId xmlns:a16="http://schemas.microsoft.com/office/drawing/2014/main" id="{7F33C862-3547-4DD9-88F4-6B5417AFAEB7}"/>
+                <a16:creationId xmlns:a16="http://schemas.microsoft.com/office/drawing/2014/main" id="{FB2D3488-F602-4C92-BA7D-0D0C213BCCC7}"/>
               </a:ext>
             </a:extLst>
           </p:cNvPr>
@@ -5532,7 +5532,7 @@
           <p:cNvPr id="3" name="">
             <a:extLst xmlns:a="http://schemas.openxmlformats.org/drawingml/2006/main">
               <a:ext uri="{FF2B5EF4-FFF2-40B4-BE49-F238E27FC236}">
-                <a16:creationId xmlns:a16="http://schemas.microsoft.com/office/drawing/2014/main" id="{E5E02E4C-6178-47F7-9A4C-44B59D4D6B03}"/>
+                <a16:creationId xmlns:a16="http://schemas.microsoft.com/office/drawing/2014/main" id="{158B07D6-5EF0-42D6-8943-29DA9943B37F}"/>
               </a:ext>
             </a:extLst>
           </p:cNvPr>
@@ -5689,7 +5689,7 @@
           <p:cNvPr id="4" name="">
             <a:extLst xmlns:a="http://schemas.openxmlformats.org/drawingml/2006/main">
               <a:ext uri="{FF2B5EF4-FFF2-40B4-BE49-F238E27FC236}">
-                <a16:creationId xmlns:a16="http://schemas.microsoft.com/office/drawing/2014/main" id="{00BD1A74-5F40-41E3-B9E1-D82E1270B640}"/>
+                <a16:creationId xmlns:a16="http://schemas.microsoft.com/office/drawing/2014/main" id="{CAC77E63-2DD7-44D7-9EF9-9E53F929600C}"/>
               </a:ext>
             </a:extLst>
           </p:cNvPr>
@@ -5846,7 +5846,7 @@
           <p:cNvPr id="5" name="">
             <a:extLst xmlns:a="http://schemas.openxmlformats.org/drawingml/2006/main">
               <a:ext uri="{FF2B5EF4-FFF2-40B4-BE49-F238E27FC236}">
-                <a16:creationId xmlns:a16="http://schemas.microsoft.com/office/drawing/2014/main" id="{02782B82-3E95-479B-9331-B5DB102C7C32}"/>
+                <a16:creationId xmlns:a16="http://schemas.microsoft.com/office/drawing/2014/main" id="{EA4A9F26-AD39-4A0D-A854-B81ED4E7DC97}"/>
               </a:ext>
             </a:extLst>
           </p:cNvPr>
@@ -6003,7 +6003,7 @@
           <p:cNvPr id="6" name="">
             <a:extLst xmlns:a="http://schemas.openxmlformats.org/drawingml/2006/main">
               <a:ext uri="{FF2B5EF4-FFF2-40B4-BE49-F238E27FC236}">
-                <a16:creationId xmlns:a16="http://schemas.microsoft.com/office/drawing/2014/main" id="{D3856CB8-EC9D-4634-8A2D-CD932BE76973}"/>
+                <a16:creationId xmlns:a16="http://schemas.microsoft.com/office/drawing/2014/main" id="{A4179F7C-473A-4BF9-B9E6-6B70E7803D0A}"/>
               </a:ext>
             </a:extLst>
           </p:cNvPr>
@@ -6160,7 +6160,7 @@
           <p:cNvPr id="7" name="">
             <a:extLst xmlns:a="http://schemas.openxmlformats.org/drawingml/2006/main">
               <a:ext uri="{FF2B5EF4-FFF2-40B4-BE49-F238E27FC236}">
-                <a16:creationId xmlns:a16="http://schemas.microsoft.com/office/drawing/2014/main" id="{2B55D05F-6299-4E46-83B3-190B09C686ED}"/>
+                <a16:creationId xmlns:a16="http://schemas.microsoft.com/office/drawing/2014/main" id="{CB418C18-1AE5-4827-9ABF-FC2F3A46AC56}"/>
               </a:ext>
             </a:extLst>
           </p:cNvPr>
@@ -6317,7 +6317,7 @@
           <p:cNvPr id="8" name="">
             <a:extLst xmlns:a="http://schemas.openxmlformats.org/drawingml/2006/main">
               <a:ext uri="{FF2B5EF4-FFF2-40B4-BE49-F238E27FC236}">
-                <a16:creationId xmlns:a16="http://schemas.microsoft.com/office/drawing/2014/main" id="{C930E6D8-7A0F-4E6E-9D75-FB4A02542170}"/>
+                <a16:creationId xmlns:a16="http://schemas.microsoft.com/office/drawing/2014/main" id="{62D30A11-48B4-4E71-A3BC-03EA66105172}"/>
               </a:ext>
             </a:extLst>
           </p:cNvPr>
@@ -6474,7 +6474,7 @@
           <p:cNvPr id="9" name="">
             <a:extLst xmlns:a="http://schemas.openxmlformats.org/drawingml/2006/main">
               <a:ext uri="{FF2B5EF4-FFF2-40B4-BE49-F238E27FC236}">
-                <a16:creationId xmlns:a16="http://schemas.microsoft.com/office/drawing/2014/main" id="{988923C5-79AA-49F2-97B5-554D622CD6B9}"/>
+                <a16:creationId xmlns:a16="http://schemas.microsoft.com/office/drawing/2014/main" id="{D482CB0C-E667-420D-92EB-8D1F92716E2B}"/>
               </a:ext>
             </a:extLst>
           </p:cNvPr>
@@ -6631,7 +6631,7 @@
           <p:cNvPr id="10" name="">
             <a:extLst xmlns:a="http://schemas.openxmlformats.org/drawingml/2006/main">
               <a:ext uri="{FF2B5EF4-FFF2-40B4-BE49-F238E27FC236}">
-                <a16:creationId xmlns:a16="http://schemas.microsoft.com/office/drawing/2014/main" id="{0A86DEC3-2D77-4DD7-9C77-E06A60D26F48}"/>
+                <a16:creationId xmlns:a16="http://schemas.microsoft.com/office/drawing/2014/main" id="{28240B3E-E583-43BA-A579-E21C69031ADE}"/>
               </a:ext>
             </a:extLst>
           </p:cNvPr>
@@ -6788,7 +6788,7 @@
           <p:cNvPr id="11" name="">
             <a:extLst xmlns:a="http://schemas.openxmlformats.org/drawingml/2006/main">
               <a:ext uri="{FF2B5EF4-FFF2-40B4-BE49-F238E27FC236}">
-                <a16:creationId xmlns:a16="http://schemas.microsoft.com/office/drawing/2014/main" id="{07E223F6-5634-4F53-A746-E9E5CB229BCC}"/>
+                <a16:creationId xmlns:a16="http://schemas.microsoft.com/office/drawing/2014/main" id="{BF51E7C5-B97B-4FB9-A78D-8BBE094C4E93}"/>
               </a:ext>
             </a:extLst>
           </p:cNvPr>
@@ -6943,7 +6943,7 @@
     </p:spTree>
     <p:extLst>
       <p:ext uri="{BB962C8B-B14F-4D97-AF65-F5344CB8AC3E}">
-        <p14:creationId xmlns:p14="http://schemas.microsoft.com/office/powerpoint/2010/main" val="78709031"/>
+        <p14:creationId xmlns:p14="http://schemas.microsoft.com/office/powerpoint/2010/main" val="1237155959"/>
       </p:ext>
     </p:extLst>
   </p:cSld>
@@ -6971,10 +6971,10 @@
       </p:grpSpPr>
       <p:sp>
         <p:nvSpPr>
-          <p:cNvPr id="13" name="">
+          <p:cNvPr id="16" name="">
             <a:extLst xmlns:a="http://schemas.openxmlformats.org/drawingml/2006/main">
               <a:ext uri="{FF2B5EF4-FFF2-40B4-BE49-F238E27FC236}">
-                <a16:creationId xmlns:a16="http://schemas.microsoft.com/office/drawing/2014/main" id="{FE39BCBA-2C6D-42DA-9A74-10431DED1B7C}"/>
+                <a16:creationId xmlns:a16="http://schemas.microsoft.com/office/drawing/2014/main" id="{AFF56531-D9AA-4340-9F15-3D49661A2B28}"/>
               </a:ext>
             </a:extLst>
           </p:cNvPr>
@@ -7121,7 +7121,7 @@
                 <a:ea typeface="Arial"/>
                 <a:cs typeface="Arial"/>
               </a:rPr>
-              <a:t>Mismo dataset, misma variante</a:t>
+              <a:t>Continuidad EP1 → EP2: cambia el modelo</a:t>
             </a:r>
           </a:p>
         </p:txBody>
@@ -7131,7 +7131,7 @@
           <p:cNvPr id="2" name="">
             <a:extLst xmlns:a="http://schemas.openxmlformats.org/drawingml/2006/main">
               <a:ext uri="{FF2B5EF4-FFF2-40B4-BE49-F238E27FC236}">
-                <a16:creationId xmlns:a16="http://schemas.microsoft.com/office/drawing/2014/main" id="{473183B0-3DF8-40FD-A8EB-91DA3388E25B}"/>
+                <a16:creationId xmlns:a16="http://schemas.microsoft.com/office/drawing/2014/main" id="{E474FA56-60C9-46E8-874B-EC348ABDD1CC}"/>
               </a:ext>
             </a:extLst>
           </p:cNvPr>
@@ -7288,7 +7288,7 @@
           <p:cNvPr id="3" name="">
             <a:extLst xmlns:a="http://schemas.openxmlformats.org/drawingml/2006/main">
               <a:ext uri="{FF2B5EF4-FFF2-40B4-BE49-F238E27FC236}">
-                <a16:creationId xmlns:a16="http://schemas.microsoft.com/office/drawing/2014/main" id="{988D648D-F141-4C7E-AAFE-7D57175A4588}"/>
+                <a16:creationId xmlns:a16="http://schemas.microsoft.com/office/drawing/2014/main" id="{F11BE22D-E703-438C-B36F-5AA1348930F4}"/>
               </a:ext>
             </a:extLst>
           </p:cNvPr>
@@ -7299,8 +7299,43 @@
         </p:nvSpPr>
         <p:spPr>
           <a:xfrm xmlns:a="http://schemas.openxmlformats.org/drawingml/2006/main">
-            <a:off x="552450" y="1285875"/>
-            <a:ext cx="2857500" cy="685800"/>
+            <a:off x="762000" y="1571625"/>
+            <a:ext cx="4000500" cy="2333625"/>
+          </a:xfrm>
+          <a:prstGeom xmlns:a="http://schemas.openxmlformats.org/drawingml/2006/main" prst="roundRect">
+            <a:avLst>
+              <a:gd name="adj" fmla="val 3265"/>
+            </a:avLst>
+          </a:prstGeom>
+          <a:solidFill xmlns:a="http://schemas.openxmlformats.org/drawingml/2006/main">
+            <a:srgbClr val="E8EEF4"/>
+          </a:solidFill>
+          <a:ln xmlns:a="http://schemas.openxmlformats.org/drawingml/2006/main" w="14288">
+            <a:solidFill>
+              <a:srgbClr val="087F8C"/>
+            </a:solidFill>
+            <a:prstDash val="solid"/>
+          </a:ln>
+        </p:spPr>
+      </p:sp>
+      <p:sp>
+        <p:nvSpPr>
+          <p:cNvPr id="4" name="">
+            <a:extLst xmlns:a="http://schemas.openxmlformats.org/drawingml/2006/main">
+              <a:ext uri="{FF2B5EF4-FFF2-40B4-BE49-F238E27FC236}">
+                <a16:creationId xmlns:a16="http://schemas.microsoft.com/office/drawing/2014/main" id="{E21CC061-17B1-4C00-AFC9-90BE70DA6AB2}"/>
+              </a:ext>
+            </a:extLst>
+          </p:cNvPr>
+          <p:cNvSpPr>
+            <a:spLocks xmlns:a="http://schemas.openxmlformats.org/drawingml/2006/main" noGrp="1"/>
+          </p:cNvSpPr>
+          <p:nvPr/>
+        </p:nvSpPr>
+        <p:spPr>
+          <a:xfrm xmlns:a="http://schemas.openxmlformats.org/drawingml/2006/main">
+            <a:off x="876300" y="1647825"/>
+            <a:ext cx="3771900" cy="361950"/>
           </a:xfrm>
           <a:prstGeom xmlns:a="http://schemas.openxmlformats.org/drawingml/2006/main" prst="rect">
             <a:avLst/>
@@ -7315,9 +7350,9 @@
           <a:bodyPr xmlns:a="http://schemas.openxmlformats.org/drawingml/2006/main" anchor="ctr"/>
           <a:lstStyle xmlns:a="http://schemas.openxmlformats.org/drawingml/2006/main">
             <a:defPPr algn="ctr">
-              <a:defRPr sz="3900" b="1">
-                <a:solidFill>
-                  <a:srgbClr val="087F8C"/>
+              <a:defRPr sz="1725" b="1">
+                <a:solidFill>
+                  <a:srgbClr val="17324D"/>
                 </a:solidFill>
                 <a:latin typeface="Arial"/>
                 <a:ea typeface="Arial"/>
@@ -7325,9 +7360,9 @@
               </a:defRPr>
             </a:defPPr>
             <a:lvl1pPr algn="ctr">
-              <a:defRPr sz="3900" b="1">
-                <a:solidFill>
-                  <a:srgbClr val="087F8C"/>
+              <a:defRPr sz="1725" b="1">
+                <a:solidFill>
+                  <a:srgbClr val="17324D"/>
                 </a:solidFill>
                 <a:latin typeface="Arial"/>
                 <a:ea typeface="Arial"/>
@@ -7335,9 +7370,9 @@
               </a:defRPr>
             </a:lvl1pPr>
             <a:lvl2pPr algn="ctr">
-              <a:defRPr sz="3900" b="1">
-                <a:solidFill>
-                  <a:srgbClr val="087F8C"/>
+              <a:defRPr sz="1725" b="1">
+                <a:solidFill>
+                  <a:srgbClr val="17324D"/>
                 </a:solidFill>
                 <a:latin typeface="Arial"/>
                 <a:ea typeface="Arial"/>
@@ -7345,9 +7380,9 @@
               </a:defRPr>
             </a:lvl2pPr>
             <a:lvl3pPr algn="ctr">
-              <a:defRPr sz="3900" b="1">
-                <a:solidFill>
-                  <a:srgbClr val="087F8C"/>
+              <a:defRPr sz="1725" b="1">
+                <a:solidFill>
+                  <a:srgbClr val="17324D"/>
                 </a:solidFill>
                 <a:latin typeface="Arial"/>
                 <a:ea typeface="Arial"/>
@@ -7355,9 +7390,9 @@
               </a:defRPr>
             </a:lvl3pPr>
             <a:lvl4pPr algn="ctr">
-              <a:defRPr sz="3900" b="1">
-                <a:solidFill>
-                  <a:srgbClr val="087F8C"/>
+              <a:defRPr sz="1725" b="1">
+                <a:solidFill>
+                  <a:srgbClr val="17324D"/>
                 </a:solidFill>
                 <a:latin typeface="Arial"/>
                 <a:ea typeface="Arial"/>
@@ -7365,9 +7400,9 @@
               </a:defRPr>
             </a:lvl4pPr>
             <a:lvl5pPr algn="ctr">
-              <a:defRPr sz="3900" b="1">
-                <a:solidFill>
-                  <a:srgbClr val="087F8C"/>
+              <a:defRPr sz="1725" b="1">
+                <a:solidFill>
+                  <a:srgbClr val="17324D"/>
                 </a:solidFill>
                 <a:latin typeface="Arial"/>
                 <a:ea typeface="Arial"/>
@@ -7375,9 +7410,9 @@
               </a:defRPr>
             </a:lvl5pPr>
             <a:lvl6pPr algn="ctr">
-              <a:defRPr sz="3900" b="1">
-                <a:solidFill>
-                  <a:srgbClr val="087F8C"/>
+              <a:defRPr sz="1725" b="1">
+                <a:solidFill>
+                  <a:srgbClr val="17324D"/>
                 </a:solidFill>
                 <a:latin typeface="Arial"/>
                 <a:ea typeface="Arial"/>
@@ -7385,9 +7420,9 @@
               </a:defRPr>
             </a:lvl6pPr>
             <a:lvl7pPr algn="ctr">
-              <a:defRPr sz="3900" b="1">
-                <a:solidFill>
-                  <a:srgbClr val="087F8C"/>
+              <a:defRPr sz="1725" b="1">
+                <a:solidFill>
+                  <a:srgbClr val="17324D"/>
                 </a:solidFill>
                 <a:latin typeface="Arial"/>
                 <a:ea typeface="Arial"/>
@@ -7395,9 +7430,9 @@
               </a:defRPr>
             </a:lvl7pPr>
             <a:lvl8pPr algn="ctr">
-              <a:defRPr sz="3900" b="1">
-                <a:solidFill>
-                  <a:srgbClr val="087F8C"/>
+              <a:defRPr sz="1725" b="1">
+                <a:solidFill>
+                  <a:srgbClr val="17324D"/>
                 </a:solidFill>
                 <a:latin typeface="Arial"/>
                 <a:ea typeface="Arial"/>
@@ -7405,9 +7440,9 @@
               </a:defRPr>
             </a:lvl8pPr>
             <a:lvl9pPr algn="ctr">
-              <a:defRPr sz="3900" b="1">
-                <a:solidFill>
-                  <a:srgbClr val="087F8C"/>
+              <a:defRPr sz="1725" b="1">
+                <a:solidFill>
+                  <a:srgbClr val="17324D"/>
                 </a:solidFill>
                 <a:latin typeface="Arial"/>
                 <a:ea typeface="Arial"/>
@@ -7417,9 +7452,9 @@
           </a:lstStyle>
           <a:p xmlns:a="http://schemas.openxmlformats.org/drawingml/2006/main">
             <a:pPr algn="ctr">
-              <a:defRPr sz="3900" b="1">
-                <a:solidFill>
-                  <a:srgbClr val="087F8C"/>
+              <a:defRPr sz="1725" b="1">
+                <a:solidFill>
+                  <a:srgbClr val="17324D"/>
                 </a:solidFill>
                 <a:latin typeface="Arial"/>
                 <a:ea typeface="Arial"/>
@@ -7427,25 +7462,25 @@
               </a:defRPr>
             </a:pPr>
             <a:r>
-              <a:rPr sz="3900" b="1">
-                <a:solidFill>
-                  <a:srgbClr val="087F8C"/>
+              <a:rPr sz="1725" b="1">
+                <a:solidFill>
+                  <a:srgbClr val="17324D"/>
                 </a:solidFill>
                 <a:latin typeface="Arial"/>
                 <a:ea typeface="Arial"/>
                 <a:cs typeface="Arial"/>
               </a:rPr>
-              <a:t>28 × 28</a:t>
+              <a:t>MLP · EP1</a:t>
             </a:r>
           </a:p>
         </p:txBody>
       </p:sp>
       <p:sp>
         <p:nvSpPr>
-          <p:cNvPr id="4" name="">
+          <p:cNvPr id="5" name="">
             <a:extLst xmlns:a="http://schemas.openxmlformats.org/drawingml/2006/main">
               <a:ext uri="{FF2B5EF4-FFF2-40B4-BE49-F238E27FC236}">
-                <a16:creationId xmlns:a16="http://schemas.microsoft.com/office/drawing/2014/main" id="{2964C2E3-7ECA-4E25-8327-017C143116B6}"/>
+                <a16:creationId xmlns:a16="http://schemas.microsoft.com/office/drawing/2014/main" id="{C9763FD7-FF05-4A3E-A421-98A09547D320}"/>
               </a:ext>
             </a:extLst>
           </p:cNvPr>
@@ -7456,8 +7491,8 @@
         </p:nvSpPr>
         <p:spPr>
           <a:xfrm xmlns:a="http://schemas.openxmlformats.org/drawingml/2006/main">
-            <a:off x="552450" y="1943100"/>
-            <a:ext cx="2857500" cy="400050"/>
+            <a:off x="876300" y="2019300"/>
+            <a:ext cx="3771900" cy="1809750"/>
           </a:xfrm>
           <a:prstGeom xmlns:a="http://schemas.openxmlformats.org/drawingml/2006/main" prst="rect">
             <a:avLst/>
@@ -7472,9 +7507,9 @@
           <a:bodyPr xmlns:a="http://schemas.openxmlformats.org/drawingml/2006/main" anchor="ctr"/>
           <a:lstStyle xmlns:a="http://schemas.openxmlformats.org/drawingml/2006/main">
             <a:defPPr algn="ctr">
-              <a:defRPr sz="1500" b="0">
-                <a:solidFill>
-                  <a:srgbClr val="17324D"/>
+              <a:defRPr sz="1350" b="0">
+                <a:solidFill>
+                  <a:srgbClr val="4E5C68"/>
                 </a:solidFill>
                 <a:latin typeface="Arial"/>
                 <a:ea typeface="Arial"/>
@@ -7482,9 +7517,9 @@
               </a:defRPr>
             </a:defPPr>
             <a:lvl1pPr algn="ctr">
-              <a:defRPr sz="1500" b="0">
-                <a:solidFill>
-                  <a:srgbClr val="17324D"/>
+              <a:defRPr sz="1350" b="0">
+                <a:solidFill>
+                  <a:srgbClr val="4E5C68"/>
                 </a:solidFill>
                 <a:latin typeface="Arial"/>
                 <a:ea typeface="Arial"/>
@@ -7492,9 +7527,9 @@
               </a:defRPr>
             </a:lvl1pPr>
             <a:lvl2pPr algn="ctr">
-              <a:defRPr sz="1500" b="0">
-                <a:solidFill>
-                  <a:srgbClr val="17324D"/>
+              <a:defRPr sz="1350" b="0">
+                <a:solidFill>
+                  <a:srgbClr val="4E5C68"/>
                 </a:solidFill>
                 <a:latin typeface="Arial"/>
                 <a:ea typeface="Arial"/>
@@ -7502,9 +7537,9 @@
               </a:defRPr>
             </a:lvl2pPr>
             <a:lvl3pPr algn="ctr">
-              <a:defRPr sz="1500" b="0">
-                <a:solidFill>
-                  <a:srgbClr val="17324D"/>
+              <a:defRPr sz="1350" b="0">
+                <a:solidFill>
+                  <a:srgbClr val="4E5C68"/>
                 </a:solidFill>
                 <a:latin typeface="Arial"/>
                 <a:ea typeface="Arial"/>
@@ -7512,9 +7547,9 @@
               </a:defRPr>
             </a:lvl3pPr>
             <a:lvl4pPr algn="ctr">
-              <a:defRPr sz="1500" b="0">
-                <a:solidFill>
-                  <a:srgbClr val="17324D"/>
+              <a:defRPr sz="1350" b="0">
+                <a:solidFill>
+                  <a:srgbClr val="4E5C68"/>
                 </a:solidFill>
                 <a:latin typeface="Arial"/>
                 <a:ea typeface="Arial"/>
@@ -7522,9 +7557,9 @@
               </a:defRPr>
             </a:lvl4pPr>
             <a:lvl5pPr algn="ctr">
-              <a:defRPr sz="1500" b="0">
-                <a:solidFill>
-                  <a:srgbClr val="17324D"/>
+              <a:defRPr sz="1350" b="0">
+                <a:solidFill>
+                  <a:srgbClr val="4E5C68"/>
                 </a:solidFill>
                 <a:latin typeface="Arial"/>
                 <a:ea typeface="Arial"/>
@@ -7532,9 +7567,9 @@
               </a:defRPr>
             </a:lvl5pPr>
             <a:lvl6pPr algn="ctr">
-              <a:defRPr sz="1500" b="0">
-                <a:solidFill>
-                  <a:srgbClr val="17324D"/>
+              <a:defRPr sz="1350" b="0">
+                <a:solidFill>
+                  <a:srgbClr val="4E5C68"/>
                 </a:solidFill>
                 <a:latin typeface="Arial"/>
                 <a:ea typeface="Arial"/>
@@ -7542,9 +7577,9 @@
               </a:defRPr>
             </a:lvl6pPr>
             <a:lvl7pPr algn="ctr">
-              <a:defRPr sz="1500" b="0">
-                <a:solidFill>
-                  <a:srgbClr val="17324D"/>
+              <a:defRPr sz="1350" b="0">
+                <a:solidFill>
+                  <a:srgbClr val="4E5C68"/>
                 </a:solidFill>
                 <a:latin typeface="Arial"/>
                 <a:ea typeface="Arial"/>
@@ -7552,9 +7587,9 @@
               </a:defRPr>
             </a:lvl7pPr>
             <a:lvl8pPr algn="ctr">
-              <a:defRPr sz="1500" b="0">
-                <a:solidFill>
-                  <a:srgbClr val="17324D"/>
+              <a:defRPr sz="1350" b="0">
+                <a:solidFill>
+                  <a:srgbClr val="4E5C68"/>
                 </a:solidFill>
                 <a:latin typeface="Arial"/>
                 <a:ea typeface="Arial"/>
@@ -7562,9 +7597,9 @@
               </a:defRPr>
             </a:lvl8pPr>
             <a:lvl9pPr algn="ctr">
-              <a:defRPr sz="1500" b="0">
-                <a:solidFill>
-                  <a:srgbClr val="17324D"/>
+              <a:defRPr sz="1350" b="0">
+                <a:solidFill>
+                  <a:srgbClr val="4E5C68"/>
                 </a:solidFill>
                 <a:latin typeface="Arial"/>
                 <a:ea typeface="Arial"/>
@@ -7574,9 +7609,9 @@
           </a:lstStyle>
           <a:p xmlns:a="http://schemas.openxmlformats.org/drawingml/2006/main">
             <a:pPr algn="ctr">
-              <a:defRPr sz="1500" b="0">
-                <a:solidFill>
-                  <a:srgbClr val="17324D"/>
+              <a:defRPr sz="1350" b="0">
+                <a:solidFill>
+                  <a:srgbClr val="4E5C68"/>
                 </a:solidFill>
                 <a:latin typeface="Arial"/>
                 <a:ea typeface="Arial"/>
@@ -7584,25 +7619,71 @@
               </a:defRPr>
             </a:pPr>
             <a:r>
-              <a:rPr sz="1500" b="0">
-                <a:solidFill>
-                  <a:srgbClr val="17324D"/>
+              <a:rPr sz="1350" b="0">
+                <a:solidFill>
+                  <a:srgbClr val="4E5C68"/>
                 </a:solidFill>
                 <a:latin typeface="Arial"/>
                 <a:ea typeface="Arial"/>
                 <a:cs typeface="Arial"/>
               </a:rPr>
-              <a:t>píxeles en gris</a:t>
+              <a:t>Entrada: vector de 784 valores</a:t>
+            </a:r>
+          </a:p>
+          <a:p xmlns:a="http://schemas.openxmlformats.org/drawingml/2006/main">
+            <a:pPr algn="ctr">
+              <a:defRPr sz="1350" b="0">
+                <a:solidFill>
+                  <a:srgbClr val="4E5C68"/>
+                </a:solidFill>
+                <a:latin typeface="Arial"/>
+                <a:ea typeface="Arial"/>
+                <a:cs typeface="Arial"/>
+              </a:defRPr>
+            </a:pPr>
+            <a:r>
+              <a:rPr sz="1350" b="0">
+                <a:solidFill>
+                  <a:srgbClr val="4E5C68"/>
+                </a:solidFill>
+                <a:latin typeface="Arial"/>
+                <a:ea typeface="Arial"/>
+                <a:cs typeface="Arial"/>
+              </a:rPr>
+              <a:t>Conexiones densas globales</a:t>
+            </a:r>
+          </a:p>
+          <a:p xmlns:a="http://schemas.openxmlformats.org/drawingml/2006/main">
+            <a:pPr algn="ctr">
+              <a:defRPr sz="1350" b="0">
+                <a:solidFill>
+                  <a:srgbClr val="4E5C68"/>
+                </a:solidFill>
+                <a:latin typeface="Arial"/>
+                <a:ea typeface="Arial"/>
+                <a:cs typeface="Arial"/>
+              </a:defRPr>
+            </a:pPr>
+            <a:r>
+              <a:rPr sz="1350" b="0">
+                <a:solidFill>
+                  <a:srgbClr val="4E5C68"/>
+                </a:solidFill>
+                <a:latin typeface="Arial"/>
+                <a:ea typeface="Arial"/>
+                <a:cs typeface="Arial"/>
+              </a:rPr>
+              <a:t>569.240 parámetros</a:t>
             </a:r>
           </a:p>
         </p:txBody>
       </p:sp>
       <p:sp>
         <p:nvSpPr>
-          <p:cNvPr id="5" name="">
+          <p:cNvPr id="6" name="">
             <a:extLst xmlns:a="http://schemas.openxmlformats.org/drawingml/2006/main">
               <a:ext uri="{FF2B5EF4-FFF2-40B4-BE49-F238E27FC236}">
-                <a16:creationId xmlns:a16="http://schemas.microsoft.com/office/drawing/2014/main" id="{B6559E5C-8A05-4801-A34B-1A88425FDC7A}"/>
+                <a16:creationId xmlns:a16="http://schemas.microsoft.com/office/drawing/2014/main" id="{F2143735-1CBE-446B-8A11-7D52A61F13F5}"/>
               </a:ext>
             </a:extLst>
           </p:cNvPr>
@@ -7613,8 +7694,41 @@
         </p:nvSpPr>
         <p:spPr>
           <a:xfrm xmlns:a="http://schemas.openxmlformats.org/drawingml/2006/main">
-            <a:off x="3667125" y="1285875"/>
-            <a:ext cx="2857500" cy="685800"/>
+            <a:off x="5286375" y="2381250"/>
+            <a:ext cx="1428750" cy="647700"/>
+          </a:xfrm>
+          <a:prstGeom xmlns:a="http://schemas.openxmlformats.org/drawingml/2006/main" prst="rightArrow">
+            <a:avLst/>
+          </a:prstGeom>
+          <a:solidFill xmlns:a="http://schemas.openxmlformats.org/drawingml/2006/main">
+            <a:srgbClr val="087F8C"/>
+          </a:solidFill>
+          <a:ln xmlns:a="http://schemas.openxmlformats.org/drawingml/2006/main" w="0">
+            <a:solidFill>
+              <a:srgbClr val="087F8C"/>
+            </a:solidFill>
+            <a:prstDash val="solid"/>
+          </a:ln>
+        </p:spPr>
+      </p:sp>
+      <p:sp>
+        <p:nvSpPr>
+          <p:cNvPr id="7" name="">
+            <a:extLst xmlns:a="http://schemas.openxmlformats.org/drawingml/2006/main">
+              <a:ext uri="{FF2B5EF4-FFF2-40B4-BE49-F238E27FC236}">
+                <a16:creationId xmlns:a16="http://schemas.microsoft.com/office/drawing/2014/main" id="{AD1181C5-1031-4728-B9A2-B76343C3186A}"/>
+              </a:ext>
+            </a:extLst>
+          </p:cNvPr>
+          <p:cNvSpPr>
+            <a:spLocks xmlns:a="http://schemas.openxmlformats.org/drawingml/2006/main" noGrp="1"/>
+          </p:cNvSpPr>
+          <p:nvPr/>
+        </p:nvSpPr>
+        <p:spPr>
+          <a:xfrm xmlns:a="http://schemas.openxmlformats.org/drawingml/2006/main">
+            <a:off x="5191125" y="1924050"/>
+            <a:ext cx="1619250" cy="381000"/>
           </a:xfrm>
           <a:prstGeom xmlns:a="http://schemas.openxmlformats.org/drawingml/2006/main" prst="rect">
             <a:avLst/>
@@ -7629,7 +7743,7 @@
           <a:bodyPr xmlns:a="http://schemas.openxmlformats.org/drawingml/2006/main" anchor="ctr"/>
           <a:lstStyle xmlns:a="http://schemas.openxmlformats.org/drawingml/2006/main">
             <a:defPPr algn="ctr">
-              <a:defRPr sz="3900" b="1">
+              <a:defRPr sz="1500" b="1">
                 <a:solidFill>
                   <a:srgbClr val="087F8C"/>
                 </a:solidFill>
@@ -7639,7 +7753,7 @@
               </a:defRPr>
             </a:defPPr>
             <a:lvl1pPr algn="ctr">
-              <a:defRPr sz="3900" b="1">
+              <a:defRPr sz="1500" b="1">
                 <a:solidFill>
                   <a:srgbClr val="087F8C"/>
                 </a:solidFill>
@@ -7649,7 +7763,7 @@
               </a:defRPr>
             </a:lvl1pPr>
             <a:lvl2pPr algn="ctr">
-              <a:defRPr sz="3900" b="1">
+              <a:defRPr sz="1500" b="1">
                 <a:solidFill>
                   <a:srgbClr val="087F8C"/>
                 </a:solidFill>
@@ -7659,7 +7773,7 @@
               </a:defRPr>
             </a:lvl2pPr>
             <a:lvl3pPr algn="ctr">
-              <a:defRPr sz="3900" b="1">
+              <a:defRPr sz="1500" b="1">
                 <a:solidFill>
                   <a:srgbClr val="087F8C"/>
                 </a:solidFill>
@@ -7669,7 +7783,7 @@
               </a:defRPr>
             </a:lvl3pPr>
             <a:lvl4pPr algn="ctr">
-              <a:defRPr sz="3900" b="1">
+              <a:defRPr sz="1500" b="1">
                 <a:solidFill>
                   <a:srgbClr val="087F8C"/>
                 </a:solidFill>
@@ -7679,7 +7793,7 @@
               </a:defRPr>
             </a:lvl4pPr>
             <a:lvl5pPr algn="ctr">
-              <a:defRPr sz="3900" b="1">
+              <a:defRPr sz="1500" b="1">
                 <a:solidFill>
                   <a:srgbClr val="087F8C"/>
                 </a:solidFill>
@@ -7689,7 +7803,7 @@
               </a:defRPr>
             </a:lvl5pPr>
             <a:lvl6pPr algn="ctr">
-              <a:defRPr sz="3900" b="1">
+              <a:defRPr sz="1500" b="1">
                 <a:solidFill>
                   <a:srgbClr val="087F8C"/>
                 </a:solidFill>
@@ -7699,7 +7813,7 @@
               </a:defRPr>
             </a:lvl6pPr>
             <a:lvl7pPr algn="ctr">
-              <a:defRPr sz="3900" b="1">
+              <a:defRPr sz="1500" b="1">
                 <a:solidFill>
                   <a:srgbClr val="087F8C"/>
                 </a:solidFill>
@@ -7709,7 +7823,7 @@
               </a:defRPr>
             </a:lvl7pPr>
             <a:lvl8pPr algn="ctr">
-              <a:defRPr sz="3900" b="1">
+              <a:defRPr sz="1500" b="1">
                 <a:solidFill>
                   <a:srgbClr val="087F8C"/>
                 </a:solidFill>
@@ -7719,7 +7833,7 @@
               </a:defRPr>
             </a:lvl8pPr>
             <a:lvl9pPr algn="ctr">
-              <a:defRPr sz="3900" b="1">
+              <a:defRPr sz="1500" b="1">
                 <a:solidFill>
                   <a:srgbClr val="087F8C"/>
                 </a:solidFill>
@@ -7731,7 +7845,7 @@
           </a:lstStyle>
           <a:p xmlns:a="http://schemas.openxmlformats.org/drawingml/2006/main">
             <a:pPr algn="ctr">
-              <a:defRPr sz="3900" b="1">
+              <a:defRPr sz="1500" b="1">
                 <a:solidFill>
                   <a:srgbClr val="087F8C"/>
                 </a:solidFill>
@@ -7741,7 +7855,7 @@
               </a:defRPr>
             </a:pPr>
             <a:r>
-              <a:rPr sz="3900" b="1">
+              <a:rPr sz="1500" b="1">
                 <a:solidFill>
                   <a:srgbClr val="087F8C"/>
                 </a:solidFill>
@@ -7749,17 +7863,17 @@
                 <a:ea typeface="Arial"/>
                 <a:cs typeface="Arial"/>
               </a:rPr>
-              <a:t>27.455</a:t>
+              <a:t>misma tarea</a:t>
             </a:r>
           </a:p>
         </p:txBody>
       </p:sp>
       <p:sp>
         <p:nvSpPr>
-          <p:cNvPr id="6" name="">
+          <p:cNvPr id="8" name="">
             <a:extLst xmlns:a="http://schemas.openxmlformats.org/drawingml/2006/main">
               <a:ext uri="{FF2B5EF4-FFF2-40B4-BE49-F238E27FC236}">
-                <a16:creationId xmlns:a16="http://schemas.microsoft.com/office/drawing/2014/main" id="{C4EC1C52-B479-4266-802F-25A4BD17B7E6}"/>
+                <a16:creationId xmlns:a16="http://schemas.microsoft.com/office/drawing/2014/main" id="{6C69CCC7-10D9-42AD-B0FE-57C2C7712D66}"/>
               </a:ext>
             </a:extLst>
           </p:cNvPr>
@@ -7770,8 +7884,43 @@
         </p:nvSpPr>
         <p:spPr>
           <a:xfrm xmlns:a="http://schemas.openxmlformats.org/drawingml/2006/main">
-            <a:off x="3667125" y="1943100"/>
-            <a:ext cx="2857500" cy="400050"/>
+            <a:off x="7239000" y="1571625"/>
+            <a:ext cx="4000500" cy="2333625"/>
+          </a:xfrm>
+          <a:prstGeom xmlns:a="http://schemas.openxmlformats.org/drawingml/2006/main" prst="roundRect">
+            <a:avLst>
+              <a:gd name="adj" fmla="val 3265"/>
+            </a:avLst>
+          </a:prstGeom>
+          <a:solidFill xmlns:a="http://schemas.openxmlformats.org/drawingml/2006/main">
+            <a:srgbClr val="EAF4F5"/>
+          </a:solidFill>
+          <a:ln xmlns:a="http://schemas.openxmlformats.org/drawingml/2006/main" w="14288">
+            <a:solidFill>
+              <a:srgbClr val="087F8C"/>
+            </a:solidFill>
+            <a:prstDash val="solid"/>
+          </a:ln>
+        </p:spPr>
+      </p:sp>
+      <p:sp>
+        <p:nvSpPr>
+          <p:cNvPr id="9" name="">
+            <a:extLst xmlns:a="http://schemas.openxmlformats.org/drawingml/2006/main">
+              <a:ext uri="{FF2B5EF4-FFF2-40B4-BE49-F238E27FC236}">
+                <a16:creationId xmlns:a16="http://schemas.microsoft.com/office/drawing/2014/main" id="{7C818D29-82F9-4B84-AFB4-1C8544B90283}"/>
+              </a:ext>
+            </a:extLst>
+          </p:cNvPr>
+          <p:cNvSpPr>
+            <a:spLocks xmlns:a="http://schemas.openxmlformats.org/drawingml/2006/main" noGrp="1"/>
+          </p:cNvSpPr>
+          <p:nvPr/>
+        </p:nvSpPr>
+        <p:spPr>
+          <a:xfrm xmlns:a="http://schemas.openxmlformats.org/drawingml/2006/main">
+            <a:off x="7353300" y="1647825"/>
+            <a:ext cx="3771900" cy="361950"/>
           </a:xfrm>
           <a:prstGeom xmlns:a="http://schemas.openxmlformats.org/drawingml/2006/main" prst="rect">
             <a:avLst/>
@@ -7786,7 +7935,7 @@
           <a:bodyPr xmlns:a="http://schemas.openxmlformats.org/drawingml/2006/main" anchor="ctr"/>
           <a:lstStyle xmlns:a="http://schemas.openxmlformats.org/drawingml/2006/main">
             <a:defPPr algn="ctr">
-              <a:defRPr sz="1500" b="0">
+              <a:defRPr sz="1725" b="1">
                 <a:solidFill>
                   <a:srgbClr val="17324D"/>
                 </a:solidFill>
@@ -7796,7 +7945,7 @@
               </a:defRPr>
             </a:defPPr>
             <a:lvl1pPr algn="ctr">
-              <a:defRPr sz="1500" b="0">
+              <a:defRPr sz="1725" b="1">
                 <a:solidFill>
                   <a:srgbClr val="17324D"/>
                 </a:solidFill>
@@ -7806,7 +7955,7 @@
               </a:defRPr>
             </a:lvl1pPr>
             <a:lvl2pPr algn="ctr">
-              <a:defRPr sz="1500" b="0">
+              <a:defRPr sz="1725" b="1">
                 <a:solidFill>
                   <a:srgbClr val="17324D"/>
                 </a:solidFill>
@@ -7816,7 +7965,7 @@
               </a:defRPr>
             </a:lvl2pPr>
             <a:lvl3pPr algn="ctr">
-              <a:defRPr sz="1500" b="0">
+              <a:defRPr sz="1725" b="1">
                 <a:solidFill>
                   <a:srgbClr val="17324D"/>
                 </a:solidFill>
@@ -7826,7 +7975,7 @@
               </a:defRPr>
             </a:lvl3pPr>
             <a:lvl4pPr algn="ctr">
-              <a:defRPr sz="1500" b="0">
+              <a:defRPr sz="1725" b="1">
                 <a:solidFill>
                   <a:srgbClr val="17324D"/>
                 </a:solidFill>
@@ -7836,7 +7985,7 @@
               </a:defRPr>
             </a:lvl4pPr>
             <a:lvl5pPr algn="ctr">
-              <a:defRPr sz="1500" b="0">
+              <a:defRPr sz="1725" b="1">
                 <a:solidFill>
                   <a:srgbClr val="17324D"/>
                 </a:solidFill>
@@ -7846,7 +7995,7 @@
               </a:defRPr>
             </a:lvl5pPr>
             <a:lvl6pPr algn="ctr">
-              <a:defRPr sz="1500" b="0">
+              <a:defRPr sz="1725" b="1">
                 <a:solidFill>
                   <a:srgbClr val="17324D"/>
                 </a:solidFill>
@@ -7856,7 +8005,7 @@
               </a:defRPr>
             </a:lvl6pPr>
             <a:lvl7pPr algn="ctr">
-              <a:defRPr sz="1500" b="0">
+              <a:defRPr sz="1725" b="1">
                 <a:solidFill>
                   <a:srgbClr val="17324D"/>
                 </a:solidFill>
@@ -7866,7 +8015,7 @@
               </a:defRPr>
             </a:lvl7pPr>
             <a:lvl8pPr algn="ctr">
-              <a:defRPr sz="1500" b="0">
+              <a:defRPr sz="1725" b="1">
                 <a:solidFill>
                   <a:srgbClr val="17324D"/>
                 </a:solidFill>
@@ -7876,7 +8025,7 @@
               </a:defRPr>
             </a:lvl8pPr>
             <a:lvl9pPr algn="ctr">
-              <a:defRPr sz="1500" b="0">
+              <a:defRPr sz="1725" b="1">
                 <a:solidFill>
                   <a:srgbClr val="17324D"/>
                 </a:solidFill>
@@ -7888,7 +8037,7 @@
           </a:lstStyle>
           <a:p xmlns:a="http://schemas.openxmlformats.org/drawingml/2006/main">
             <a:pPr algn="ctr">
-              <a:defRPr sz="1500" b="0">
+              <a:defRPr sz="1725" b="1">
                 <a:solidFill>
                   <a:srgbClr val="17324D"/>
                 </a:solidFill>
@@ -7898,7 +8047,7 @@
               </a:defRPr>
             </a:pPr>
             <a:r>
-              <a:rPr sz="1500" b="0">
+              <a:rPr sz="1725" b="1">
                 <a:solidFill>
                   <a:srgbClr val="17324D"/>
                 </a:solidFill>
@@ -7906,17 +8055,17 @@
                 <a:ea typeface="Arial"/>
                 <a:cs typeface="Arial"/>
               </a:rPr>
-              <a:t>entrenamiento oficial</a:t>
+              <a:t>CNN · EP2</a:t>
             </a:r>
           </a:p>
         </p:txBody>
       </p:sp>
       <p:sp>
         <p:nvSpPr>
-          <p:cNvPr id="7" name="">
+          <p:cNvPr id="10" name="">
             <a:extLst xmlns:a="http://schemas.openxmlformats.org/drawingml/2006/main">
               <a:ext uri="{FF2B5EF4-FFF2-40B4-BE49-F238E27FC236}">
-                <a16:creationId xmlns:a16="http://schemas.microsoft.com/office/drawing/2014/main" id="{4F3F5955-CCBB-43C8-BD31-7D7DB31E1B4F}"/>
+                <a16:creationId xmlns:a16="http://schemas.microsoft.com/office/drawing/2014/main" id="{02A33488-27D6-4826-97E4-89666FCB8931}"/>
               </a:ext>
             </a:extLst>
           </p:cNvPr>
@@ -7927,8 +8076,8 @@
         </p:nvSpPr>
         <p:spPr>
           <a:xfrm xmlns:a="http://schemas.openxmlformats.org/drawingml/2006/main">
-            <a:off x="6781800" y="1285875"/>
-            <a:ext cx="2381250" cy="685800"/>
+            <a:off x="7353300" y="2019300"/>
+            <a:ext cx="3771900" cy="1809750"/>
           </a:xfrm>
           <a:prstGeom xmlns:a="http://schemas.openxmlformats.org/drawingml/2006/main" prst="rect">
             <a:avLst/>
@@ -7943,9 +8092,9 @@
           <a:bodyPr xmlns:a="http://schemas.openxmlformats.org/drawingml/2006/main" anchor="ctr"/>
           <a:lstStyle xmlns:a="http://schemas.openxmlformats.org/drawingml/2006/main">
             <a:defPPr algn="ctr">
-              <a:defRPr sz="3900" b="1">
-                <a:solidFill>
-                  <a:srgbClr val="087F8C"/>
+              <a:defRPr sz="1350" b="0">
+                <a:solidFill>
+                  <a:srgbClr val="4E5C68"/>
                 </a:solidFill>
                 <a:latin typeface="Arial"/>
                 <a:ea typeface="Arial"/>
@@ -7953,9 +8102,9 @@
               </a:defRPr>
             </a:defPPr>
             <a:lvl1pPr algn="ctr">
-              <a:defRPr sz="3900" b="1">
-                <a:solidFill>
-                  <a:srgbClr val="087F8C"/>
+              <a:defRPr sz="1350" b="0">
+                <a:solidFill>
+                  <a:srgbClr val="4E5C68"/>
                 </a:solidFill>
                 <a:latin typeface="Arial"/>
                 <a:ea typeface="Arial"/>
@@ -7963,9 +8112,9 @@
               </a:defRPr>
             </a:lvl1pPr>
             <a:lvl2pPr algn="ctr">
-              <a:defRPr sz="3900" b="1">
-                <a:solidFill>
-                  <a:srgbClr val="087F8C"/>
+              <a:defRPr sz="1350" b="0">
+                <a:solidFill>
+                  <a:srgbClr val="4E5C68"/>
                 </a:solidFill>
                 <a:latin typeface="Arial"/>
                 <a:ea typeface="Arial"/>
@@ -7973,9 +8122,9 @@
               </a:defRPr>
             </a:lvl2pPr>
             <a:lvl3pPr algn="ctr">
-              <a:defRPr sz="3900" b="1">
-                <a:solidFill>
-                  <a:srgbClr val="087F8C"/>
+              <a:defRPr sz="1350" b="0">
+                <a:solidFill>
+                  <a:srgbClr val="4E5C68"/>
                 </a:solidFill>
                 <a:latin typeface="Arial"/>
                 <a:ea typeface="Arial"/>
@@ -7983,9 +8132,9 @@
               </a:defRPr>
             </a:lvl3pPr>
             <a:lvl4pPr algn="ctr">
-              <a:defRPr sz="3900" b="1">
-                <a:solidFill>
-                  <a:srgbClr val="087F8C"/>
+              <a:defRPr sz="1350" b="0">
+                <a:solidFill>
+                  <a:srgbClr val="4E5C68"/>
                 </a:solidFill>
                 <a:latin typeface="Arial"/>
                 <a:ea typeface="Arial"/>
@@ -7993,9 +8142,9 @@
               </a:defRPr>
             </a:lvl4pPr>
             <a:lvl5pPr algn="ctr">
-              <a:defRPr sz="3900" b="1">
-                <a:solidFill>
-                  <a:srgbClr val="087F8C"/>
+              <a:defRPr sz="1350" b="0">
+                <a:solidFill>
+                  <a:srgbClr val="4E5C68"/>
                 </a:solidFill>
                 <a:latin typeface="Arial"/>
                 <a:ea typeface="Arial"/>
@@ -8003,9 +8152,9 @@
               </a:defRPr>
             </a:lvl5pPr>
             <a:lvl6pPr algn="ctr">
-              <a:defRPr sz="3900" b="1">
-                <a:solidFill>
-                  <a:srgbClr val="087F8C"/>
+              <a:defRPr sz="1350" b="0">
+                <a:solidFill>
+                  <a:srgbClr val="4E5C68"/>
                 </a:solidFill>
                 <a:latin typeface="Arial"/>
                 <a:ea typeface="Arial"/>
@@ -8013,9 +8162,9 @@
               </a:defRPr>
             </a:lvl6pPr>
             <a:lvl7pPr algn="ctr">
-              <a:defRPr sz="3900" b="1">
-                <a:solidFill>
-                  <a:srgbClr val="087F8C"/>
+              <a:defRPr sz="1350" b="0">
+                <a:solidFill>
+                  <a:srgbClr val="4E5C68"/>
                 </a:solidFill>
                 <a:latin typeface="Arial"/>
                 <a:ea typeface="Arial"/>
@@ -8023,9 +8172,9 @@
               </a:defRPr>
             </a:lvl7pPr>
             <a:lvl8pPr algn="ctr">
-              <a:defRPr sz="3900" b="1">
-                <a:solidFill>
-                  <a:srgbClr val="087F8C"/>
+              <a:defRPr sz="1350" b="0">
+                <a:solidFill>
+                  <a:srgbClr val="4E5C68"/>
                 </a:solidFill>
                 <a:latin typeface="Arial"/>
                 <a:ea typeface="Arial"/>
@@ -8033,9 +8182,9 @@
               </a:defRPr>
             </a:lvl8pPr>
             <a:lvl9pPr algn="ctr">
-              <a:defRPr sz="3900" b="1">
-                <a:solidFill>
-                  <a:srgbClr val="087F8C"/>
+              <a:defRPr sz="1350" b="0">
+                <a:solidFill>
+                  <a:srgbClr val="4E5C68"/>
                 </a:solidFill>
                 <a:latin typeface="Arial"/>
                 <a:ea typeface="Arial"/>
@@ -8045,9 +8194,9 @@
           </a:lstStyle>
           <a:p xmlns:a="http://schemas.openxmlformats.org/drawingml/2006/main">
             <a:pPr algn="ctr">
-              <a:defRPr sz="3900" b="1">
-                <a:solidFill>
-                  <a:srgbClr val="087F8C"/>
+              <a:defRPr sz="1350" b="0">
+                <a:solidFill>
+                  <a:srgbClr val="4E5C68"/>
                 </a:solidFill>
                 <a:latin typeface="Arial"/>
                 <a:ea typeface="Arial"/>
@@ -8055,25 +8204,71 @@
               </a:defRPr>
             </a:pPr>
             <a:r>
-              <a:rPr sz="3900" b="1">
-                <a:solidFill>
-                  <a:srgbClr val="087F8C"/>
+              <a:rPr sz="1350" b="0">
+                <a:solidFill>
+                  <a:srgbClr val="4E5C68"/>
                 </a:solidFill>
                 <a:latin typeface="Arial"/>
                 <a:ea typeface="Arial"/>
                 <a:cs typeface="Arial"/>
               </a:rPr>
-              <a:t>7.172</a:t>
+              <a:t>Entrada: tensor 28 × 28 × 1</a:t>
+            </a:r>
+          </a:p>
+          <a:p xmlns:a="http://schemas.openxmlformats.org/drawingml/2006/main">
+            <a:pPr algn="ctr">
+              <a:defRPr sz="1350" b="0">
+                <a:solidFill>
+                  <a:srgbClr val="4E5C68"/>
+                </a:solidFill>
+                <a:latin typeface="Arial"/>
+                <a:ea typeface="Arial"/>
+                <a:cs typeface="Arial"/>
+              </a:defRPr>
+            </a:pPr>
+            <a:r>
+              <a:rPr sz="1350" b="0">
+                <a:solidFill>
+                  <a:srgbClr val="4E5C68"/>
+                </a:solidFill>
+                <a:latin typeface="Arial"/>
+                <a:ea typeface="Arial"/>
+                <a:cs typeface="Arial"/>
+              </a:rPr>
+              <a:t>Filtros locales + pooling</a:t>
+            </a:r>
+          </a:p>
+          <a:p xmlns:a="http://schemas.openxmlformats.org/drawingml/2006/main">
+            <a:pPr algn="ctr">
+              <a:defRPr sz="1350" b="0">
+                <a:solidFill>
+                  <a:srgbClr val="4E5C68"/>
+                </a:solidFill>
+                <a:latin typeface="Arial"/>
+                <a:ea typeface="Arial"/>
+                <a:cs typeface="Arial"/>
+              </a:defRPr>
+            </a:pPr>
+            <a:r>
+              <a:rPr sz="1350" b="0">
+                <a:solidFill>
+                  <a:srgbClr val="4E5C68"/>
+                </a:solidFill>
+                <a:latin typeface="Arial"/>
+                <a:ea typeface="Arial"/>
+                <a:cs typeface="Arial"/>
+              </a:rPr>
+              <a:t>243.352 parámetros</a:t>
             </a:r>
           </a:p>
         </p:txBody>
       </p:sp>
       <p:sp>
         <p:nvSpPr>
-          <p:cNvPr id="8" name="">
+          <p:cNvPr id="11" name="">
             <a:extLst xmlns:a="http://schemas.openxmlformats.org/drawingml/2006/main">
               <a:ext uri="{FF2B5EF4-FFF2-40B4-BE49-F238E27FC236}">
-                <a16:creationId xmlns:a16="http://schemas.microsoft.com/office/drawing/2014/main" id="{D5646BAE-9179-4C9A-92DA-E3CFE30AFC2E}"/>
+                <a16:creationId xmlns:a16="http://schemas.microsoft.com/office/drawing/2014/main" id="{291EB380-D2C1-44BD-990C-A1C1F0B417B3}"/>
               </a:ext>
             </a:extLst>
           </p:cNvPr>
@@ -8084,8 +8279,636 @@
         </p:nvSpPr>
         <p:spPr>
           <a:xfrm xmlns:a="http://schemas.openxmlformats.org/drawingml/2006/main">
-            <a:off x="6781800" y="1943100"/>
-            <a:ext cx="2381250" cy="400050"/>
+            <a:off x="762000" y="4429125"/>
+            <a:ext cx="2571750" cy="400050"/>
+          </a:xfrm>
+          <a:prstGeom xmlns:a="http://schemas.openxmlformats.org/drawingml/2006/main" prst="rect">
+            <a:avLst/>
+          </a:prstGeom>
+          <a:noFill xmlns:a="http://schemas.openxmlformats.org/drawingml/2006/main"/>
+          <a:ln xmlns:a="http://schemas.openxmlformats.org/drawingml/2006/main" w="0">
+            <a:noFill/>
+            <a:prstDash val="solid"/>
+          </a:ln>
+        </p:spPr>
+        <p:txBody>
+          <a:bodyPr xmlns:a="http://schemas.openxmlformats.org/drawingml/2006/main" anchor="ctr"/>
+          <a:lstStyle xmlns:a="http://schemas.openxmlformats.org/drawingml/2006/main">
+            <a:defPPr algn="l">
+              <a:defRPr sz="2175" b="1">
+                <a:solidFill>
+                  <a:srgbClr val="087F8C"/>
+                </a:solidFill>
+                <a:latin typeface="Arial"/>
+                <a:ea typeface="Arial"/>
+                <a:cs typeface="Arial"/>
+              </a:defRPr>
+            </a:defPPr>
+            <a:lvl1pPr algn="l">
+              <a:defRPr sz="2175" b="1">
+                <a:solidFill>
+                  <a:srgbClr val="087F8C"/>
+                </a:solidFill>
+                <a:latin typeface="Arial"/>
+                <a:ea typeface="Arial"/>
+                <a:cs typeface="Arial"/>
+              </a:defRPr>
+            </a:lvl1pPr>
+            <a:lvl2pPr algn="l">
+              <a:defRPr sz="2175" b="1">
+                <a:solidFill>
+                  <a:srgbClr val="087F8C"/>
+                </a:solidFill>
+                <a:latin typeface="Arial"/>
+                <a:ea typeface="Arial"/>
+                <a:cs typeface="Arial"/>
+              </a:defRPr>
+            </a:lvl2pPr>
+            <a:lvl3pPr algn="l">
+              <a:defRPr sz="2175" b="1">
+                <a:solidFill>
+                  <a:srgbClr val="087F8C"/>
+                </a:solidFill>
+                <a:latin typeface="Arial"/>
+                <a:ea typeface="Arial"/>
+                <a:cs typeface="Arial"/>
+              </a:defRPr>
+            </a:lvl3pPr>
+            <a:lvl4pPr algn="l">
+              <a:defRPr sz="2175" b="1">
+                <a:solidFill>
+                  <a:srgbClr val="087F8C"/>
+                </a:solidFill>
+                <a:latin typeface="Arial"/>
+                <a:ea typeface="Arial"/>
+                <a:cs typeface="Arial"/>
+              </a:defRPr>
+            </a:lvl4pPr>
+            <a:lvl5pPr algn="l">
+              <a:defRPr sz="2175" b="1">
+                <a:solidFill>
+                  <a:srgbClr val="087F8C"/>
+                </a:solidFill>
+                <a:latin typeface="Arial"/>
+                <a:ea typeface="Arial"/>
+                <a:cs typeface="Arial"/>
+              </a:defRPr>
+            </a:lvl5pPr>
+            <a:lvl6pPr algn="l">
+              <a:defRPr sz="2175" b="1">
+                <a:solidFill>
+                  <a:srgbClr val="087F8C"/>
+                </a:solidFill>
+                <a:latin typeface="Arial"/>
+                <a:ea typeface="Arial"/>
+                <a:cs typeface="Arial"/>
+              </a:defRPr>
+            </a:lvl6pPr>
+            <a:lvl7pPr algn="l">
+              <a:defRPr sz="2175" b="1">
+                <a:solidFill>
+                  <a:srgbClr val="087F8C"/>
+                </a:solidFill>
+                <a:latin typeface="Arial"/>
+                <a:ea typeface="Arial"/>
+                <a:cs typeface="Arial"/>
+              </a:defRPr>
+            </a:lvl7pPr>
+            <a:lvl8pPr algn="l">
+              <a:defRPr sz="2175" b="1">
+                <a:solidFill>
+                  <a:srgbClr val="087F8C"/>
+                </a:solidFill>
+                <a:latin typeface="Arial"/>
+                <a:ea typeface="Arial"/>
+                <a:cs typeface="Arial"/>
+              </a:defRPr>
+            </a:lvl8pPr>
+            <a:lvl9pPr algn="l">
+              <a:defRPr sz="2175" b="1">
+                <a:solidFill>
+                  <a:srgbClr val="087F8C"/>
+                </a:solidFill>
+                <a:latin typeface="Arial"/>
+                <a:ea typeface="Arial"/>
+                <a:cs typeface="Arial"/>
+              </a:defRPr>
+            </a:lvl9pPr>
+          </a:lstStyle>
+          <a:p xmlns:a="http://schemas.openxmlformats.org/drawingml/2006/main">
+            <a:pPr algn="l">
+              <a:defRPr sz="2175" b="1">
+                <a:solidFill>
+                  <a:srgbClr val="087F8C"/>
+                </a:solidFill>
+                <a:latin typeface="Arial"/>
+                <a:ea typeface="Arial"/>
+                <a:cs typeface="Arial"/>
+              </a:defRPr>
+            </a:pPr>
+            <a:r>
+              <a:rPr sz="2175" b="1">
+                <a:solidFill>
+                  <a:srgbClr val="087F8C"/>
+                </a:solidFill>
+                <a:latin typeface="Arial"/>
+                <a:ea typeface="Arial"/>
+                <a:cs typeface="Arial"/>
+              </a:rPr>
+              <a:t>Se mantiene</a:t>
+            </a:r>
+          </a:p>
+        </p:txBody>
+      </p:sp>
+      <p:sp>
+        <p:nvSpPr>
+          <p:cNvPr id="12" name="">
+            <a:extLst xmlns:a="http://schemas.openxmlformats.org/drawingml/2006/main">
+              <a:ext uri="{FF2B5EF4-FFF2-40B4-BE49-F238E27FC236}">
+                <a16:creationId xmlns:a16="http://schemas.microsoft.com/office/drawing/2014/main" id="{606484A0-8804-4CE6-B0B3-0822B780180B}"/>
+              </a:ext>
+            </a:extLst>
+          </p:cNvPr>
+          <p:cNvSpPr>
+            <a:spLocks xmlns:a="http://schemas.openxmlformats.org/drawingml/2006/main" noGrp="1"/>
+          </p:cNvSpPr>
+          <p:nvPr/>
+        </p:nvSpPr>
+        <p:spPr>
+          <a:xfrm xmlns:a="http://schemas.openxmlformats.org/drawingml/2006/main">
+            <a:off x="762000" y="4876800"/>
+            <a:ext cx="4762500" cy="514350"/>
+          </a:xfrm>
+          <a:prstGeom xmlns:a="http://schemas.openxmlformats.org/drawingml/2006/main" prst="rect">
+            <a:avLst/>
+          </a:prstGeom>
+          <a:noFill xmlns:a="http://schemas.openxmlformats.org/drawingml/2006/main"/>
+          <a:ln xmlns:a="http://schemas.openxmlformats.org/drawingml/2006/main" w="0">
+            <a:noFill/>
+            <a:prstDash val="solid"/>
+          </a:ln>
+        </p:spPr>
+        <p:txBody>
+          <a:bodyPr xmlns:a="http://schemas.openxmlformats.org/drawingml/2006/main" anchor="ctr"/>
+          <a:lstStyle xmlns:a="http://schemas.openxmlformats.org/drawingml/2006/main">
+            <a:defPPr algn="l">
+              <a:defRPr sz="1725" b="0">
+                <a:solidFill>
+                  <a:srgbClr val="263746"/>
+                </a:solidFill>
+                <a:latin typeface="Arial"/>
+                <a:ea typeface="Arial"/>
+                <a:cs typeface="Arial"/>
+              </a:defRPr>
+            </a:defPPr>
+            <a:lvl1pPr algn="l">
+              <a:defRPr sz="1725" b="0">
+                <a:solidFill>
+                  <a:srgbClr val="263746"/>
+                </a:solidFill>
+                <a:latin typeface="Arial"/>
+                <a:ea typeface="Arial"/>
+                <a:cs typeface="Arial"/>
+              </a:defRPr>
+            </a:lvl1pPr>
+            <a:lvl2pPr algn="l">
+              <a:defRPr sz="1725" b="0">
+                <a:solidFill>
+                  <a:srgbClr val="263746"/>
+                </a:solidFill>
+                <a:latin typeface="Arial"/>
+                <a:ea typeface="Arial"/>
+                <a:cs typeface="Arial"/>
+              </a:defRPr>
+            </a:lvl2pPr>
+            <a:lvl3pPr algn="l">
+              <a:defRPr sz="1725" b="0">
+                <a:solidFill>
+                  <a:srgbClr val="263746"/>
+                </a:solidFill>
+                <a:latin typeface="Arial"/>
+                <a:ea typeface="Arial"/>
+                <a:cs typeface="Arial"/>
+              </a:defRPr>
+            </a:lvl3pPr>
+            <a:lvl4pPr algn="l">
+              <a:defRPr sz="1725" b="0">
+                <a:solidFill>
+                  <a:srgbClr val="263746"/>
+                </a:solidFill>
+                <a:latin typeface="Arial"/>
+                <a:ea typeface="Arial"/>
+                <a:cs typeface="Arial"/>
+              </a:defRPr>
+            </a:lvl4pPr>
+            <a:lvl5pPr algn="l">
+              <a:defRPr sz="1725" b="0">
+                <a:solidFill>
+                  <a:srgbClr val="263746"/>
+                </a:solidFill>
+                <a:latin typeface="Arial"/>
+                <a:ea typeface="Arial"/>
+                <a:cs typeface="Arial"/>
+              </a:defRPr>
+            </a:lvl5pPr>
+            <a:lvl6pPr algn="l">
+              <a:defRPr sz="1725" b="0">
+                <a:solidFill>
+                  <a:srgbClr val="263746"/>
+                </a:solidFill>
+                <a:latin typeface="Arial"/>
+                <a:ea typeface="Arial"/>
+                <a:cs typeface="Arial"/>
+              </a:defRPr>
+            </a:lvl6pPr>
+            <a:lvl7pPr algn="l">
+              <a:defRPr sz="1725" b="0">
+                <a:solidFill>
+                  <a:srgbClr val="263746"/>
+                </a:solidFill>
+                <a:latin typeface="Arial"/>
+                <a:ea typeface="Arial"/>
+                <a:cs typeface="Arial"/>
+              </a:defRPr>
+            </a:lvl7pPr>
+            <a:lvl8pPr algn="l">
+              <a:defRPr sz="1725" b="0">
+                <a:solidFill>
+                  <a:srgbClr val="263746"/>
+                </a:solidFill>
+                <a:latin typeface="Arial"/>
+                <a:ea typeface="Arial"/>
+                <a:cs typeface="Arial"/>
+              </a:defRPr>
+            </a:lvl8pPr>
+            <a:lvl9pPr algn="l">
+              <a:defRPr sz="1725" b="0">
+                <a:solidFill>
+                  <a:srgbClr val="263746"/>
+                </a:solidFill>
+                <a:latin typeface="Arial"/>
+                <a:ea typeface="Arial"/>
+                <a:cs typeface="Arial"/>
+              </a:defRPr>
+            </a:lvl9pPr>
+          </a:lstStyle>
+          <a:p xmlns:a="http://schemas.openxmlformats.org/drawingml/2006/main">
+            <a:pPr algn="l">
+              <a:defRPr sz="1725" b="0">
+                <a:solidFill>
+                  <a:srgbClr val="263746"/>
+                </a:solidFill>
+                <a:latin typeface="Arial"/>
+                <a:ea typeface="Arial"/>
+                <a:cs typeface="Arial"/>
+              </a:defRPr>
+            </a:pPr>
+            <a:r>
+              <a:rPr sz="1725" b="0">
+                <a:solidFill>
+                  <a:srgbClr val="263746"/>
+                </a:solidFill>
+                <a:latin typeface="Arial"/>
+                <a:ea typeface="Arial"/>
+                <a:cs typeface="Arial"/>
+              </a:rPr>
+              <a:t>Dataset, 24 clases, particiones y semilla 42</a:t>
+            </a:r>
+          </a:p>
+        </p:txBody>
+      </p:sp>
+      <p:sp>
+        <p:nvSpPr>
+          <p:cNvPr id="13" name="">
+            <a:extLst xmlns:a="http://schemas.openxmlformats.org/drawingml/2006/main">
+              <a:ext uri="{FF2B5EF4-FFF2-40B4-BE49-F238E27FC236}">
+                <a16:creationId xmlns:a16="http://schemas.microsoft.com/office/drawing/2014/main" id="{F3BED4C2-FBB0-431E-9B47-C87A283C8D31}"/>
+              </a:ext>
+            </a:extLst>
+          </p:cNvPr>
+          <p:cNvSpPr>
+            <a:spLocks xmlns:a="http://schemas.openxmlformats.org/drawingml/2006/main" noGrp="1"/>
+          </p:cNvSpPr>
+          <p:nvPr/>
+        </p:nvSpPr>
+        <p:spPr>
+          <a:xfrm xmlns:a="http://schemas.openxmlformats.org/drawingml/2006/main">
+            <a:off x="6429375" y="4429125"/>
+            <a:ext cx="2571750" cy="400050"/>
+          </a:xfrm>
+          <a:prstGeom xmlns:a="http://schemas.openxmlformats.org/drawingml/2006/main" prst="rect">
+            <a:avLst/>
+          </a:prstGeom>
+          <a:noFill xmlns:a="http://schemas.openxmlformats.org/drawingml/2006/main"/>
+          <a:ln xmlns:a="http://schemas.openxmlformats.org/drawingml/2006/main" w="0">
+            <a:noFill/>
+            <a:prstDash val="solid"/>
+          </a:ln>
+        </p:spPr>
+        <p:txBody>
+          <a:bodyPr xmlns:a="http://schemas.openxmlformats.org/drawingml/2006/main" anchor="ctr"/>
+          <a:lstStyle xmlns:a="http://schemas.openxmlformats.org/drawingml/2006/main">
+            <a:defPPr algn="l">
+              <a:defRPr sz="2175" b="1">
+                <a:solidFill>
+                  <a:srgbClr val="087F8C"/>
+                </a:solidFill>
+                <a:latin typeface="Arial"/>
+                <a:ea typeface="Arial"/>
+                <a:cs typeface="Arial"/>
+              </a:defRPr>
+            </a:defPPr>
+            <a:lvl1pPr algn="l">
+              <a:defRPr sz="2175" b="1">
+                <a:solidFill>
+                  <a:srgbClr val="087F8C"/>
+                </a:solidFill>
+                <a:latin typeface="Arial"/>
+                <a:ea typeface="Arial"/>
+                <a:cs typeface="Arial"/>
+              </a:defRPr>
+            </a:lvl1pPr>
+            <a:lvl2pPr algn="l">
+              <a:defRPr sz="2175" b="1">
+                <a:solidFill>
+                  <a:srgbClr val="087F8C"/>
+                </a:solidFill>
+                <a:latin typeface="Arial"/>
+                <a:ea typeface="Arial"/>
+                <a:cs typeface="Arial"/>
+              </a:defRPr>
+            </a:lvl2pPr>
+            <a:lvl3pPr algn="l">
+              <a:defRPr sz="2175" b="1">
+                <a:solidFill>
+                  <a:srgbClr val="087F8C"/>
+                </a:solidFill>
+                <a:latin typeface="Arial"/>
+                <a:ea typeface="Arial"/>
+                <a:cs typeface="Arial"/>
+              </a:defRPr>
+            </a:lvl3pPr>
+            <a:lvl4pPr algn="l">
+              <a:defRPr sz="2175" b="1">
+                <a:solidFill>
+                  <a:srgbClr val="087F8C"/>
+                </a:solidFill>
+                <a:latin typeface="Arial"/>
+                <a:ea typeface="Arial"/>
+                <a:cs typeface="Arial"/>
+              </a:defRPr>
+            </a:lvl4pPr>
+            <a:lvl5pPr algn="l">
+              <a:defRPr sz="2175" b="1">
+                <a:solidFill>
+                  <a:srgbClr val="087F8C"/>
+                </a:solidFill>
+                <a:latin typeface="Arial"/>
+                <a:ea typeface="Arial"/>
+                <a:cs typeface="Arial"/>
+              </a:defRPr>
+            </a:lvl5pPr>
+            <a:lvl6pPr algn="l">
+              <a:defRPr sz="2175" b="1">
+                <a:solidFill>
+                  <a:srgbClr val="087F8C"/>
+                </a:solidFill>
+                <a:latin typeface="Arial"/>
+                <a:ea typeface="Arial"/>
+                <a:cs typeface="Arial"/>
+              </a:defRPr>
+            </a:lvl6pPr>
+            <a:lvl7pPr algn="l">
+              <a:defRPr sz="2175" b="1">
+                <a:solidFill>
+                  <a:srgbClr val="087F8C"/>
+                </a:solidFill>
+                <a:latin typeface="Arial"/>
+                <a:ea typeface="Arial"/>
+                <a:cs typeface="Arial"/>
+              </a:defRPr>
+            </a:lvl7pPr>
+            <a:lvl8pPr algn="l">
+              <a:defRPr sz="2175" b="1">
+                <a:solidFill>
+                  <a:srgbClr val="087F8C"/>
+                </a:solidFill>
+                <a:latin typeface="Arial"/>
+                <a:ea typeface="Arial"/>
+                <a:cs typeface="Arial"/>
+              </a:defRPr>
+            </a:lvl8pPr>
+            <a:lvl9pPr algn="l">
+              <a:defRPr sz="2175" b="1">
+                <a:solidFill>
+                  <a:srgbClr val="087F8C"/>
+                </a:solidFill>
+                <a:latin typeface="Arial"/>
+                <a:ea typeface="Arial"/>
+                <a:cs typeface="Arial"/>
+              </a:defRPr>
+            </a:lvl9pPr>
+          </a:lstStyle>
+          <a:p xmlns:a="http://schemas.openxmlformats.org/drawingml/2006/main">
+            <a:pPr algn="l">
+              <a:defRPr sz="2175" b="1">
+                <a:solidFill>
+                  <a:srgbClr val="087F8C"/>
+                </a:solidFill>
+                <a:latin typeface="Arial"/>
+                <a:ea typeface="Arial"/>
+                <a:cs typeface="Arial"/>
+              </a:defRPr>
+            </a:pPr>
+            <a:r>
+              <a:rPr sz="2175" b="1">
+                <a:solidFill>
+                  <a:srgbClr val="087F8C"/>
+                </a:solidFill>
+                <a:latin typeface="Arial"/>
+                <a:ea typeface="Arial"/>
+                <a:cs typeface="Arial"/>
+              </a:rPr>
+              <a:t>Se adapta</a:t>
+            </a:r>
+          </a:p>
+        </p:txBody>
+      </p:sp>
+      <p:sp>
+        <p:nvSpPr>
+          <p:cNvPr id="14" name="">
+            <a:extLst xmlns:a="http://schemas.openxmlformats.org/drawingml/2006/main">
+              <a:ext uri="{FF2B5EF4-FFF2-40B4-BE49-F238E27FC236}">
+                <a16:creationId xmlns:a16="http://schemas.microsoft.com/office/drawing/2014/main" id="{34174A67-341E-426E-A18D-EB81A08695F6}"/>
+              </a:ext>
+            </a:extLst>
+          </p:cNvPr>
+          <p:cNvSpPr>
+            <a:spLocks xmlns:a="http://schemas.openxmlformats.org/drawingml/2006/main" noGrp="1"/>
+          </p:cNvSpPr>
+          <p:nvPr/>
+        </p:nvSpPr>
+        <p:spPr>
+          <a:xfrm xmlns:a="http://schemas.openxmlformats.org/drawingml/2006/main">
+            <a:off x="6429375" y="4876800"/>
+            <a:ext cx="4810125" cy="609600"/>
+          </a:xfrm>
+          <a:prstGeom xmlns:a="http://schemas.openxmlformats.org/drawingml/2006/main" prst="rect">
+            <a:avLst/>
+          </a:prstGeom>
+          <a:noFill xmlns:a="http://schemas.openxmlformats.org/drawingml/2006/main"/>
+          <a:ln xmlns:a="http://schemas.openxmlformats.org/drawingml/2006/main" w="0">
+            <a:noFill/>
+            <a:prstDash val="solid"/>
+          </a:ln>
+        </p:spPr>
+        <p:txBody>
+          <a:bodyPr xmlns:a="http://schemas.openxmlformats.org/drawingml/2006/main" anchor="ctr"/>
+          <a:lstStyle xmlns:a="http://schemas.openxmlformats.org/drawingml/2006/main">
+            <a:defPPr algn="l">
+              <a:defRPr sz="1725" b="0">
+                <a:solidFill>
+                  <a:srgbClr val="263746"/>
+                </a:solidFill>
+                <a:latin typeface="Arial"/>
+                <a:ea typeface="Arial"/>
+                <a:cs typeface="Arial"/>
+              </a:defRPr>
+            </a:defPPr>
+            <a:lvl1pPr algn="l">
+              <a:defRPr sz="1725" b="0">
+                <a:solidFill>
+                  <a:srgbClr val="263746"/>
+                </a:solidFill>
+                <a:latin typeface="Arial"/>
+                <a:ea typeface="Arial"/>
+                <a:cs typeface="Arial"/>
+              </a:defRPr>
+            </a:lvl1pPr>
+            <a:lvl2pPr algn="l">
+              <a:defRPr sz="1725" b="0">
+                <a:solidFill>
+                  <a:srgbClr val="263746"/>
+                </a:solidFill>
+                <a:latin typeface="Arial"/>
+                <a:ea typeface="Arial"/>
+                <a:cs typeface="Arial"/>
+              </a:defRPr>
+            </a:lvl2pPr>
+            <a:lvl3pPr algn="l">
+              <a:defRPr sz="1725" b="0">
+                <a:solidFill>
+                  <a:srgbClr val="263746"/>
+                </a:solidFill>
+                <a:latin typeface="Arial"/>
+                <a:ea typeface="Arial"/>
+                <a:cs typeface="Arial"/>
+              </a:defRPr>
+            </a:lvl3pPr>
+            <a:lvl4pPr algn="l">
+              <a:defRPr sz="1725" b="0">
+                <a:solidFill>
+                  <a:srgbClr val="263746"/>
+                </a:solidFill>
+                <a:latin typeface="Arial"/>
+                <a:ea typeface="Arial"/>
+                <a:cs typeface="Arial"/>
+              </a:defRPr>
+            </a:lvl4pPr>
+            <a:lvl5pPr algn="l">
+              <a:defRPr sz="1725" b="0">
+                <a:solidFill>
+                  <a:srgbClr val="263746"/>
+                </a:solidFill>
+                <a:latin typeface="Arial"/>
+                <a:ea typeface="Arial"/>
+                <a:cs typeface="Arial"/>
+              </a:defRPr>
+            </a:lvl5pPr>
+            <a:lvl6pPr algn="l">
+              <a:defRPr sz="1725" b="0">
+                <a:solidFill>
+                  <a:srgbClr val="263746"/>
+                </a:solidFill>
+                <a:latin typeface="Arial"/>
+                <a:ea typeface="Arial"/>
+                <a:cs typeface="Arial"/>
+              </a:defRPr>
+            </a:lvl6pPr>
+            <a:lvl7pPr algn="l">
+              <a:defRPr sz="1725" b="0">
+                <a:solidFill>
+                  <a:srgbClr val="263746"/>
+                </a:solidFill>
+                <a:latin typeface="Arial"/>
+                <a:ea typeface="Arial"/>
+                <a:cs typeface="Arial"/>
+              </a:defRPr>
+            </a:lvl7pPr>
+            <a:lvl8pPr algn="l">
+              <a:defRPr sz="1725" b="0">
+                <a:solidFill>
+                  <a:srgbClr val="263746"/>
+                </a:solidFill>
+                <a:latin typeface="Arial"/>
+                <a:ea typeface="Arial"/>
+                <a:cs typeface="Arial"/>
+              </a:defRPr>
+            </a:lvl8pPr>
+            <a:lvl9pPr algn="l">
+              <a:defRPr sz="1725" b="0">
+                <a:solidFill>
+                  <a:srgbClr val="263746"/>
+                </a:solidFill>
+                <a:latin typeface="Arial"/>
+                <a:ea typeface="Arial"/>
+                <a:cs typeface="Arial"/>
+              </a:defRPr>
+            </a:lvl9pPr>
+          </a:lstStyle>
+          <a:p xmlns:a="http://schemas.openxmlformats.org/drawingml/2006/main">
+            <a:pPr algn="l">
+              <a:defRPr sz="1725" b="0">
+                <a:solidFill>
+                  <a:srgbClr val="263746"/>
+                </a:solidFill>
+                <a:latin typeface="Arial"/>
+                <a:ea typeface="Arial"/>
+                <a:cs typeface="Arial"/>
+              </a:defRPr>
+            </a:pPr>
+            <a:r>
+              <a:rPr sz="1725" b="0">
+                <a:solidFill>
+                  <a:srgbClr val="263746"/>
+                </a:solidFill>
+                <a:latin typeface="Arial"/>
+                <a:ea typeface="Arial"/>
+                <a:cs typeface="Arial"/>
+              </a:rPr>
+              <a:t>Formato de entrada y arquitectura para aprovechar la estructura espacial</a:t>
+            </a:r>
+          </a:p>
+        </p:txBody>
+      </p:sp>
+      <p:sp>
+        <p:nvSpPr>
+          <p:cNvPr id="15" name="">
+            <a:extLst xmlns:a="http://schemas.openxmlformats.org/drawingml/2006/main">
+              <a:ext uri="{FF2B5EF4-FFF2-40B4-BE49-F238E27FC236}">
+                <a16:creationId xmlns:a16="http://schemas.microsoft.com/office/drawing/2014/main" id="{3C2C9CAA-7266-4173-98DF-EC67B9F0C882}"/>
+              </a:ext>
+            </a:extLst>
+          </p:cNvPr>
+          <p:cNvSpPr>
+            <a:spLocks xmlns:a="http://schemas.openxmlformats.org/drawingml/2006/main" noGrp="1"/>
+          </p:cNvSpPr>
+          <p:nvPr/>
+        </p:nvSpPr>
+        <p:spPr>
+          <a:xfrm xmlns:a="http://schemas.openxmlformats.org/drawingml/2006/main">
+            <a:off x="762000" y="5848350"/>
+            <a:ext cx="10382250" cy="400050"/>
           </a:xfrm>
           <a:prstGeom xmlns:a="http://schemas.openxmlformats.org/drawingml/2006/main" prst="rect">
             <a:avLst/>
@@ -8100,9 +8923,9 @@
           <a:bodyPr xmlns:a="http://schemas.openxmlformats.org/drawingml/2006/main" anchor="ctr"/>
           <a:lstStyle xmlns:a="http://schemas.openxmlformats.org/drawingml/2006/main">
             <a:defPPr algn="ctr">
-              <a:defRPr sz="1500" b="0">
-                <a:solidFill>
-                  <a:srgbClr val="17324D"/>
+              <a:defRPr sz="1800" b="1">
+                <a:solidFill>
+                  <a:srgbClr val="4E5C68"/>
                 </a:solidFill>
                 <a:latin typeface="Arial"/>
                 <a:ea typeface="Arial"/>
@@ -8110,9 +8933,9 @@
               </a:defRPr>
             </a:defPPr>
             <a:lvl1pPr algn="ctr">
-              <a:defRPr sz="1500" b="0">
-                <a:solidFill>
-                  <a:srgbClr val="17324D"/>
+              <a:defRPr sz="1800" b="1">
+                <a:solidFill>
+                  <a:srgbClr val="4E5C68"/>
                 </a:solidFill>
                 <a:latin typeface="Arial"/>
                 <a:ea typeface="Arial"/>
@@ -8120,9 +8943,9 @@
               </a:defRPr>
             </a:lvl1pPr>
             <a:lvl2pPr algn="ctr">
-              <a:defRPr sz="1500" b="0">
-                <a:solidFill>
-                  <a:srgbClr val="17324D"/>
+              <a:defRPr sz="1800" b="1">
+                <a:solidFill>
+                  <a:srgbClr val="4E5C68"/>
                 </a:solidFill>
                 <a:latin typeface="Arial"/>
                 <a:ea typeface="Arial"/>
@@ -8130,9 +8953,9 @@
               </a:defRPr>
             </a:lvl2pPr>
             <a:lvl3pPr algn="ctr">
-              <a:defRPr sz="1500" b="0">
-                <a:solidFill>
-                  <a:srgbClr val="17324D"/>
+              <a:defRPr sz="1800" b="1">
+                <a:solidFill>
+                  <a:srgbClr val="4E5C68"/>
                 </a:solidFill>
                 <a:latin typeface="Arial"/>
                 <a:ea typeface="Arial"/>
@@ -8140,9 +8963,9 @@
               </a:defRPr>
             </a:lvl3pPr>
             <a:lvl4pPr algn="ctr">
-              <a:defRPr sz="1500" b="0">
-                <a:solidFill>
-                  <a:srgbClr val="17324D"/>
+              <a:defRPr sz="1800" b="1">
+                <a:solidFill>
+                  <a:srgbClr val="4E5C68"/>
                 </a:solidFill>
                 <a:latin typeface="Arial"/>
                 <a:ea typeface="Arial"/>
@@ -8150,9 +8973,9 @@
               </a:defRPr>
             </a:lvl4pPr>
             <a:lvl5pPr algn="ctr">
-              <a:defRPr sz="1500" b="0">
-                <a:solidFill>
-                  <a:srgbClr val="17324D"/>
+              <a:defRPr sz="1800" b="1">
+                <a:solidFill>
+                  <a:srgbClr val="4E5C68"/>
                 </a:solidFill>
                 <a:latin typeface="Arial"/>
                 <a:ea typeface="Arial"/>
@@ -8160,9 +8983,9 @@
               </a:defRPr>
             </a:lvl5pPr>
             <a:lvl6pPr algn="ctr">
-              <a:defRPr sz="1500" b="0">
-                <a:solidFill>
-                  <a:srgbClr val="17324D"/>
+              <a:defRPr sz="1800" b="1">
+                <a:solidFill>
+                  <a:srgbClr val="4E5C68"/>
                 </a:solidFill>
                 <a:latin typeface="Arial"/>
                 <a:ea typeface="Arial"/>
@@ -8170,9 +8993,9 @@
               </a:defRPr>
             </a:lvl6pPr>
             <a:lvl7pPr algn="ctr">
-              <a:defRPr sz="1500" b="0">
-                <a:solidFill>
-                  <a:srgbClr val="17324D"/>
+              <a:defRPr sz="1800" b="1">
+                <a:solidFill>
+                  <a:srgbClr val="4E5C68"/>
                 </a:solidFill>
                 <a:latin typeface="Arial"/>
                 <a:ea typeface="Arial"/>
@@ -8180,9 +9003,9 @@
               </a:defRPr>
             </a:lvl7pPr>
             <a:lvl8pPr algn="ctr">
-              <a:defRPr sz="1500" b="0">
-                <a:solidFill>
-                  <a:srgbClr val="17324D"/>
+              <a:defRPr sz="1800" b="1">
+                <a:solidFill>
+                  <a:srgbClr val="4E5C68"/>
                 </a:solidFill>
                 <a:latin typeface="Arial"/>
                 <a:ea typeface="Arial"/>
@@ -8190,9 +9013,9 @@
               </a:defRPr>
             </a:lvl8pPr>
             <a:lvl9pPr algn="ctr">
-              <a:defRPr sz="1500" b="0">
-                <a:solidFill>
-                  <a:srgbClr val="17324D"/>
+              <a:defRPr sz="1800" b="1">
+                <a:solidFill>
+                  <a:srgbClr val="4E5C68"/>
                 </a:solidFill>
                 <a:latin typeface="Arial"/>
                 <a:ea typeface="Arial"/>
@@ -8202,9 +9025,9 @@
           </a:lstStyle>
           <a:p xmlns:a="http://schemas.openxmlformats.org/drawingml/2006/main">
             <a:pPr algn="ctr">
-              <a:defRPr sz="1500" b="0">
-                <a:solidFill>
-                  <a:srgbClr val="17324D"/>
+              <a:defRPr sz="1800" b="1">
+                <a:solidFill>
+                  <a:srgbClr val="4E5C68"/>
                 </a:solidFill>
                 <a:latin typeface="Arial"/>
                 <a:ea typeface="Arial"/>
@@ -8212,514 +9035,15 @@
               </a:defRPr>
             </a:pPr>
             <a:r>
-              <a:rPr sz="1500" b="0">
-                <a:solidFill>
-                  <a:srgbClr val="17324D"/>
+              <a:rPr sz="1800" b="1">
+                <a:solidFill>
+                  <a:srgbClr val="4E5C68"/>
                 </a:solidFill>
                 <a:latin typeface="Arial"/>
                 <a:ea typeface="Arial"/>
                 <a:cs typeface="Arial"/>
               </a:rPr>
-              <a:t>test oficial</a:t>
-            </a:r>
-          </a:p>
-        </p:txBody>
-      </p:sp>
-      <p:sp>
-        <p:nvSpPr>
-          <p:cNvPr id="9" name="">
-            <a:extLst xmlns:a="http://schemas.openxmlformats.org/drawingml/2006/main">
-              <a:ext uri="{FF2B5EF4-FFF2-40B4-BE49-F238E27FC236}">
-                <a16:creationId xmlns:a16="http://schemas.microsoft.com/office/drawing/2014/main" id="{DA17F318-D06F-4434-BB26-288481DE5268}"/>
-              </a:ext>
-            </a:extLst>
-          </p:cNvPr>
-          <p:cNvSpPr>
-            <a:spLocks xmlns:a="http://schemas.openxmlformats.org/drawingml/2006/main" noGrp="1"/>
-          </p:cNvSpPr>
-          <p:nvPr/>
-        </p:nvSpPr>
-        <p:spPr>
-          <a:xfrm xmlns:a="http://schemas.openxmlformats.org/drawingml/2006/main">
-            <a:off x="9382125" y="1285875"/>
-            <a:ext cx="2095500" cy="685800"/>
-          </a:xfrm>
-          <a:prstGeom xmlns:a="http://schemas.openxmlformats.org/drawingml/2006/main" prst="rect">
-            <a:avLst/>
-          </a:prstGeom>
-          <a:noFill xmlns:a="http://schemas.openxmlformats.org/drawingml/2006/main"/>
-          <a:ln xmlns:a="http://schemas.openxmlformats.org/drawingml/2006/main" w="0">
-            <a:noFill/>
-            <a:prstDash val="solid"/>
-          </a:ln>
-        </p:spPr>
-        <p:txBody>
-          <a:bodyPr xmlns:a="http://schemas.openxmlformats.org/drawingml/2006/main" anchor="ctr"/>
-          <a:lstStyle xmlns:a="http://schemas.openxmlformats.org/drawingml/2006/main">
-            <a:defPPr algn="ctr">
-              <a:defRPr sz="3900" b="1">
-                <a:solidFill>
-                  <a:srgbClr val="087F8C"/>
-                </a:solidFill>
-                <a:latin typeface="Arial"/>
-                <a:ea typeface="Arial"/>
-                <a:cs typeface="Arial"/>
-              </a:defRPr>
-            </a:defPPr>
-            <a:lvl1pPr algn="ctr">
-              <a:defRPr sz="3900" b="1">
-                <a:solidFill>
-                  <a:srgbClr val="087F8C"/>
-                </a:solidFill>
-                <a:latin typeface="Arial"/>
-                <a:ea typeface="Arial"/>
-                <a:cs typeface="Arial"/>
-              </a:defRPr>
-            </a:lvl1pPr>
-            <a:lvl2pPr algn="ctr">
-              <a:defRPr sz="3900" b="1">
-                <a:solidFill>
-                  <a:srgbClr val="087F8C"/>
-                </a:solidFill>
-                <a:latin typeface="Arial"/>
-                <a:ea typeface="Arial"/>
-                <a:cs typeface="Arial"/>
-              </a:defRPr>
-            </a:lvl2pPr>
-            <a:lvl3pPr algn="ctr">
-              <a:defRPr sz="3900" b="1">
-                <a:solidFill>
-                  <a:srgbClr val="087F8C"/>
-                </a:solidFill>
-                <a:latin typeface="Arial"/>
-                <a:ea typeface="Arial"/>
-                <a:cs typeface="Arial"/>
-              </a:defRPr>
-            </a:lvl3pPr>
-            <a:lvl4pPr algn="ctr">
-              <a:defRPr sz="3900" b="1">
-                <a:solidFill>
-                  <a:srgbClr val="087F8C"/>
-                </a:solidFill>
-                <a:latin typeface="Arial"/>
-                <a:ea typeface="Arial"/>
-                <a:cs typeface="Arial"/>
-              </a:defRPr>
-            </a:lvl4pPr>
-            <a:lvl5pPr algn="ctr">
-              <a:defRPr sz="3900" b="1">
-                <a:solidFill>
-                  <a:srgbClr val="087F8C"/>
-                </a:solidFill>
-                <a:latin typeface="Arial"/>
-                <a:ea typeface="Arial"/>
-                <a:cs typeface="Arial"/>
-              </a:defRPr>
-            </a:lvl5pPr>
-            <a:lvl6pPr algn="ctr">
-              <a:defRPr sz="3900" b="1">
-                <a:solidFill>
-                  <a:srgbClr val="087F8C"/>
-                </a:solidFill>
-                <a:latin typeface="Arial"/>
-                <a:ea typeface="Arial"/>
-                <a:cs typeface="Arial"/>
-              </a:defRPr>
-            </a:lvl6pPr>
-            <a:lvl7pPr algn="ctr">
-              <a:defRPr sz="3900" b="1">
-                <a:solidFill>
-                  <a:srgbClr val="087F8C"/>
-                </a:solidFill>
-                <a:latin typeface="Arial"/>
-                <a:ea typeface="Arial"/>
-                <a:cs typeface="Arial"/>
-              </a:defRPr>
-            </a:lvl7pPr>
-            <a:lvl8pPr algn="ctr">
-              <a:defRPr sz="3900" b="1">
-                <a:solidFill>
-                  <a:srgbClr val="087F8C"/>
-                </a:solidFill>
-                <a:latin typeface="Arial"/>
-                <a:ea typeface="Arial"/>
-                <a:cs typeface="Arial"/>
-              </a:defRPr>
-            </a:lvl8pPr>
-            <a:lvl9pPr algn="ctr">
-              <a:defRPr sz="3900" b="1">
-                <a:solidFill>
-                  <a:srgbClr val="087F8C"/>
-                </a:solidFill>
-                <a:latin typeface="Arial"/>
-                <a:ea typeface="Arial"/>
-                <a:cs typeface="Arial"/>
-              </a:defRPr>
-            </a:lvl9pPr>
-          </a:lstStyle>
-          <a:p xmlns:a="http://schemas.openxmlformats.org/drawingml/2006/main">
-            <a:pPr algn="ctr">
-              <a:defRPr sz="3900" b="1">
-                <a:solidFill>
-                  <a:srgbClr val="087F8C"/>
-                </a:solidFill>
-                <a:latin typeface="Arial"/>
-                <a:ea typeface="Arial"/>
-                <a:cs typeface="Arial"/>
-              </a:defRPr>
-            </a:pPr>
-            <a:r>
-              <a:rPr sz="3900" b="1">
-                <a:solidFill>
-                  <a:srgbClr val="087F8C"/>
-                </a:solidFill>
-                <a:latin typeface="Arial"/>
-                <a:ea typeface="Arial"/>
-                <a:cs typeface="Arial"/>
-              </a:rPr>
-              <a:t>24</a:t>
-            </a:r>
-          </a:p>
-        </p:txBody>
-      </p:sp>
-      <p:sp>
-        <p:nvSpPr>
-          <p:cNvPr id="10" name="">
-            <a:extLst xmlns:a="http://schemas.openxmlformats.org/drawingml/2006/main">
-              <a:ext uri="{FF2B5EF4-FFF2-40B4-BE49-F238E27FC236}">
-                <a16:creationId xmlns:a16="http://schemas.microsoft.com/office/drawing/2014/main" id="{8FEFE435-7966-4A83-9C00-E753544A44B9}"/>
-              </a:ext>
-            </a:extLst>
-          </p:cNvPr>
-          <p:cNvSpPr>
-            <a:spLocks xmlns:a="http://schemas.openxmlformats.org/drawingml/2006/main" noGrp="1"/>
-          </p:cNvSpPr>
-          <p:nvPr/>
-        </p:nvSpPr>
-        <p:spPr>
-          <a:xfrm xmlns:a="http://schemas.openxmlformats.org/drawingml/2006/main">
-            <a:off x="9382125" y="1943100"/>
-            <a:ext cx="2095500" cy="400050"/>
-          </a:xfrm>
-          <a:prstGeom xmlns:a="http://schemas.openxmlformats.org/drawingml/2006/main" prst="rect">
-            <a:avLst/>
-          </a:prstGeom>
-          <a:noFill xmlns:a="http://schemas.openxmlformats.org/drawingml/2006/main"/>
-          <a:ln xmlns:a="http://schemas.openxmlformats.org/drawingml/2006/main" w="0">
-            <a:noFill/>
-            <a:prstDash val="solid"/>
-          </a:ln>
-        </p:spPr>
-        <p:txBody>
-          <a:bodyPr xmlns:a="http://schemas.openxmlformats.org/drawingml/2006/main" anchor="ctr"/>
-          <a:lstStyle xmlns:a="http://schemas.openxmlformats.org/drawingml/2006/main">
-            <a:defPPr algn="ctr">
-              <a:defRPr sz="1500" b="0">
-                <a:solidFill>
-                  <a:srgbClr val="17324D"/>
-                </a:solidFill>
-                <a:latin typeface="Arial"/>
-                <a:ea typeface="Arial"/>
-                <a:cs typeface="Arial"/>
-              </a:defRPr>
-            </a:defPPr>
-            <a:lvl1pPr algn="ctr">
-              <a:defRPr sz="1500" b="0">
-                <a:solidFill>
-                  <a:srgbClr val="17324D"/>
-                </a:solidFill>
-                <a:latin typeface="Arial"/>
-                <a:ea typeface="Arial"/>
-                <a:cs typeface="Arial"/>
-              </a:defRPr>
-            </a:lvl1pPr>
-            <a:lvl2pPr algn="ctr">
-              <a:defRPr sz="1500" b="0">
-                <a:solidFill>
-                  <a:srgbClr val="17324D"/>
-                </a:solidFill>
-                <a:latin typeface="Arial"/>
-                <a:ea typeface="Arial"/>
-                <a:cs typeface="Arial"/>
-              </a:defRPr>
-            </a:lvl2pPr>
-            <a:lvl3pPr algn="ctr">
-              <a:defRPr sz="1500" b="0">
-                <a:solidFill>
-                  <a:srgbClr val="17324D"/>
-                </a:solidFill>
-                <a:latin typeface="Arial"/>
-                <a:ea typeface="Arial"/>
-                <a:cs typeface="Arial"/>
-              </a:defRPr>
-            </a:lvl3pPr>
-            <a:lvl4pPr algn="ctr">
-              <a:defRPr sz="1500" b="0">
-                <a:solidFill>
-                  <a:srgbClr val="17324D"/>
-                </a:solidFill>
-                <a:latin typeface="Arial"/>
-                <a:ea typeface="Arial"/>
-                <a:cs typeface="Arial"/>
-              </a:defRPr>
-            </a:lvl4pPr>
-            <a:lvl5pPr algn="ctr">
-              <a:defRPr sz="1500" b="0">
-                <a:solidFill>
-                  <a:srgbClr val="17324D"/>
-                </a:solidFill>
-                <a:latin typeface="Arial"/>
-                <a:ea typeface="Arial"/>
-                <a:cs typeface="Arial"/>
-              </a:defRPr>
-            </a:lvl5pPr>
-            <a:lvl6pPr algn="ctr">
-              <a:defRPr sz="1500" b="0">
-                <a:solidFill>
-                  <a:srgbClr val="17324D"/>
-                </a:solidFill>
-                <a:latin typeface="Arial"/>
-                <a:ea typeface="Arial"/>
-                <a:cs typeface="Arial"/>
-              </a:defRPr>
-            </a:lvl6pPr>
-            <a:lvl7pPr algn="ctr">
-              <a:defRPr sz="1500" b="0">
-                <a:solidFill>
-                  <a:srgbClr val="17324D"/>
-                </a:solidFill>
-                <a:latin typeface="Arial"/>
-                <a:ea typeface="Arial"/>
-                <a:cs typeface="Arial"/>
-              </a:defRPr>
-            </a:lvl7pPr>
-            <a:lvl8pPr algn="ctr">
-              <a:defRPr sz="1500" b="0">
-                <a:solidFill>
-                  <a:srgbClr val="17324D"/>
-                </a:solidFill>
-                <a:latin typeface="Arial"/>
-                <a:ea typeface="Arial"/>
-                <a:cs typeface="Arial"/>
-              </a:defRPr>
-            </a:lvl8pPr>
-            <a:lvl9pPr algn="ctr">
-              <a:defRPr sz="1500" b="0">
-                <a:solidFill>
-                  <a:srgbClr val="17324D"/>
-                </a:solidFill>
-                <a:latin typeface="Arial"/>
-                <a:ea typeface="Arial"/>
-                <a:cs typeface="Arial"/>
-              </a:defRPr>
-            </a:lvl9pPr>
-          </a:lstStyle>
-          <a:p xmlns:a="http://schemas.openxmlformats.org/drawingml/2006/main">
-            <a:pPr algn="ctr">
-              <a:defRPr sz="1500" b="0">
-                <a:solidFill>
-                  <a:srgbClr val="17324D"/>
-                </a:solidFill>
-                <a:latin typeface="Arial"/>
-                <a:ea typeface="Arial"/>
-                <a:cs typeface="Arial"/>
-              </a:defRPr>
-            </a:pPr>
-            <a:r>
-              <a:rPr sz="1500" b="0">
-                <a:solidFill>
-                  <a:srgbClr val="17324D"/>
-                </a:solidFill>
-                <a:latin typeface="Arial"/>
-                <a:ea typeface="Arial"/>
-                <a:cs typeface="Arial"/>
-              </a:rPr>
-              <a:t>clases A-I y K-Y</a:t>
-            </a:r>
-          </a:p>
-        </p:txBody>
-      </p:sp>
-      <p:pic>
-        <p:nvPicPr>
-          <p:cNvPr id="11" name="">
-            <a:extLst xmlns:a="http://schemas.openxmlformats.org/drawingml/2006/main">
-              <a:ext uri="{FF2B5EF4-FFF2-40B4-BE49-F238E27FC236}">
-                <a16:creationId xmlns:a16="http://schemas.microsoft.com/office/drawing/2014/main" id="{3BEEFA72-8864-4AB3-8091-CA3B7EC35F41}"/>
-              </a:ext>
-            </a:extLst>
-          </p:cNvPr>
-          <p:cNvPicPr>
-            <a:picLocks xmlns:a="http://schemas.openxmlformats.org/drawingml/2006/main" noChangeAspect="1"/>
-          </p:cNvPicPr>
-          <p:nvPr/>
-        </p:nvPicPr>
-        <p:blipFill>
-          <a:blip xmlns:r="http://schemas.openxmlformats.org/officeDocument/2006/relationships" xmlns:a="http://schemas.openxmlformats.org/drawingml/2006/main" r:embed="Ra346b68f3a8744db"/>
-          <a:stretch xmlns:a="http://schemas.openxmlformats.org/drawingml/2006/main"/>
-        </p:blipFill>
-        <p:spPr>
-          <a:xfrm xmlns:a="http://schemas.openxmlformats.org/drawingml/2006/main">
-            <a:off x="1842977" y="2714625"/>
-            <a:ext cx="8506047" cy="3048000"/>
-          </a:xfrm>
-          <a:prstGeom xmlns:a="http://schemas.openxmlformats.org/drawingml/2006/main" prst="rect">
-            <a:avLst/>
-          </a:prstGeom>
-        </p:spPr>
-      </p:pic>
-      <p:sp>
-        <p:nvSpPr>
-          <p:cNvPr id="12" name="">
-            <a:extLst xmlns:a="http://schemas.openxmlformats.org/drawingml/2006/main">
-              <a:ext uri="{FF2B5EF4-FFF2-40B4-BE49-F238E27FC236}">
-                <a16:creationId xmlns:a16="http://schemas.microsoft.com/office/drawing/2014/main" id="{B2B1E58D-1F7A-44A4-9D35-B1E99612F1AD}"/>
-              </a:ext>
-            </a:extLst>
-          </p:cNvPr>
-          <p:cNvSpPr>
-            <a:spLocks xmlns:a="http://schemas.openxmlformats.org/drawingml/2006/main" noGrp="1"/>
-          </p:cNvSpPr>
-          <p:nvPr/>
-        </p:nvSpPr>
-        <p:spPr>
-          <a:xfrm xmlns:a="http://schemas.openxmlformats.org/drawingml/2006/main">
-            <a:off x="609600" y="5867400"/>
-            <a:ext cx="10287000" cy="428625"/>
-          </a:xfrm>
-          <a:prstGeom xmlns:a="http://schemas.openxmlformats.org/drawingml/2006/main" prst="rect">
-            <a:avLst/>
-          </a:prstGeom>
-          <a:noFill xmlns:a="http://schemas.openxmlformats.org/drawingml/2006/main"/>
-          <a:ln xmlns:a="http://schemas.openxmlformats.org/drawingml/2006/main" w="0">
-            <a:noFill/>
-            <a:prstDash val="solid"/>
-          </a:ln>
-        </p:spPr>
-        <p:txBody>
-          <a:bodyPr xmlns:a="http://schemas.openxmlformats.org/drawingml/2006/main" anchor="ctr"/>
-          <a:lstStyle xmlns:a="http://schemas.openxmlformats.org/drawingml/2006/main">
-            <a:defPPr algn="l">
-              <a:defRPr sz="1875" b="0">
-                <a:solidFill>
-                  <a:srgbClr val="4E5C68"/>
-                </a:solidFill>
-                <a:latin typeface="Arial"/>
-                <a:ea typeface="Arial"/>
-                <a:cs typeface="Arial"/>
-              </a:defRPr>
-            </a:defPPr>
-            <a:lvl1pPr algn="l">
-              <a:defRPr sz="1875" b="0">
-                <a:solidFill>
-                  <a:srgbClr val="4E5C68"/>
-                </a:solidFill>
-                <a:latin typeface="Arial"/>
-                <a:ea typeface="Arial"/>
-                <a:cs typeface="Arial"/>
-              </a:defRPr>
-            </a:lvl1pPr>
-            <a:lvl2pPr algn="l">
-              <a:defRPr sz="1875" b="0">
-                <a:solidFill>
-                  <a:srgbClr val="4E5C68"/>
-                </a:solidFill>
-                <a:latin typeface="Arial"/>
-                <a:ea typeface="Arial"/>
-                <a:cs typeface="Arial"/>
-              </a:defRPr>
-            </a:lvl2pPr>
-            <a:lvl3pPr algn="l">
-              <a:defRPr sz="1875" b="0">
-                <a:solidFill>
-                  <a:srgbClr val="4E5C68"/>
-                </a:solidFill>
-                <a:latin typeface="Arial"/>
-                <a:ea typeface="Arial"/>
-                <a:cs typeface="Arial"/>
-              </a:defRPr>
-            </a:lvl3pPr>
-            <a:lvl4pPr algn="l">
-              <a:defRPr sz="1875" b="0">
-                <a:solidFill>
-                  <a:srgbClr val="4E5C68"/>
-                </a:solidFill>
-                <a:latin typeface="Arial"/>
-                <a:ea typeface="Arial"/>
-                <a:cs typeface="Arial"/>
-              </a:defRPr>
-            </a:lvl4pPr>
-            <a:lvl5pPr algn="l">
-              <a:defRPr sz="1875" b="0">
-                <a:solidFill>
-                  <a:srgbClr val="4E5C68"/>
-                </a:solidFill>
-                <a:latin typeface="Arial"/>
-                <a:ea typeface="Arial"/>
-                <a:cs typeface="Arial"/>
-              </a:defRPr>
-            </a:lvl5pPr>
-            <a:lvl6pPr algn="l">
-              <a:defRPr sz="1875" b="0">
-                <a:solidFill>
-                  <a:srgbClr val="4E5C68"/>
-                </a:solidFill>
-                <a:latin typeface="Arial"/>
-                <a:ea typeface="Arial"/>
-                <a:cs typeface="Arial"/>
-              </a:defRPr>
-            </a:lvl6pPr>
-            <a:lvl7pPr algn="l">
-              <a:defRPr sz="1875" b="0">
-                <a:solidFill>
-                  <a:srgbClr val="4E5C68"/>
-                </a:solidFill>
-                <a:latin typeface="Arial"/>
-                <a:ea typeface="Arial"/>
-                <a:cs typeface="Arial"/>
-              </a:defRPr>
-            </a:lvl7pPr>
-            <a:lvl8pPr algn="l">
-              <a:defRPr sz="1875" b="0">
-                <a:solidFill>
-                  <a:srgbClr val="4E5C68"/>
-                </a:solidFill>
-                <a:latin typeface="Arial"/>
-                <a:ea typeface="Arial"/>
-                <a:cs typeface="Arial"/>
-              </a:defRPr>
-            </a:lvl8pPr>
-            <a:lvl9pPr algn="l">
-              <a:defRPr sz="1875" b="0">
-                <a:solidFill>
-                  <a:srgbClr val="4E5C68"/>
-                </a:solidFill>
-                <a:latin typeface="Arial"/>
-                <a:ea typeface="Arial"/>
-                <a:cs typeface="Arial"/>
-              </a:defRPr>
-            </a:lvl9pPr>
-          </a:lstStyle>
-          <a:p xmlns:a="http://schemas.openxmlformats.org/drawingml/2006/main">
-            <a:pPr algn="l">
-              <a:defRPr sz="1875" b="0">
-                <a:solidFill>
-                  <a:srgbClr val="4E5C68"/>
-                </a:solidFill>
-                <a:latin typeface="Arial"/>
-                <a:ea typeface="Arial"/>
-                <a:cs typeface="Arial"/>
-              </a:defRPr>
-            </a:pPr>
-            <a:r>
-              <a:rPr sz="1875" b="0">
-                <a:solidFill>
-                  <a:srgbClr val="4E5C68"/>
-                </a:solidFill>
-                <a:latin typeface="Arial"/>
-                <a:ea typeface="Arial"/>
-                <a:cs typeface="Arial"/>
-              </a:rPr>
-              <a:t>J y Z no están incluidas porque requieren movimiento.</a:t>
+              <a:t>No se repite la limpieza de la EP1: se reutilizan los datos ya validados.</a:t>
             </a:r>
           </a:p>
         </p:txBody>
@@ -8727,7 +9051,7 @@
     </p:spTree>
     <p:extLst>
       <p:ext uri="{BB962C8B-B14F-4D97-AF65-F5344CB8AC3E}">
-        <p14:creationId xmlns:p14="http://schemas.microsoft.com/office/powerpoint/2010/main" val="271790330"/>
+        <p14:creationId xmlns:p14="http://schemas.microsoft.com/office/powerpoint/2010/main" val="1560982674"/>
       </p:ext>
     </p:extLst>
   </p:cSld>
@@ -8758,7 +9082,7 @@
           <p:cNvPr id="26" name="">
             <a:extLst xmlns:a="http://schemas.openxmlformats.org/drawingml/2006/main">
               <a:ext uri="{FF2B5EF4-FFF2-40B4-BE49-F238E27FC236}">
-                <a16:creationId xmlns:a16="http://schemas.microsoft.com/office/drawing/2014/main" id="{14BFCDBC-8D05-478D-A21F-73419271D17E}"/>
+                <a16:creationId xmlns:a16="http://schemas.microsoft.com/office/drawing/2014/main" id="{2CFAED93-9780-4E02-B058-F3EA05749D65}"/>
               </a:ext>
             </a:extLst>
           </p:cNvPr>
@@ -8915,7 +9239,7 @@
           <p:cNvPr id="2" name="">
             <a:extLst xmlns:a="http://schemas.openxmlformats.org/drawingml/2006/main">
               <a:ext uri="{FF2B5EF4-FFF2-40B4-BE49-F238E27FC236}">
-                <a16:creationId xmlns:a16="http://schemas.microsoft.com/office/drawing/2014/main" id="{A491297C-B946-464C-9274-58CAEA4E94BF}"/>
+                <a16:creationId xmlns:a16="http://schemas.microsoft.com/office/drawing/2014/main" id="{63735E4E-B532-4F9B-A19E-D7F22EE3BF3A}"/>
               </a:ext>
             </a:extLst>
           </p:cNvPr>
@@ -9072,7 +9396,7 @@
           <p:cNvPr id="3" name="">
             <a:extLst xmlns:a="http://schemas.openxmlformats.org/drawingml/2006/main">
               <a:ext uri="{FF2B5EF4-FFF2-40B4-BE49-F238E27FC236}">
-                <a16:creationId xmlns:a16="http://schemas.microsoft.com/office/drawing/2014/main" id="{D9E71DC3-1C11-486D-AA0E-1E126496BA4A}"/>
+                <a16:creationId xmlns:a16="http://schemas.microsoft.com/office/drawing/2014/main" id="{1A79FDEB-F8E1-4D9B-BD96-B6C8D1D29838}"/>
               </a:ext>
             </a:extLst>
           </p:cNvPr>
@@ -9107,7 +9431,7 @@
           <p:cNvPr id="4" name="">
             <a:extLst xmlns:a="http://schemas.openxmlformats.org/drawingml/2006/main">
               <a:ext uri="{FF2B5EF4-FFF2-40B4-BE49-F238E27FC236}">
-                <a16:creationId xmlns:a16="http://schemas.microsoft.com/office/drawing/2014/main" id="{D5B8051A-7A04-404D-AEA2-5BDF4CCD813B}"/>
+                <a16:creationId xmlns:a16="http://schemas.microsoft.com/office/drawing/2014/main" id="{9AF8D49A-D217-4113-87B7-E107367CECD0}"/>
               </a:ext>
             </a:extLst>
           </p:cNvPr>
@@ -9264,7 +9588,7 @@
           <p:cNvPr id="5" name="">
             <a:extLst xmlns:a="http://schemas.openxmlformats.org/drawingml/2006/main">
               <a:ext uri="{FF2B5EF4-FFF2-40B4-BE49-F238E27FC236}">
-                <a16:creationId xmlns:a16="http://schemas.microsoft.com/office/drawing/2014/main" id="{41897F4C-61C3-4C0D-BD23-71A34CD7906C}"/>
+                <a16:creationId xmlns:a16="http://schemas.microsoft.com/office/drawing/2014/main" id="{CAE50F5F-05D4-4D64-B99D-F397C5DCC816}"/>
               </a:ext>
             </a:extLst>
           </p:cNvPr>
@@ -9421,7 +9745,7 @@
           <p:cNvPr id="6" name="">
             <a:extLst xmlns:a="http://schemas.openxmlformats.org/drawingml/2006/main">
               <a:ext uri="{FF2B5EF4-FFF2-40B4-BE49-F238E27FC236}">
-                <a16:creationId xmlns:a16="http://schemas.microsoft.com/office/drawing/2014/main" id="{C49B5F34-CD7F-424A-872C-F0ECF93DA03D}"/>
+                <a16:creationId xmlns:a16="http://schemas.microsoft.com/office/drawing/2014/main" id="{0753400B-204D-4108-8FFE-4606A7C45CFF}"/>
               </a:ext>
             </a:extLst>
           </p:cNvPr>
@@ -9454,7 +9778,7 @@
           <p:cNvPr id="7" name="">
             <a:extLst xmlns:a="http://schemas.openxmlformats.org/drawingml/2006/main">
               <a:ext uri="{FF2B5EF4-FFF2-40B4-BE49-F238E27FC236}">
-                <a16:creationId xmlns:a16="http://schemas.microsoft.com/office/drawing/2014/main" id="{217AE238-C847-4994-97A1-DAF0A1D22ED9}"/>
+                <a16:creationId xmlns:a16="http://schemas.microsoft.com/office/drawing/2014/main" id="{64574DF3-769B-4DA5-BD61-95DD51E8D699}"/>
               </a:ext>
             </a:extLst>
           </p:cNvPr>
@@ -9489,7 +9813,7 @@
           <p:cNvPr id="8" name="">
             <a:extLst xmlns:a="http://schemas.openxmlformats.org/drawingml/2006/main">
               <a:ext uri="{FF2B5EF4-FFF2-40B4-BE49-F238E27FC236}">
-                <a16:creationId xmlns:a16="http://schemas.microsoft.com/office/drawing/2014/main" id="{A9060614-883A-45C2-8B57-129695B52033}"/>
+                <a16:creationId xmlns:a16="http://schemas.microsoft.com/office/drawing/2014/main" id="{EB13C8FD-2448-44D8-88AE-F6299B6AA219}"/>
               </a:ext>
             </a:extLst>
           </p:cNvPr>
@@ -9646,7 +9970,7 @@
           <p:cNvPr id="9" name="">
             <a:extLst xmlns:a="http://schemas.openxmlformats.org/drawingml/2006/main">
               <a:ext uri="{FF2B5EF4-FFF2-40B4-BE49-F238E27FC236}">
-                <a16:creationId xmlns:a16="http://schemas.microsoft.com/office/drawing/2014/main" id="{F8E77E78-0CFD-4D1D-A1EA-712D927F9022}"/>
+                <a16:creationId xmlns:a16="http://schemas.microsoft.com/office/drawing/2014/main" id="{1D7A3A71-04FA-4439-8BBF-FCB36D32D4E1}"/>
               </a:ext>
             </a:extLst>
           </p:cNvPr>
@@ -9826,7 +10150,7 @@
           <p:cNvPr id="10" name="">
             <a:extLst xmlns:a="http://schemas.openxmlformats.org/drawingml/2006/main">
               <a:ext uri="{FF2B5EF4-FFF2-40B4-BE49-F238E27FC236}">
-                <a16:creationId xmlns:a16="http://schemas.microsoft.com/office/drawing/2014/main" id="{E0C95E80-3294-4383-BCE2-E77347FD2DD4}"/>
+                <a16:creationId xmlns:a16="http://schemas.microsoft.com/office/drawing/2014/main" id="{DB2FDDCD-148C-4FD6-B19F-D2E1F1EFB67B}"/>
               </a:ext>
             </a:extLst>
           </p:cNvPr>
@@ -9859,7 +10183,7 @@
           <p:cNvPr id="11" name="">
             <a:extLst xmlns:a="http://schemas.openxmlformats.org/drawingml/2006/main">
               <a:ext uri="{FF2B5EF4-FFF2-40B4-BE49-F238E27FC236}">
-                <a16:creationId xmlns:a16="http://schemas.microsoft.com/office/drawing/2014/main" id="{D8B1BF39-EDBB-45E4-98C8-F6FF7983FB0D}"/>
+                <a16:creationId xmlns:a16="http://schemas.microsoft.com/office/drawing/2014/main" id="{7BB35D6D-DEA8-49DF-AAC7-99D377925EBB}"/>
               </a:ext>
             </a:extLst>
           </p:cNvPr>
@@ -9894,7 +10218,7 @@
           <p:cNvPr id="12" name="">
             <a:extLst xmlns:a="http://schemas.openxmlformats.org/drawingml/2006/main">
               <a:ext uri="{FF2B5EF4-FFF2-40B4-BE49-F238E27FC236}">
-                <a16:creationId xmlns:a16="http://schemas.microsoft.com/office/drawing/2014/main" id="{46B1DAE9-45F4-4929-98B6-054FA5E2BA5C}"/>
+                <a16:creationId xmlns:a16="http://schemas.microsoft.com/office/drawing/2014/main" id="{C87CFD5C-0773-41B9-9328-B620D5AFA46B}"/>
               </a:ext>
             </a:extLst>
           </p:cNvPr>
@@ -10051,7 +10375,7 @@
           <p:cNvPr id="13" name="">
             <a:extLst xmlns:a="http://schemas.openxmlformats.org/drawingml/2006/main">
               <a:ext uri="{FF2B5EF4-FFF2-40B4-BE49-F238E27FC236}">
-                <a16:creationId xmlns:a16="http://schemas.microsoft.com/office/drawing/2014/main" id="{8672ACDC-57E1-471F-A3F8-DCAD851225B7}"/>
+                <a16:creationId xmlns:a16="http://schemas.microsoft.com/office/drawing/2014/main" id="{94FE65D1-D4E4-41CA-95A0-D6AB6C592883}"/>
               </a:ext>
             </a:extLst>
           </p:cNvPr>
@@ -10208,7 +10532,7 @@
           <p:cNvPr id="14" name="">
             <a:extLst xmlns:a="http://schemas.openxmlformats.org/drawingml/2006/main">
               <a:ext uri="{FF2B5EF4-FFF2-40B4-BE49-F238E27FC236}">
-                <a16:creationId xmlns:a16="http://schemas.microsoft.com/office/drawing/2014/main" id="{BAAF45AE-E727-4CDB-AB53-C826F3833E4F}"/>
+                <a16:creationId xmlns:a16="http://schemas.microsoft.com/office/drawing/2014/main" id="{B7792E35-135D-4F35-B7F5-C7F68481FB16}"/>
               </a:ext>
             </a:extLst>
           </p:cNvPr>
@@ -10241,7 +10565,7 @@
           <p:cNvPr id="15" name="">
             <a:extLst xmlns:a="http://schemas.openxmlformats.org/drawingml/2006/main">
               <a:ext uri="{FF2B5EF4-FFF2-40B4-BE49-F238E27FC236}">
-                <a16:creationId xmlns:a16="http://schemas.microsoft.com/office/drawing/2014/main" id="{0E84AB46-DB79-40D3-9302-36CF5813505E}"/>
+                <a16:creationId xmlns:a16="http://schemas.microsoft.com/office/drawing/2014/main" id="{5125E27C-1D87-484A-A372-23D65206E343}"/>
               </a:ext>
             </a:extLst>
           </p:cNvPr>
@@ -10276,7 +10600,7 @@
           <p:cNvPr id="16" name="">
             <a:extLst xmlns:a="http://schemas.openxmlformats.org/drawingml/2006/main">
               <a:ext uri="{FF2B5EF4-FFF2-40B4-BE49-F238E27FC236}">
-                <a16:creationId xmlns:a16="http://schemas.microsoft.com/office/drawing/2014/main" id="{237F8292-4E79-4433-9CD6-824F443D7193}"/>
+                <a16:creationId xmlns:a16="http://schemas.microsoft.com/office/drawing/2014/main" id="{5FB53C19-526D-475C-920B-83A1CA39B480}"/>
               </a:ext>
             </a:extLst>
           </p:cNvPr>
@@ -10433,7 +10757,7 @@
           <p:cNvPr id="17" name="">
             <a:extLst xmlns:a="http://schemas.openxmlformats.org/drawingml/2006/main">
               <a:ext uri="{FF2B5EF4-FFF2-40B4-BE49-F238E27FC236}">
-                <a16:creationId xmlns:a16="http://schemas.microsoft.com/office/drawing/2014/main" id="{379703B1-777B-4D1C-B961-C1047CDCA4F7}"/>
+                <a16:creationId xmlns:a16="http://schemas.microsoft.com/office/drawing/2014/main" id="{F3AD7250-D8CC-4F8F-A4A5-BB9EA1FEE103}"/>
               </a:ext>
             </a:extLst>
           </p:cNvPr>
@@ -10590,7 +10914,7 @@
           <p:cNvPr id="18" name="">
             <a:extLst xmlns:a="http://schemas.openxmlformats.org/drawingml/2006/main">
               <a:ext uri="{FF2B5EF4-FFF2-40B4-BE49-F238E27FC236}">
-                <a16:creationId xmlns:a16="http://schemas.microsoft.com/office/drawing/2014/main" id="{98E28BE1-6F1A-40B4-BB79-E12AB31B30BD}"/>
+                <a16:creationId xmlns:a16="http://schemas.microsoft.com/office/drawing/2014/main" id="{1D531879-EB35-4784-A7D2-F6969094B13A}"/>
               </a:ext>
             </a:extLst>
           </p:cNvPr>
@@ -10747,7 +11071,7 @@
           <p:cNvPr id="19" name="">
             <a:extLst xmlns:a="http://schemas.openxmlformats.org/drawingml/2006/main">
               <a:ext uri="{FF2B5EF4-FFF2-40B4-BE49-F238E27FC236}">
-                <a16:creationId xmlns:a16="http://schemas.microsoft.com/office/drawing/2014/main" id="{6286801B-35D8-4D22-98D0-3328A358B571}"/>
+                <a16:creationId xmlns:a16="http://schemas.microsoft.com/office/drawing/2014/main" id="{4BE06FBA-4B09-4CF0-A90E-47E59C2B97E8}"/>
               </a:ext>
             </a:extLst>
           </p:cNvPr>
@@ -10904,7 +11228,7 @@
           <p:cNvPr id="20" name="">
             <a:extLst xmlns:a="http://schemas.openxmlformats.org/drawingml/2006/main">
               <a:ext uri="{FF2B5EF4-FFF2-40B4-BE49-F238E27FC236}">
-                <a16:creationId xmlns:a16="http://schemas.microsoft.com/office/drawing/2014/main" id="{607A9A64-BDC1-43FE-97A8-D6622030A3C9}"/>
+                <a16:creationId xmlns:a16="http://schemas.microsoft.com/office/drawing/2014/main" id="{53028720-0F60-4A57-A367-F113D7FF085A}"/>
               </a:ext>
             </a:extLst>
           </p:cNvPr>
@@ -11061,7 +11385,7 @@
           <p:cNvPr id="21" name="">
             <a:extLst xmlns:a="http://schemas.openxmlformats.org/drawingml/2006/main">
               <a:ext uri="{FF2B5EF4-FFF2-40B4-BE49-F238E27FC236}">
-                <a16:creationId xmlns:a16="http://schemas.microsoft.com/office/drawing/2014/main" id="{D977FBD1-42C5-4F2B-A019-6FBB12C530EF}"/>
+                <a16:creationId xmlns:a16="http://schemas.microsoft.com/office/drawing/2014/main" id="{5B82760D-6127-40CA-8C33-94469D8ABE68}"/>
               </a:ext>
             </a:extLst>
           </p:cNvPr>
@@ -11218,7 +11542,7 @@
           <p:cNvPr id="22" name="">
             <a:extLst xmlns:a="http://schemas.openxmlformats.org/drawingml/2006/main">
               <a:ext uri="{FF2B5EF4-FFF2-40B4-BE49-F238E27FC236}">
-                <a16:creationId xmlns:a16="http://schemas.microsoft.com/office/drawing/2014/main" id="{A4665696-7024-4EA8-933D-C9AD7E77D1CF}"/>
+                <a16:creationId xmlns:a16="http://schemas.microsoft.com/office/drawing/2014/main" id="{B172924C-BEB0-4186-B5D8-DD495B1B40E7}"/>
               </a:ext>
             </a:extLst>
           </p:cNvPr>
@@ -11375,7 +11699,7 @@
           <p:cNvPr id="23" name="">
             <a:extLst xmlns:a="http://schemas.openxmlformats.org/drawingml/2006/main">
               <a:ext uri="{FF2B5EF4-FFF2-40B4-BE49-F238E27FC236}">
-                <a16:creationId xmlns:a16="http://schemas.microsoft.com/office/drawing/2014/main" id="{0DE753A8-C844-4D2E-9BC5-455646A102D9}"/>
+                <a16:creationId xmlns:a16="http://schemas.microsoft.com/office/drawing/2014/main" id="{19CE26F1-74C3-4C26-8844-6369C0AA40C0}"/>
               </a:ext>
             </a:extLst>
           </p:cNvPr>
@@ -11532,7 +11856,7 @@
           <p:cNvPr id="24" name="">
             <a:extLst xmlns:a="http://schemas.openxmlformats.org/drawingml/2006/main">
               <a:ext uri="{FF2B5EF4-FFF2-40B4-BE49-F238E27FC236}">
-                <a16:creationId xmlns:a16="http://schemas.microsoft.com/office/drawing/2014/main" id="{FC4D2217-0BA9-45B5-A4D9-64F7D8A0594C}"/>
+                <a16:creationId xmlns:a16="http://schemas.microsoft.com/office/drawing/2014/main" id="{C433A1A0-5677-440B-9BA9-947FAB7892D9}"/>
               </a:ext>
             </a:extLst>
           </p:cNvPr>
@@ -11689,7 +12013,7 @@
           <p:cNvPr id="25" name="">
             <a:extLst xmlns:a="http://schemas.openxmlformats.org/drawingml/2006/main">
               <a:ext uri="{FF2B5EF4-FFF2-40B4-BE49-F238E27FC236}">
-                <a16:creationId xmlns:a16="http://schemas.microsoft.com/office/drawing/2014/main" id="{C59F2403-8FA8-454F-A3EC-6ACB75688F2F}"/>
+                <a16:creationId xmlns:a16="http://schemas.microsoft.com/office/drawing/2014/main" id="{CAC887EE-A97A-4669-A121-89F9C1710054}"/>
               </a:ext>
             </a:extLst>
           </p:cNvPr>
@@ -11716,7 +12040,7 @@
           <a:bodyPr xmlns:a="http://schemas.openxmlformats.org/drawingml/2006/main" anchor="ctr"/>
           <a:lstStyle xmlns:a="http://schemas.openxmlformats.org/drawingml/2006/main">
             <a:defPPr algn="l">
-              <a:defRPr sz="1875" b="0">
+              <a:defRPr sz="1725" b="0">
                 <a:solidFill>
                   <a:srgbClr val="4E5C68"/>
                 </a:solidFill>
@@ -11726,7 +12050,7 @@
               </a:defRPr>
             </a:defPPr>
             <a:lvl1pPr algn="l">
-              <a:defRPr sz="1875" b="0">
+              <a:defRPr sz="1725" b="0">
                 <a:solidFill>
                   <a:srgbClr val="4E5C68"/>
                 </a:solidFill>
@@ -11736,7 +12060,7 @@
               </a:defRPr>
             </a:lvl1pPr>
             <a:lvl2pPr algn="l">
-              <a:defRPr sz="1875" b="0">
+              <a:defRPr sz="1725" b="0">
                 <a:solidFill>
                   <a:srgbClr val="4E5C68"/>
                 </a:solidFill>
@@ -11746,7 +12070,7 @@
               </a:defRPr>
             </a:lvl2pPr>
             <a:lvl3pPr algn="l">
-              <a:defRPr sz="1875" b="0">
+              <a:defRPr sz="1725" b="0">
                 <a:solidFill>
                   <a:srgbClr val="4E5C68"/>
                 </a:solidFill>
@@ -11756,7 +12080,7 @@
               </a:defRPr>
             </a:lvl3pPr>
             <a:lvl4pPr algn="l">
-              <a:defRPr sz="1875" b="0">
+              <a:defRPr sz="1725" b="0">
                 <a:solidFill>
                   <a:srgbClr val="4E5C68"/>
                 </a:solidFill>
@@ -11766,7 +12090,7 @@
               </a:defRPr>
             </a:lvl4pPr>
             <a:lvl5pPr algn="l">
-              <a:defRPr sz="1875" b="0">
+              <a:defRPr sz="1725" b="0">
                 <a:solidFill>
                   <a:srgbClr val="4E5C68"/>
                 </a:solidFill>
@@ -11776,7 +12100,7 @@
               </a:defRPr>
             </a:lvl5pPr>
             <a:lvl6pPr algn="l">
-              <a:defRPr sz="1875" b="0">
+              <a:defRPr sz="1725" b="0">
                 <a:solidFill>
                   <a:srgbClr val="4E5C68"/>
                 </a:solidFill>
@@ -11786,7 +12110,7 @@
               </a:defRPr>
             </a:lvl6pPr>
             <a:lvl7pPr algn="l">
-              <a:defRPr sz="1875" b="0">
+              <a:defRPr sz="1725" b="0">
                 <a:solidFill>
                   <a:srgbClr val="4E5C68"/>
                 </a:solidFill>
@@ -11796,7 +12120,7 @@
               </a:defRPr>
             </a:lvl7pPr>
             <a:lvl8pPr algn="l">
-              <a:defRPr sz="1875" b="0">
+              <a:defRPr sz="1725" b="0">
                 <a:solidFill>
                   <a:srgbClr val="4E5C68"/>
                 </a:solidFill>
@@ -11806,7 +12130,7 @@
               </a:defRPr>
             </a:lvl8pPr>
             <a:lvl9pPr algn="l">
-              <a:defRPr sz="1875" b="0">
+              <a:defRPr sz="1725" b="0">
                 <a:solidFill>
                   <a:srgbClr val="4E5C68"/>
                 </a:solidFill>
@@ -11818,7 +12142,7 @@
           </a:lstStyle>
           <a:p xmlns:a="http://schemas.openxmlformats.org/drawingml/2006/main">
             <a:pPr algn="l">
-              <a:defRPr sz="1875" b="0">
+              <a:defRPr sz="1725" b="0">
                 <a:solidFill>
                   <a:srgbClr val="4E5C68"/>
                 </a:solidFill>
@@ -11828,7 +12152,7 @@
               </a:defRPr>
             </a:pPr>
             <a:r>
-              <a:rPr sz="1875" b="0">
+              <a:rPr sz="1725" b="0">
                 <a:solidFill>
                   <a:srgbClr val="4E5C68"/>
                 </a:solidFill>
@@ -11836,7 +12160,7 @@
                 <a:ea typeface="Arial"/>
                 <a:cs typeface="Arial"/>
               </a:rPr>
-              <a:t>El test permanece separado hasta la evaluación final.</a:t>
+              <a:t>Adaptación EP2: cambiar el formato, no volver a limpiar. El test sigue separado.</a:t>
             </a:r>
           </a:p>
         </p:txBody>
@@ -11844,7 +12168,7 @@
     </p:spTree>
     <p:extLst>
       <p:ext uri="{BB962C8B-B14F-4D97-AF65-F5344CB8AC3E}">
-        <p14:creationId xmlns:p14="http://schemas.microsoft.com/office/powerpoint/2010/main" val="1108810183"/>
+        <p14:creationId xmlns:p14="http://schemas.microsoft.com/office/powerpoint/2010/main" val="1325095495"/>
       </p:ext>
     </p:extLst>
   </p:cSld>
@@ -11875,7 +12199,7 @@
           <p:cNvPr id="32" name="">
             <a:extLst xmlns:a="http://schemas.openxmlformats.org/drawingml/2006/main">
               <a:ext uri="{FF2B5EF4-FFF2-40B4-BE49-F238E27FC236}">
-                <a16:creationId xmlns:a16="http://schemas.microsoft.com/office/drawing/2014/main" id="{34E1257D-FC8D-43BA-9020-02B8829FB97F}"/>
+                <a16:creationId xmlns:a16="http://schemas.microsoft.com/office/drawing/2014/main" id="{2530F363-BDD6-4A1F-B625-92B27DDCC304}"/>
               </a:ext>
             </a:extLst>
           </p:cNvPr>
@@ -12032,7 +12356,7 @@
           <p:cNvPr id="2" name="">
             <a:extLst xmlns:a="http://schemas.openxmlformats.org/drawingml/2006/main">
               <a:ext uri="{FF2B5EF4-FFF2-40B4-BE49-F238E27FC236}">
-                <a16:creationId xmlns:a16="http://schemas.microsoft.com/office/drawing/2014/main" id="{DAA10F37-2126-4797-B9A3-C32803ABD9CE}"/>
+                <a16:creationId xmlns:a16="http://schemas.microsoft.com/office/drawing/2014/main" id="{355C2A52-CCF6-4622-9F92-71A09FA0C396}"/>
               </a:ext>
             </a:extLst>
           </p:cNvPr>
@@ -12189,7 +12513,7 @@
           <p:cNvPr id="3" name="">
             <a:extLst xmlns:a="http://schemas.openxmlformats.org/drawingml/2006/main">
               <a:ext uri="{FF2B5EF4-FFF2-40B4-BE49-F238E27FC236}">
-                <a16:creationId xmlns:a16="http://schemas.microsoft.com/office/drawing/2014/main" id="{B27DC143-5929-41C8-A860-A58FF30DE8C2}"/>
+                <a16:creationId xmlns:a16="http://schemas.microsoft.com/office/drawing/2014/main" id="{DBF6EEBD-20EA-43E7-A8F3-B411521025DD}"/>
               </a:ext>
             </a:extLst>
           </p:cNvPr>
@@ -12224,7 +12548,7 @@
           <p:cNvPr id="4" name="">
             <a:extLst xmlns:a="http://schemas.openxmlformats.org/drawingml/2006/main">
               <a:ext uri="{FF2B5EF4-FFF2-40B4-BE49-F238E27FC236}">
-                <a16:creationId xmlns:a16="http://schemas.microsoft.com/office/drawing/2014/main" id="{4D1018C3-B72D-4BEF-A6A8-BAFF939E79BE}"/>
+                <a16:creationId xmlns:a16="http://schemas.microsoft.com/office/drawing/2014/main" id="{7C1C8F23-13FE-4387-9805-5155BB7EF712}"/>
               </a:ext>
             </a:extLst>
           </p:cNvPr>
@@ -12381,7 +12705,7 @@
           <p:cNvPr id="5" name="">
             <a:extLst xmlns:a="http://schemas.openxmlformats.org/drawingml/2006/main">
               <a:ext uri="{FF2B5EF4-FFF2-40B4-BE49-F238E27FC236}">
-                <a16:creationId xmlns:a16="http://schemas.microsoft.com/office/drawing/2014/main" id="{9DF6DAA3-231B-4F8D-B165-4C95DB0A249A}"/>
+                <a16:creationId xmlns:a16="http://schemas.microsoft.com/office/drawing/2014/main" id="{BB63866F-E67E-4445-9FF9-A9C52321EFAD}"/>
               </a:ext>
             </a:extLst>
           </p:cNvPr>
@@ -12538,7 +12862,7 @@
           <p:cNvPr id="6" name="">
             <a:extLst xmlns:a="http://schemas.openxmlformats.org/drawingml/2006/main">
               <a:ext uri="{FF2B5EF4-FFF2-40B4-BE49-F238E27FC236}">
-                <a16:creationId xmlns:a16="http://schemas.microsoft.com/office/drawing/2014/main" id="{5C4B9C07-B4A8-49EF-B3BD-63C623827BCE}"/>
+                <a16:creationId xmlns:a16="http://schemas.microsoft.com/office/drawing/2014/main" id="{2A0F9593-2C86-490B-AF37-99B64C477013}"/>
               </a:ext>
             </a:extLst>
           </p:cNvPr>
@@ -12571,7 +12895,7 @@
           <p:cNvPr id="7" name="">
             <a:extLst xmlns:a="http://schemas.openxmlformats.org/drawingml/2006/main">
               <a:ext uri="{FF2B5EF4-FFF2-40B4-BE49-F238E27FC236}">
-                <a16:creationId xmlns:a16="http://schemas.microsoft.com/office/drawing/2014/main" id="{A452EC64-EB55-454A-9B71-088F87D69518}"/>
+                <a16:creationId xmlns:a16="http://schemas.microsoft.com/office/drawing/2014/main" id="{D5B0F51D-8009-489F-A09E-92DA24865AA5}"/>
               </a:ext>
             </a:extLst>
           </p:cNvPr>
@@ -12606,7 +12930,7 @@
           <p:cNvPr id="8" name="">
             <a:extLst xmlns:a="http://schemas.openxmlformats.org/drawingml/2006/main">
               <a:ext uri="{FF2B5EF4-FFF2-40B4-BE49-F238E27FC236}">
-                <a16:creationId xmlns:a16="http://schemas.microsoft.com/office/drawing/2014/main" id="{2288EDB7-5212-4CEC-8D30-9DEBBDBF6C29}"/>
+                <a16:creationId xmlns:a16="http://schemas.microsoft.com/office/drawing/2014/main" id="{42A8B7DF-D06F-460C-BF82-47634F26B978}"/>
               </a:ext>
             </a:extLst>
           </p:cNvPr>
@@ -12763,7 +13087,7 @@
           <p:cNvPr id="9" name="">
             <a:extLst xmlns:a="http://schemas.openxmlformats.org/drawingml/2006/main">
               <a:ext uri="{FF2B5EF4-FFF2-40B4-BE49-F238E27FC236}">
-                <a16:creationId xmlns:a16="http://schemas.microsoft.com/office/drawing/2014/main" id="{B8862A76-6EDB-4AC0-A42F-26B58D6781D8}"/>
+                <a16:creationId xmlns:a16="http://schemas.microsoft.com/office/drawing/2014/main" id="{68E7148B-4994-4F5E-88CF-1574EE6CB957}"/>
               </a:ext>
             </a:extLst>
           </p:cNvPr>
@@ -12920,7 +13244,7 @@
           <p:cNvPr id="10" name="">
             <a:extLst xmlns:a="http://schemas.openxmlformats.org/drawingml/2006/main">
               <a:ext uri="{FF2B5EF4-FFF2-40B4-BE49-F238E27FC236}">
-                <a16:creationId xmlns:a16="http://schemas.microsoft.com/office/drawing/2014/main" id="{8952F6D2-3484-4930-A2CE-AB21589BBF30}"/>
+                <a16:creationId xmlns:a16="http://schemas.microsoft.com/office/drawing/2014/main" id="{834D9ACA-F177-4D45-A7C6-9D9203C924B4}"/>
               </a:ext>
             </a:extLst>
           </p:cNvPr>
@@ -12953,7 +13277,7 @@
           <p:cNvPr id="11" name="">
             <a:extLst xmlns:a="http://schemas.openxmlformats.org/drawingml/2006/main">
               <a:ext uri="{FF2B5EF4-FFF2-40B4-BE49-F238E27FC236}">
-                <a16:creationId xmlns:a16="http://schemas.microsoft.com/office/drawing/2014/main" id="{A23EC6FD-24E4-426F-B5CB-287B252C3F08}"/>
+                <a16:creationId xmlns:a16="http://schemas.microsoft.com/office/drawing/2014/main" id="{EC925FE0-EE3E-4270-8B68-DC8E089AD77A}"/>
               </a:ext>
             </a:extLst>
           </p:cNvPr>
@@ -12988,7 +13312,7 @@
           <p:cNvPr id="12" name="">
             <a:extLst xmlns:a="http://schemas.openxmlformats.org/drawingml/2006/main">
               <a:ext uri="{FF2B5EF4-FFF2-40B4-BE49-F238E27FC236}">
-                <a16:creationId xmlns:a16="http://schemas.microsoft.com/office/drawing/2014/main" id="{8D32985E-D75D-4AA9-8905-5F8367D0F04C}"/>
+                <a16:creationId xmlns:a16="http://schemas.microsoft.com/office/drawing/2014/main" id="{00E854B2-34C4-440A-B931-87F827CCB648}"/>
               </a:ext>
             </a:extLst>
           </p:cNvPr>
@@ -13145,7 +13469,7 @@
           <p:cNvPr id="13" name="">
             <a:extLst xmlns:a="http://schemas.openxmlformats.org/drawingml/2006/main">
               <a:ext uri="{FF2B5EF4-FFF2-40B4-BE49-F238E27FC236}">
-                <a16:creationId xmlns:a16="http://schemas.microsoft.com/office/drawing/2014/main" id="{FDD69A63-C226-481C-A47E-7B2EE9A38A71}"/>
+                <a16:creationId xmlns:a16="http://schemas.microsoft.com/office/drawing/2014/main" id="{3467282E-F235-4237-92B1-5A3DDE504201}"/>
               </a:ext>
             </a:extLst>
           </p:cNvPr>
@@ -13302,7 +13626,7 @@
           <p:cNvPr id="14" name="">
             <a:extLst xmlns:a="http://schemas.openxmlformats.org/drawingml/2006/main">
               <a:ext uri="{FF2B5EF4-FFF2-40B4-BE49-F238E27FC236}">
-                <a16:creationId xmlns:a16="http://schemas.microsoft.com/office/drawing/2014/main" id="{09B54250-6784-46EC-8109-141532A27062}"/>
+                <a16:creationId xmlns:a16="http://schemas.microsoft.com/office/drawing/2014/main" id="{9C8B109C-EF8F-44EC-BECC-65198763654D}"/>
               </a:ext>
             </a:extLst>
           </p:cNvPr>
@@ -13335,7 +13659,7 @@
           <p:cNvPr id="15" name="">
             <a:extLst xmlns:a="http://schemas.openxmlformats.org/drawingml/2006/main">
               <a:ext uri="{FF2B5EF4-FFF2-40B4-BE49-F238E27FC236}">
-                <a16:creationId xmlns:a16="http://schemas.microsoft.com/office/drawing/2014/main" id="{33E30B6E-5E70-45FE-B74E-862944017F5D}"/>
+                <a16:creationId xmlns:a16="http://schemas.microsoft.com/office/drawing/2014/main" id="{1DC147AE-8D59-4A18-96DC-38022DBCBFBA}"/>
               </a:ext>
             </a:extLst>
           </p:cNvPr>
@@ -13370,7 +13694,7 @@
           <p:cNvPr id="16" name="">
             <a:extLst xmlns:a="http://schemas.openxmlformats.org/drawingml/2006/main">
               <a:ext uri="{FF2B5EF4-FFF2-40B4-BE49-F238E27FC236}">
-                <a16:creationId xmlns:a16="http://schemas.microsoft.com/office/drawing/2014/main" id="{B741DEBB-9ABE-4B3C-B6A3-2D3BBFA90CF5}"/>
+                <a16:creationId xmlns:a16="http://schemas.microsoft.com/office/drawing/2014/main" id="{3DF1A389-345A-4344-AB4A-3FB5AB45CA93}"/>
               </a:ext>
             </a:extLst>
           </p:cNvPr>
@@ -13527,7 +13851,7 @@
           <p:cNvPr id="17" name="">
             <a:extLst xmlns:a="http://schemas.openxmlformats.org/drawingml/2006/main">
               <a:ext uri="{FF2B5EF4-FFF2-40B4-BE49-F238E27FC236}">
-                <a16:creationId xmlns:a16="http://schemas.microsoft.com/office/drawing/2014/main" id="{55F17926-3623-4D1E-9318-33D888FE1ACC}"/>
+                <a16:creationId xmlns:a16="http://schemas.microsoft.com/office/drawing/2014/main" id="{D209D6E9-0638-4EC5-9162-32C7FAF6968E}"/>
               </a:ext>
             </a:extLst>
           </p:cNvPr>
@@ -13684,7 +14008,7 @@
           <p:cNvPr id="18" name="">
             <a:extLst xmlns:a="http://schemas.openxmlformats.org/drawingml/2006/main">
               <a:ext uri="{FF2B5EF4-FFF2-40B4-BE49-F238E27FC236}">
-                <a16:creationId xmlns:a16="http://schemas.microsoft.com/office/drawing/2014/main" id="{034A2DEA-E7F1-4189-B733-DCC36BE4A379}"/>
+                <a16:creationId xmlns:a16="http://schemas.microsoft.com/office/drawing/2014/main" id="{1EF510B6-5AA7-4C3B-92BE-17027ADDD3E8}"/>
               </a:ext>
             </a:extLst>
           </p:cNvPr>
@@ -13717,7 +14041,7 @@
           <p:cNvPr id="19" name="">
             <a:extLst xmlns:a="http://schemas.openxmlformats.org/drawingml/2006/main">
               <a:ext uri="{FF2B5EF4-FFF2-40B4-BE49-F238E27FC236}">
-                <a16:creationId xmlns:a16="http://schemas.microsoft.com/office/drawing/2014/main" id="{3818C74D-8092-4C81-A2BE-21C08BECAE25}"/>
+                <a16:creationId xmlns:a16="http://schemas.microsoft.com/office/drawing/2014/main" id="{CA861775-0909-4119-A12C-6456C76E9196}"/>
               </a:ext>
             </a:extLst>
           </p:cNvPr>
@@ -13752,7 +14076,7 @@
           <p:cNvPr id="20" name="">
             <a:extLst xmlns:a="http://schemas.openxmlformats.org/drawingml/2006/main">
               <a:ext uri="{FF2B5EF4-FFF2-40B4-BE49-F238E27FC236}">
-                <a16:creationId xmlns:a16="http://schemas.microsoft.com/office/drawing/2014/main" id="{E11E3C94-8DB6-46FF-AC94-46E8174C9EEF}"/>
+                <a16:creationId xmlns:a16="http://schemas.microsoft.com/office/drawing/2014/main" id="{3ED563BA-6F2A-414E-8B95-5377F2518388}"/>
               </a:ext>
             </a:extLst>
           </p:cNvPr>
@@ -13909,7 +14233,7 @@
           <p:cNvPr id="21" name="">
             <a:extLst xmlns:a="http://schemas.openxmlformats.org/drawingml/2006/main">
               <a:ext uri="{FF2B5EF4-FFF2-40B4-BE49-F238E27FC236}">
-                <a16:creationId xmlns:a16="http://schemas.microsoft.com/office/drawing/2014/main" id="{99F6AAA8-7ADC-494E-B83A-9F14CA7A08BE}"/>
+                <a16:creationId xmlns:a16="http://schemas.microsoft.com/office/drawing/2014/main" id="{EFCAF635-91C2-48A9-9FF1-7277DA4F475A}"/>
               </a:ext>
             </a:extLst>
           </p:cNvPr>
@@ -14066,7 +14390,7 @@
           <p:cNvPr id="22" name="">
             <a:extLst xmlns:a="http://schemas.openxmlformats.org/drawingml/2006/main">
               <a:ext uri="{FF2B5EF4-FFF2-40B4-BE49-F238E27FC236}">
-                <a16:creationId xmlns:a16="http://schemas.microsoft.com/office/drawing/2014/main" id="{D1AF7565-79FE-4510-AD3A-2188AA3DC557}"/>
+                <a16:creationId xmlns:a16="http://schemas.microsoft.com/office/drawing/2014/main" id="{B809B52B-3756-42C7-AE14-6FF609A4FC93}"/>
               </a:ext>
             </a:extLst>
           </p:cNvPr>
@@ -14223,7 +14547,7 @@
           <p:cNvPr id="23" name="">
             <a:extLst xmlns:a="http://schemas.openxmlformats.org/drawingml/2006/main">
               <a:ext uri="{FF2B5EF4-FFF2-40B4-BE49-F238E27FC236}">
-                <a16:creationId xmlns:a16="http://schemas.microsoft.com/office/drawing/2014/main" id="{A5E42742-04F6-4103-AFED-0EE3E14571BA}"/>
+                <a16:creationId xmlns:a16="http://schemas.microsoft.com/office/drawing/2014/main" id="{6DE8DB35-DF6D-46B4-952E-749222A686E4}"/>
               </a:ext>
             </a:extLst>
           </p:cNvPr>
@@ -14380,7 +14704,7 @@
           <p:cNvPr id="24" name="">
             <a:extLst xmlns:a="http://schemas.openxmlformats.org/drawingml/2006/main">
               <a:ext uri="{FF2B5EF4-FFF2-40B4-BE49-F238E27FC236}">
-                <a16:creationId xmlns:a16="http://schemas.microsoft.com/office/drawing/2014/main" id="{FE3EC078-9857-4F41-A6B5-C10399640346}"/>
+                <a16:creationId xmlns:a16="http://schemas.microsoft.com/office/drawing/2014/main" id="{966B0AF3-7C75-4CA6-A565-2F083DD99B52}"/>
               </a:ext>
             </a:extLst>
           </p:cNvPr>
@@ -14537,7 +14861,7 @@
           <p:cNvPr id="25" name="">
             <a:extLst xmlns:a="http://schemas.openxmlformats.org/drawingml/2006/main">
               <a:ext uri="{FF2B5EF4-FFF2-40B4-BE49-F238E27FC236}">
-                <a16:creationId xmlns:a16="http://schemas.microsoft.com/office/drawing/2014/main" id="{A896C447-6B16-41E8-8355-9D8FDDEB283B}"/>
+                <a16:creationId xmlns:a16="http://schemas.microsoft.com/office/drawing/2014/main" id="{F00E4EF8-48C5-40CA-A2E9-EC06F6724446}"/>
               </a:ext>
             </a:extLst>
           </p:cNvPr>
@@ -14694,7 +15018,7 @@
           <p:cNvPr id="26" name="">
             <a:extLst xmlns:a="http://schemas.openxmlformats.org/drawingml/2006/main">
               <a:ext uri="{FF2B5EF4-FFF2-40B4-BE49-F238E27FC236}">
-                <a16:creationId xmlns:a16="http://schemas.microsoft.com/office/drawing/2014/main" id="{AE27CBE5-F835-47A5-9C05-F66A51DD405B}"/>
+                <a16:creationId xmlns:a16="http://schemas.microsoft.com/office/drawing/2014/main" id="{5A9B218E-1F19-4D9C-84CA-F8AF7B797D55}"/>
               </a:ext>
             </a:extLst>
           </p:cNvPr>
@@ -14851,7 +15175,7 @@
           <p:cNvPr id="27" name="">
             <a:extLst xmlns:a="http://schemas.openxmlformats.org/drawingml/2006/main">
               <a:ext uri="{FF2B5EF4-FFF2-40B4-BE49-F238E27FC236}">
-                <a16:creationId xmlns:a16="http://schemas.microsoft.com/office/drawing/2014/main" id="{D680EDAD-A815-4D0C-AD32-055545071FB2}"/>
+                <a16:creationId xmlns:a16="http://schemas.microsoft.com/office/drawing/2014/main" id="{DA253CEC-E73E-4F14-9096-B28743FAC2E4}"/>
               </a:ext>
             </a:extLst>
           </p:cNvPr>
@@ -15008,7 +15332,7 @@
           <p:cNvPr id="28" name="">
             <a:extLst xmlns:a="http://schemas.openxmlformats.org/drawingml/2006/main">
               <a:ext uri="{FF2B5EF4-FFF2-40B4-BE49-F238E27FC236}">
-                <a16:creationId xmlns:a16="http://schemas.microsoft.com/office/drawing/2014/main" id="{14DB74CB-35DE-48B2-B066-8C0DF5AC64BF}"/>
+                <a16:creationId xmlns:a16="http://schemas.microsoft.com/office/drawing/2014/main" id="{1455B637-C3F5-44F2-A051-41A498A71E84}"/>
               </a:ext>
             </a:extLst>
           </p:cNvPr>
@@ -15165,7 +15489,7 @@
           <p:cNvPr id="29" name="">
             <a:extLst xmlns:a="http://schemas.openxmlformats.org/drawingml/2006/main">
               <a:ext uri="{FF2B5EF4-FFF2-40B4-BE49-F238E27FC236}">
-                <a16:creationId xmlns:a16="http://schemas.microsoft.com/office/drawing/2014/main" id="{8B914081-5DDF-42D6-9630-B6872A7B71FF}"/>
+                <a16:creationId xmlns:a16="http://schemas.microsoft.com/office/drawing/2014/main" id="{D48EB9AB-4D3D-464B-B142-BFD9B759FE41}"/>
               </a:ext>
             </a:extLst>
           </p:cNvPr>
@@ -15322,7 +15646,7 @@
           <p:cNvPr id="30" name="">
             <a:extLst xmlns:a="http://schemas.openxmlformats.org/drawingml/2006/main">
               <a:ext uri="{FF2B5EF4-FFF2-40B4-BE49-F238E27FC236}">
-                <a16:creationId xmlns:a16="http://schemas.microsoft.com/office/drawing/2014/main" id="{3A92C4BB-F058-4828-895B-CE3AC74DE8EF}"/>
+                <a16:creationId xmlns:a16="http://schemas.microsoft.com/office/drawing/2014/main" id="{D45505E5-9FD4-462D-9915-9267E756178D}"/>
               </a:ext>
             </a:extLst>
           </p:cNvPr>
@@ -15479,7 +15803,7 @@
           <p:cNvPr id="31" name="">
             <a:extLst xmlns:a="http://schemas.openxmlformats.org/drawingml/2006/main">
               <a:ext uri="{FF2B5EF4-FFF2-40B4-BE49-F238E27FC236}">
-                <a16:creationId xmlns:a16="http://schemas.microsoft.com/office/drawing/2014/main" id="{8F110F4C-5779-4D3C-B0D4-912E29BE2C72}"/>
+                <a16:creationId xmlns:a16="http://schemas.microsoft.com/office/drawing/2014/main" id="{4E5B16A3-E343-433F-BDF0-43CDDFA486CB}"/>
               </a:ext>
             </a:extLst>
           </p:cNvPr>
@@ -15634,7 +15958,7 @@
     </p:spTree>
     <p:extLst>
       <p:ext uri="{BB962C8B-B14F-4D97-AF65-F5344CB8AC3E}">
-        <p14:creationId xmlns:p14="http://schemas.microsoft.com/office/powerpoint/2010/main" val="2111948638"/>
+        <p14:creationId xmlns:p14="http://schemas.microsoft.com/office/powerpoint/2010/main" val="56622113"/>
       </p:ext>
     </p:extLst>
   </p:cSld>
@@ -15665,7 +15989,7 @@
           <p:cNvPr id="18" name="">
             <a:extLst xmlns:a="http://schemas.openxmlformats.org/drawingml/2006/main">
               <a:ext uri="{FF2B5EF4-FFF2-40B4-BE49-F238E27FC236}">
-                <a16:creationId xmlns:a16="http://schemas.microsoft.com/office/drawing/2014/main" id="{D2CFCC7C-238D-493B-AEAC-FC36F8E2F7E1}"/>
+                <a16:creationId xmlns:a16="http://schemas.microsoft.com/office/drawing/2014/main" id="{B6471F43-02A4-4CC9-BBF6-D0C852B03CA2}"/>
               </a:ext>
             </a:extLst>
           </p:cNvPr>
@@ -15822,7 +16146,7 @@
           <p:cNvPr id="2" name="">
             <a:extLst xmlns:a="http://schemas.openxmlformats.org/drawingml/2006/main">
               <a:ext uri="{FF2B5EF4-FFF2-40B4-BE49-F238E27FC236}">
-                <a16:creationId xmlns:a16="http://schemas.microsoft.com/office/drawing/2014/main" id="{2B0F38BB-E060-415F-86D1-409C9DC9BA96}"/>
+                <a16:creationId xmlns:a16="http://schemas.microsoft.com/office/drawing/2014/main" id="{2891E86A-D63E-4F6E-AC53-F9BD2AD0EEBE}"/>
               </a:ext>
             </a:extLst>
           </p:cNvPr>
@@ -15979,7 +16303,7 @@
           <p:cNvPr id="3" name="">
             <a:extLst xmlns:a="http://schemas.openxmlformats.org/drawingml/2006/main">
               <a:ext uri="{FF2B5EF4-FFF2-40B4-BE49-F238E27FC236}">
-                <a16:creationId xmlns:a16="http://schemas.microsoft.com/office/drawing/2014/main" id="{D0F04BCE-5B4E-4B68-93F5-BB3A5C062CE2}"/>
+                <a16:creationId xmlns:a16="http://schemas.microsoft.com/office/drawing/2014/main" id="{3ECEC092-1A64-429A-8145-559E9641D997}"/>
               </a:ext>
             </a:extLst>
           </p:cNvPr>
@@ -16136,7 +16460,7 @@
           <p:cNvPr id="4" name="">
             <a:extLst xmlns:a="http://schemas.openxmlformats.org/drawingml/2006/main">
               <a:ext uri="{FF2B5EF4-FFF2-40B4-BE49-F238E27FC236}">
-                <a16:creationId xmlns:a16="http://schemas.microsoft.com/office/drawing/2014/main" id="{2823C8C9-6B58-4F21-980E-6D2B75848BA9}"/>
+                <a16:creationId xmlns:a16="http://schemas.microsoft.com/office/drawing/2014/main" id="{1F45D0AD-31BD-4942-8DE4-08F4CAA85A35}"/>
               </a:ext>
             </a:extLst>
           </p:cNvPr>
@@ -16293,7 +16617,7 @@
           <p:cNvPr id="5" name="">
             <a:extLst xmlns:a="http://schemas.openxmlformats.org/drawingml/2006/main">
               <a:ext uri="{FF2B5EF4-FFF2-40B4-BE49-F238E27FC236}">
-                <a16:creationId xmlns:a16="http://schemas.microsoft.com/office/drawing/2014/main" id="{4A7559FA-0D52-4028-9584-48255377F395}"/>
+                <a16:creationId xmlns:a16="http://schemas.microsoft.com/office/drawing/2014/main" id="{A165BFDA-4E0A-4524-A9BC-5EFFEA56E7B6}"/>
               </a:ext>
             </a:extLst>
           </p:cNvPr>
@@ -16450,7 +16774,7 @@
           <p:cNvPr id="6" name="">
             <a:extLst xmlns:a="http://schemas.openxmlformats.org/drawingml/2006/main">
               <a:ext uri="{FF2B5EF4-FFF2-40B4-BE49-F238E27FC236}">
-                <a16:creationId xmlns:a16="http://schemas.microsoft.com/office/drawing/2014/main" id="{E4DC814B-D4D2-4438-A45B-02573CB77395}"/>
+                <a16:creationId xmlns:a16="http://schemas.microsoft.com/office/drawing/2014/main" id="{9E45B62A-695B-42D1-BC85-8EF5085B02A2}"/>
               </a:ext>
             </a:extLst>
           </p:cNvPr>
@@ -16607,7 +16931,7 @@
           <p:cNvPr id="7" name="">
             <a:extLst xmlns:a="http://schemas.openxmlformats.org/drawingml/2006/main">
               <a:ext uri="{FF2B5EF4-FFF2-40B4-BE49-F238E27FC236}">
-                <a16:creationId xmlns:a16="http://schemas.microsoft.com/office/drawing/2014/main" id="{07178C8A-F1B1-49F9-A63D-C5C8A91C3BA2}"/>
+                <a16:creationId xmlns:a16="http://schemas.microsoft.com/office/drawing/2014/main" id="{DD520F66-5A15-4DFC-B686-19A0B343FCB2}"/>
               </a:ext>
             </a:extLst>
           </p:cNvPr>
@@ -16764,7 +17088,7 @@
           <p:cNvPr id="8" name="">
             <a:extLst xmlns:a="http://schemas.openxmlformats.org/drawingml/2006/main">
               <a:ext uri="{FF2B5EF4-FFF2-40B4-BE49-F238E27FC236}">
-                <a16:creationId xmlns:a16="http://schemas.microsoft.com/office/drawing/2014/main" id="{814399F1-AF0D-45AD-B972-045BD2879985}"/>
+                <a16:creationId xmlns:a16="http://schemas.microsoft.com/office/drawing/2014/main" id="{49470566-8EB3-4261-B7F3-54398462AA6E}"/>
               </a:ext>
             </a:extLst>
           </p:cNvPr>
@@ -16921,7 +17245,7 @@
           <p:cNvPr id="9" name="">
             <a:extLst xmlns:a="http://schemas.openxmlformats.org/drawingml/2006/main">
               <a:ext uri="{FF2B5EF4-FFF2-40B4-BE49-F238E27FC236}">
-                <a16:creationId xmlns:a16="http://schemas.microsoft.com/office/drawing/2014/main" id="{7675BE9F-9E8E-4288-9E3B-CE1CE2C9F6B0}"/>
+                <a16:creationId xmlns:a16="http://schemas.microsoft.com/office/drawing/2014/main" id="{99DAC7AA-BB74-4E6D-960E-DEFEFF061402}"/>
               </a:ext>
             </a:extLst>
           </p:cNvPr>
@@ -17078,7 +17402,7 @@
           <p:cNvPr id="10" name="">
             <a:extLst xmlns:a="http://schemas.openxmlformats.org/drawingml/2006/main">
               <a:ext uri="{FF2B5EF4-FFF2-40B4-BE49-F238E27FC236}">
-                <a16:creationId xmlns:a16="http://schemas.microsoft.com/office/drawing/2014/main" id="{7A064CEE-2956-4B6D-A1FA-E9BEAE15E3C5}"/>
+                <a16:creationId xmlns:a16="http://schemas.microsoft.com/office/drawing/2014/main" id="{CFDB70C9-1379-43A2-A346-0E6B266DD200}"/>
               </a:ext>
             </a:extLst>
           </p:cNvPr>
@@ -17235,7 +17559,7 @@
           <p:cNvPr id="11" name="">
             <a:extLst xmlns:a="http://schemas.openxmlformats.org/drawingml/2006/main">
               <a:ext uri="{FF2B5EF4-FFF2-40B4-BE49-F238E27FC236}">
-                <a16:creationId xmlns:a16="http://schemas.microsoft.com/office/drawing/2014/main" id="{7959552D-E960-4C2C-AFE0-5BAA79B3BC29}"/>
+                <a16:creationId xmlns:a16="http://schemas.microsoft.com/office/drawing/2014/main" id="{5EDB5393-07FF-4800-A6D2-814C393ACE5F}"/>
               </a:ext>
             </a:extLst>
           </p:cNvPr>
@@ -17392,7 +17716,7 @@
           <p:cNvPr id="12" name="">
             <a:extLst xmlns:a="http://schemas.openxmlformats.org/drawingml/2006/main">
               <a:ext uri="{FF2B5EF4-FFF2-40B4-BE49-F238E27FC236}">
-                <a16:creationId xmlns:a16="http://schemas.microsoft.com/office/drawing/2014/main" id="{16D59DE2-70D7-4D84-98C0-DD1FB3C92390}"/>
+                <a16:creationId xmlns:a16="http://schemas.microsoft.com/office/drawing/2014/main" id="{DFEB366C-B677-4917-9110-D7756A449AB8}"/>
               </a:ext>
             </a:extLst>
           </p:cNvPr>
@@ -17549,7 +17873,7 @@
           <p:cNvPr id="13" name="">
             <a:extLst xmlns:a="http://schemas.openxmlformats.org/drawingml/2006/main">
               <a:ext uri="{FF2B5EF4-FFF2-40B4-BE49-F238E27FC236}">
-                <a16:creationId xmlns:a16="http://schemas.microsoft.com/office/drawing/2014/main" id="{C6B59C7B-3717-439B-9182-5EB1E43EED84}"/>
+                <a16:creationId xmlns:a16="http://schemas.microsoft.com/office/drawing/2014/main" id="{E5B917C9-C127-41B7-87A8-9F24B895C212}"/>
               </a:ext>
             </a:extLst>
           </p:cNvPr>
@@ -17706,7 +18030,7 @@
           <p:cNvPr id="14" name="">
             <a:extLst xmlns:a="http://schemas.openxmlformats.org/drawingml/2006/main">
               <a:ext uri="{FF2B5EF4-FFF2-40B4-BE49-F238E27FC236}">
-                <a16:creationId xmlns:a16="http://schemas.microsoft.com/office/drawing/2014/main" id="{5F1415D1-A7CD-4D65-BDF6-B31731227AA8}"/>
+                <a16:creationId xmlns:a16="http://schemas.microsoft.com/office/drawing/2014/main" id="{0078F6A6-85E8-4A62-98CD-1AEDEDDCBC63}"/>
               </a:ext>
             </a:extLst>
           </p:cNvPr>
@@ -17863,7 +18187,7 @@
           <p:cNvPr id="15" name="">
             <a:extLst xmlns:a="http://schemas.openxmlformats.org/drawingml/2006/main">
               <a:ext uri="{FF2B5EF4-FFF2-40B4-BE49-F238E27FC236}">
-                <a16:creationId xmlns:a16="http://schemas.microsoft.com/office/drawing/2014/main" id="{1C0A3544-2663-4EE9-8CA4-D415249F5BCA}"/>
+                <a16:creationId xmlns:a16="http://schemas.microsoft.com/office/drawing/2014/main" id="{01CDD737-06A8-41FB-AAD9-2E470B351784}"/>
               </a:ext>
             </a:extLst>
           </p:cNvPr>
@@ -18020,7 +18344,7 @@
           <p:cNvPr id="16" name="">
             <a:extLst xmlns:a="http://schemas.openxmlformats.org/drawingml/2006/main">
               <a:ext uri="{FF2B5EF4-FFF2-40B4-BE49-F238E27FC236}">
-                <a16:creationId xmlns:a16="http://schemas.microsoft.com/office/drawing/2014/main" id="{B876F14E-AA98-4128-A466-B0F1AD3755DD}"/>
+                <a16:creationId xmlns:a16="http://schemas.microsoft.com/office/drawing/2014/main" id="{754018F2-9AF2-4830-BB6B-68DF356DCB3D}"/>
               </a:ext>
             </a:extLst>
           </p:cNvPr>
@@ -18030,7 +18354,7 @@
           <p:nvPr/>
         </p:nvPicPr>
         <p:blipFill>
-          <a:blip xmlns:r="http://schemas.openxmlformats.org/officeDocument/2006/relationships" xmlns:a="http://schemas.openxmlformats.org/drawingml/2006/main" r:embed="R3752db355202429e"/>
+          <a:blip xmlns:r="http://schemas.openxmlformats.org/officeDocument/2006/relationships" xmlns:a="http://schemas.openxmlformats.org/drawingml/2006/main" r:embed="Rbaa982961a304481"/>
           <a:stretch xmlns:a="http://schemas.openxmlformats.org/drawingml/2006/main"/>
         </p:blipFill>
         <p:spPr>
@@ -18048,7 +18372,7 @@
           <p:cNvPr id="17" name="">
             <a:extLst xmlns:a="http://schemas.openxmlformats.org/drawingml/2006/main">
               <a:ext uri="{FF2B5EF4-FFF2-40B4-BE49-F238E27FC236}">
-                <a16:creationId xmlns:a16="http://schemas.microsoft.com/office/drawing/2014/main" id="{6C7111CC-D697-42EE-970D-70C3E5B3A661}"/>
+                <a16:creationId xmlns:a16="http://schemas.microsoft.com/office/drawing/2014/main" id="{62F15BA2-C8D9-4A18-A748-F5C1F20E3A00}"/>
               </a:ext>
             </a:extLst>
           </p:cNvPr>
@@ -18203,7 +18527,7 @@
     </p:spTree>
     <p:extLst>
       <p:ext uri="{BB962C8B-B14F-4D97-AF65-F5344CB8AC3E}">
-        <p14:creationId xmlns:p14="http://schemas.microsoft.com/office/powerpoint/2010/main" val="2039765131"/>
+        <p14:creationId xmlns:p14="http://schemas.microsoft.com/office/powerpoint/2010/main" val="1392106558"/>
       </p:ext>
     </p:extLst>
   </p:cSld>
@@ -18234,7 +18558,7 @@
           <p:cNvPr id="9" name="">
             <a:extLst xmlns:a="http://schemas.openxmlformats.org/drawingml/2006/main">
               <a:ext uri="{FF2B5EF4-FFF2-40B4-BE49-F238E27FC236}">
-                <a16:creationId xmlns:a16="http://schemas.microsoft.com/office/drawing/2014/main" id="{14BDCD4B-735E-401E-B735-A3CC041FF1FC}"/>
+                <a16:creationId xmlns:a16="http://schemas.microsoft.com/office/drawing/2014/main" id="{2BBFBC78-D227-463B-B449-CB94FF3E41D5}"/>
               </a:ext>
             </a:extLst>
           </p:cNvPr>
@@ -18391,7 +18715,7 @@
           <p:cNvPr id="2" name="">
             <a:extLst xmlns:a="http://schemas.openxmlformats.org/drawingml/2006/main">
               <a:ext uri="{FF2B5EF4-FFF2-40B4-BE49-F238E27FC236}">
-                <a16:creationId xmlns:a16="http://schemas.microsoft.com/office/drawing/2014/main" id="{E62C1228-9B67-4F91-80B9-1CB48DAA7065}"/>
+                <a16:creationId xmlns:a16="http://schemas.microsoft.com/office/drawing/2014/main" id="{681CBF01-CFCC-4AB5-A1E1-EAC2603241DE}"/>
               </a:ext>
             </a:extLst>
           </p:cNvPr>
@@ -18548,7 +18872,7 @@
           <p:cNvPr id="3" name="">
             <a:extLst xmlns:a="http://schemas.openxmlformats.org/drawingml/2006/main">
               <a:ext uri="{FF2B5EF4-FFF2-40B4-BE49-F238E27FC236}">
-                <a16:creationId xmlns:a16="http://schemas.microsoft.com/office/drawing/2014/main" id="{77C1C94B-6385-4BEE-956B-4086A44A890A}"/>
+                <a16:creationId xmlns:a16="http://schemas.microsoft.com/office/drawing/2014/main" id="{B6A4AB0C-808E-4C0E-B93D-7CD8E7FD4EB5}"/>
               </a:ext>
             </a:extLst>
           </p:cNvPr>
@@ -18705,7 +19029,7 @@
           <p:cNvPr id="4" name="">
             <a:extLst xmlns:a="http://schemas.openxmlformats.org/drawingml/2006/main">
               <a:ext uri="{FF2B5EF4-FFF2-40B4-BE49-F238E27FC236}">
-                <a16:creationId xmlns:a16="http://schemas.microsoft.com/office/drawing/2014/main" id="{7416BF0F-B81C-4068-9667-93A325613D42}"/>
+                <a16:creationId xmlns:a16="http://schemas.microsoft.com/office/drawing/2014/main" id="{F309DF86-E890-4B4F-84C9-A65707D37435}"/>
               </a:ext>
             </a:extLst>
           </p:cNvPr>
@@ -18862,7 +19186,7 @@
           <p:cNvPr id="5" name="">
             <a:extLst xmlns:a="http://schemas.openxmlformats.org/drawingml/2006/main">
               <a:ext uri="{FF2B5EF4-FFF2-40B4-BE49-F238E27FC236}">
-                <a16:creationId xmlns:a16="http://schemas.microsoft.com/office/drawing/2014/main" id="{49F41FC0-4EFB-496D-8EC0-8D3032BF3494}"/>
+                <a16:creationId xmlns:a16="http://schemas.microsoft.com/office/drawing/2014/main" id="{C855D823-A554-4C1E-B9A2-E0A5D5ECB3DF}"/>
               </a:ext>
             </a:extLst>
           </p:cNvPr>
@@ -18872,7 +19196,7 @@
           <p:nvPr/>
         </p:nvPicPr>
         <p:blipFill>
-          <a:blip xmlns:r="http://schemas.openxmlformats.org/officeDocument/2006/relationships" xmlns:a="http://schemas.openxmlformats.org/drawingml/2006/main" r:embed="R7fe5d918bf8140e9"/>
+          <a:blip xmlns:r="http://schemas.openxmlformats.org/officeDocument/2006/relationships" xmlns:a="http://schemas.openxmlformats.org/drawingml/2006/main" r:embed="Rb5710d7498914ad3"/>
           <a:stretch xmlns:a="http://schemas.openxmlformats.org/drawingml/2006/main"/>
         </p:blipFill>
         <p:spPr>
@@ -18890,7 +19214,7 @@
           <p:cNvPr id="6" name="">
             <a:extLst xmlns:a="http://schemas.openxmlformats.org/drawingml/2006/main">
               <a:ext uri="{FF2B5EF4-FFF2-40B4-BE49-F238E27FC236}">
-                <a16:creationId xmlns:a16="http://schemas.microsoft.com/office/drawing/2014/main" id="{99C888EA-6696-421E-9D72-F42CB2A61893}"/>
+                <a16:creationId xmlns:a16="http://schemas.microsoft.com/office/drawing/2014/main" id="{13380C24-140A-487F-B389-BAB2291CB19D}"/>
               </a:ext>
             </a:extLst>
           </p:cNvPr>
@@ -18900,7 +19224,7 @@
           <p:nvPr/>
         </p:nvPicPr>
         <p:blipFill>
-          <a:blip xmlns:r="http://schemas.openxmlformats.org/officeDocument/2006/relationships" xmlns:a="http://schemas.openxmlformats.org/drawingml/2006/main" r:embed="Rc09b776ac5924a44"/>
+          <a:blip xmlns:r="http://schemas.openxmlformats.org/officeDocument/2006/relationships" xmlns:a="http://schemas.openxmlformats.org/drawingml/2006/main" r:embed="R4d0088472051417e"/>
           <a:stretch xmlns:a="http://schemas.openxmlformats.org/drawingml/2006/main"/>
         </p:blipFill>
         <p:spPr>
@@ -18918,7 +19242,7 @@
           <p:cNvPr id="7" name="">
             <a:extLst xmlns:a="http://schemas.openxmlformats.org/drawingml/2006/main">
               <a:ext uri="{FF2B5EF4-FFF2-40B4-BE49-F238E27FC236}">
-                <a16:creationId xmlns:a16="http://schemas.microsoft.com/office/drawing/2014/main" id="{3A352634-EE6D-4F84-9E7E-6AD103E19219}"/>
+                <a16:creationId xmlns:a16="http://schemas.microsoft.com/office/drawing/2014/main" id="{BAFAA046-24DB-46DD-8BD1-0DFC43AD0216}"/>
               </a:ext>
             </a:extLst>
           </p:cNvPr>
@@ -19075,7 +19399,7 @@
           <p:cNvPr id="8" name="">
             <a:extLst xmlns:a="http://schemas.openxmlformats.org/drawingml/2006/main">
               <a:ext uri="{FF2B5EF4-FFF2-40B4-BE49-F238E27FC236}">
-                <a16:creationId xmlns:a16="http://schemas.microsoft.com/office/drawing/2014/main" id="{746C5813-3C5B-4EBF-8068-579C911664E0}"/>
+                <a16:creationId xmlns:a16="http://schemas.microsoft.com/office/drawing/2014/main" id="{507276D6-3082-47C9-9A90-AF497BA9A24A}"/>
               </a:ext>
             </a:extLst>
           </p:cNvPr>
@@ -19230,7 +19554,7 @@
     </p:spTree>
     <p:extLst>
       <p:ext uri="{BB962C8B-B14F-4D97-AF65-F5344CB8AC3E}">
-        <p14:creationId xmlns:p14="http://schemas.microsoft.com/office/powerpoint/2010/main" val="1134335375"/>
+        <p14:creationId xmlns:p14="http://schemas.microsoft.com/office/powerpoint/2010/main" val="1066894043"/>
       </p:ext>
     </p:extLst>
   </p:cSld>
@@ -19261,7 +19585,7 @@
           <p:cNvPr id="12" name="">
             <a:extLst xmlns:a="http://schemas.openxmlformats.org/drawingml/2006/main">
               <a:ext uri="{FF2B5EF4-FFF2-40B4-BE49-F238E27FC236}">
-                <a16:creationId xmlns:a16="http://schemas.microsoft.com/office/drawing/2014/main" id="{526E3843-03EB-4860-A96D-8524814A55C4}"/>
+                <a16:creationId xmlns:a16="http://schemas.microsoft.com/office/drawing/2014/main" id="{3F3E2544-E2BD-4D7F-BB31-749FD57EB520}"/>
               </a:ext>
             </a:extLst>
           </p:cNvPr>
@@ -19418,7 +19742,7 @@
           <p:cNvPr id="2" name="">
             <a:extLst xmlns:a="http://schemas.openxmlformats.org/drawingml/2006/main">
               <a:ext uri="{FF2B5EF4-FFF2-40B4-BE49-F238E27FC236}">
-                <a16:creationId xmlns:a16="http://schemas.microsoft.com/office/drawing/2014/main" id="{6A9F2521-E400-4B78-A31A-8FDF00E5715B}"/>
+                <a16:creationId xmlns:a16="http://schemas.microsoft.com/office/drawing/2014/main" id="{82468884-93C4-4DEF-915C-BE68C543809A}"/>
               </a:ext>
             </a:extLst>
           </p:cNvPr>
@@ -19575,7 +19899,7 @@
           <p:cNvPr id="3" name="">
             <a:extLst xmlns:a="http://schemas.openxmlformats.org/drawingml/2006/main">
               <a:ext uri="{FF2B5EF4-FFF2-40B4-BE49-F238E27FC236}">
-                <a16:creationId xmlns:a16="http://schemas.microsoft.com/office/drawing/2014/main" id="{CC6FB5B7-37E2-48FC-A759-9256294242D5}"/>
+                <a16:creationId xmlns:a16="http://schemas.microsoft.com/office/drawing/2014/main" id="{63B1BF14-83AE-4867-B4BC-6B413104E6EE}"/>
               </a:ext>
             </a:extLst>
           </p:cNvPr>
@@ -19732,7 +20056,7 @@
           <p:cNvPr id="4" name="">
             <a:extLst xmlns:a="http://schemas.openxmlformats.org/drawingml/2006/main">
               <a:ext uri="{FF2B5EF4-FFF2-40B4-BE49-F238E27FC236}">
-                <a16:creationId xmlns:a16="http://schemas.microsoft.com/office/drawing/2014/main" id="{B038EAB8-0785-4B1F-B0D1-48EB143AF90F}"/>
+                <a16:creationId xmlns:a16="http://schemas.microsoft.com/office/drawing/2014/main" id="{C6ED73CD-E66F-4893-8EC2-2E382692A95A}"/>
               </a:ext>
             </a:extLst>
           </p:cNvPr>
@@ -19889,7 +20213,7 @@
           <p:cNvPr id="5" name="">
             <a:extLst xmlns:a="http://schemas.openxmlformats.org/drawingml/2006/main">
               <a:ext uri="{FF2B5EF4-FFF2-40B4-BE49-F238E27FC236}">
-                <a16:creationId xmlns:a16="http://schemas.microsoft.com/office/drawing/2014/main" id="{FCE2BD14-FF8F-455C-8AD3-BBA17120F089}"/>
+                <a16:creationId xmlns:a16="http://schemas.microsoft.com/office/drawing/2014/main" id="{2F397CC0-EF5E-40C2-947A-E6F6949ADD48}"/>
               </a:ext>
             </a:extLst>
           </p:cNvPr>
@@ -20046,7 +20370,7 @@
           <p:cNvPr id="6" name="">
             <a:extLst xmlns:a="http://schemas.openxmlformats.org/drawingml/2006/main">
               <a:ext uri="{FF2B5EF4-FFF2-40B4-BE49-F238E27FC236}">
-                <a16:creationId xmlns:a16="http://schemas.microsoft.com/office/drawing/2014/main" id="{9728739A-18DB-4FEF-8254-0AB870F01537}"/>
+                <a16:creationId xmlns:a16="http://schemas.microsoft.com/office/drawing/2014/main" id="{E3EE1829-084B-4EBE-8747-5DA5523B0F28}"/>
               </a:ext>
             </a:extLst>
           </p:cNvPr>
@@ -20203,7 +20527,7 @@
           <p:cNvPr id="7" name="">
             <a:extLst xmlns:a="http://schemas.openxmlformats.org/drawingml/2006/main">
               <a:ext uri="{FF2B5EF4-FFF2-40B4-BE49-F238E27FC236}">
-                <a16:creationId xmlns:a16="http://schemas.microsoft.com/office/drawing/2014/main" id="{297FFA34-A384-4F92-8ACE-D6087E012DB3}"/>
+                <a16:creationId xmlns:a16="http://schemas.microsoft.com/office/drawing/2014/main" id="{3AA52AE3-5661-43DC-B118-CD25F3E624F7}"/>
               </a:ext>
             </a:extLst>
           </p:cNvPr>
@@ -20360,7 +20684,7 @@
           <p:cNvPr id="8" name="">
             <a:extLst xmlns:a="http://schemas.openxmlformats.org/drawingml/2006/main">
               <a:ext uri="{FF2B5EF4-FFF2-40B4-BE49-F238E27FC236}">
-                <a16:creationId xmlns:a16="http://schemas.microsoft.com/office/drawing/2014/main" id="{BA6754C1-D363-4136-B471-B4B8B69C465A}"/>
+                <a16:creationId xmlns:a16="http://schemas.microsoft.com/office/drawing/2014/main" id="{DA5AEDD2-D2BE-4D05-A3FA-776B612FC793}"/>
               </a:ext>
             </a:extLst>
           </p:cNvPr>
@@ -20517,7 +20841,7 @@
           <p:cNvPr id="9" name="">
             <a:extLst xmlns:a="http://schemas.openxmlformats.org/drawingml/2006/main">
               <a:ext uri="{FF2B5EF4-FFF2-40B4-BE49-F238E27FC236}">
-                <a16:creationId xmlns:a16="http://schemas.microsoft.com/office/drawing/2014/main" id="{5D683B2F-4AAF-4800-BC55-8D5E103F2E18}"/>
+                <a16:creationId xmlns:a16="http://schemas.microsoft.com/office/drawing/2014/main" id="{F5E965AF-20BA-4B75-A409-1E4B56C2E285}"/>
               </a:ext>
             </a:extLst>
           </p:cNvPr>
@@ -20674,7 +20998,7 @@
           <p:cNvPr id="10" name="">
             <a:extLst xmlns:a="http://schemas.openxmlformats.org/drawingml/2006/main">
               <a:ext uri="{FF2B5EF4-FFF2-40B4-BE49-F238E27FC236}">
-                <a16:creationId xmlns:a16="http://schemas.microsoft.com/office/drawing/2014/main" id="{FA04E516-40F1-480A-B82A-3D736D58EB16}"/>
+                <a16:creationId xmlns:a16="http://schemas.microsoft.com/office/drawing/2014/main" id="{0B9641CA-B9F4-4E39-BA2F-E25D2D1C1EC0}"/>
               </a:ext>
             </a:extLst>
           </p:cNvPr>
@@ -20831,7 +21155,7 @@
           <p:cNvPr id="11" name="">
             <a:extLst xmlns:a="http://schemas.openxmlformats.org/drawingml/2006/main">
               <a:ext uri="{FF2B5EF4-FFF2-40B4-BE49-F238E27FC236}">
-                <a16:creationId xmlns:a16="http://schemas.microsoft.com/office/drawing/2014/main" id="{E90E90D5-0C77-489E-ACF8-39AACC3D02CE}"/>
+                <a16:creationId xmlns:a16="http://schemas.microsoft.com/office/drawing/2014/main" id="{1636B3A1-3706-4C72-8D5E-CA2B87AE5AE3}"/>
               </a:ext>
             </a:extLst>
           </p:cNvPr>
@@ -20841,7 +21165,7 @@
           <p:nvPr/>
         </p:nvPicPr>
         <p:blipFill>
-          <a:blip xmlns:r="http://schemas.openxmlformats.org/officeDocument/2006/relationships" xmlns:a="http://schemas.openxmlformats.org/drawingml/2006/main" r:embed="R6e0fc1ba68954c7b"/>
+          <a:blip xmlns:r="http://schemas.openxmlformats.org/officeDocument/2006/relationships" xmlns:a="http://schemas.openxmlformats.org/drawingml/2006/main" r:embed="Re694ee3e95f742fd"/>
           <a:stretch xmlns:a="http://schemas.openxmlformats.org/drawingml/2006/main"/>
         </p:blipFill>
         <p:spPr>
@@ -20857,7 +21181,7 @@
     </p:spTree>
     <p:extLst>
       <p:ext uri="{BB962C8B-B14F-4D97-AF65-F5344CB8AC3E}">
-        <p14:creationId xmlns:p14="http://schemas.microsoft.com/office/powerpoint/2010/main" val="1583150791"/>
+        <p14:creationId xmlns:p14="http://schemas.microsoft.com/office/powerpoint/2010/main" val="1808816140"/>
       </p:ext>
     </p:extLst>
   </p:cSld>
@@ -20888,7 +21212,7 @@
           <p:cNvPr id="11" name="">
             <a:extLst xmlns:a="http://schemas.openxmlformats.org/drawingml/2006/main">
               <a:ext uri="{FF2B5EF4-FFF2-40B4-BE49-F238E27FC236}">
-                <a16:creationId xmlns:a16="http://schemas.microsoft.com/office/drawing/2014/main" id="{D497F806-AC5E-418A-9C96-CE421AE8D8D3}"/>
+                <a16:creationId xmlns:a16="http://schemas.microsoft.com/office/drawing/2014/main" id="{480FB5E4-7DC1-4B01-B003-B0C8C4CA2372}"/>
               </a:ext>
             </a:extLst>
           </p:cNvPr>
@@ -21045,7 +21369,7 @@
           <p:cNvPr id="2" name="">
             <a:extLst xmlns:a="http://schemas.openxmlformats.org/drawingml/2006/main">
               <a:ext uri="{FF2B5EF4-FFF2-40B4-BE49-F238E27FC236}">
-                <a16:creationId xmlns:a16="http://schemas.microsoft.com/office/drawing/2014/main" id="{6DE9E237-BD8A-41FC-B1D0-60F19A58A318}"/>
+                <a16:creationId xmlns:a16="http://schemas.microsoft.com/office/drawing/2014/main" id="{3E6E054D-FFC3-427F-B2B9-BBBCD1F633CE}"/>
               </a:ext>
             </a:extLst>
           </p:cNvPr>
@@ -21202,7 +21526,7 @@
           <p:cNvPr id="3" name="Chart">
             <a:extLst xmlns:a="http://schemas.openxmlformats.org/drawingml/2006/main">
               <a:ext uri="{FF2B5EF4-FFF2-40B4-BE49-F238E27FC236}">
-                <a16:creationId xmlns:a16="http://schemas.microsoft.com/office/drawing/2014/main" id="{EAD755E1-3086-4399-8D8C-C79C7D89890A}"/>
+                <a16:creationId xmlns:a16="http://schemas.microsoft.com/office/drawing/2014/main" id="{95772FE4-C47A-494B-ACB0-4326733BD9FD}"/>
               </a:ext>
             </a:extLst>
           </p:cNvPr>
@@ -21215,7 +21539,7 @@
         </p:xfrm>
         <a:graphic xmlns:a="http://schemas.openxmlformats.org/drawingml/2006/main">
           <a:graphicData uri="http://schemas.openxmlformats.org/drawingml/2006/chart">
-            <c:chart xmlns:r="http://schemas.openxmlformats.org/officeDocument/2006/relationships" xmlns:c="http://schemas.openxmlformats.org/drawingml/2006/chart" r:id="R67dcf4dde7404f19"/>
+            <c:chart xmlns:r="http://schemas.openxmlformats.org/officeDocument/2006/relationships" xmlns:c="http://schemas.openxmlformats.org/drawingml/2006/chart" r:id="Rfee5a25c1ebd4dea"/>
           </a:graphicData>
         </a:graphic>
       </p:graphicFrame>
@@ -21224,7 +21548,7 @@
           <p:cNvPr id="4" name="">
             <a:extLst xmlns:a="http://schemas.openxmlformats.org/drawingml/2006/main">
               <a:ext uri="{FF2B5EF4-FFF2-40B4-BE49-F238E27FC236}">
-                <a16:creationId xmlns:a16="http://schemas.microsoft.com/office/drawing/2014/main" id="{A09D6976-A769-4372-A432-87BA92C4E37B}"/>
+                <a16:creationId xmlns:a16="http://schemas.microsoft.com/office/drawing/2014/main" id="{13D9CDF9-A96A-4BD7-AE76-B434B68EEB58}"/>
               </a:ext>
             </a:extLst>
           </p:cNvPr>
@@ -21381,7 +21705,7 @@
           <p:cNvPr id="5" name="">
             <a:extLst xmlns:a="http://schemas.openxmlformats.org/drawingml/2006/main">
               <a:ext uri="{FF2B5EF4-FFF2-40B4-BE49-F238E27FC236}">
-                <a16:creationId xmlns:a16="http://schemas.microsoft.com/office/drawing/2014/main" id="{213A654C-9724-4FEC-A12C-754F423675AE}"/>
+                <a16:creationId xmlns:a16="http://schemas.microsoft.com/office/drawing/2014/main" id="{61F14133-0457-4897-9830-9883E7D95224}"/>
               </a:ext>
             </a:extLst>
           </p:cNvPr>
@@ -21538,7 +21862,7 @@
           <p:cNvPr id="6" name="">
             <a:extLst xmlns:a="http://schemas.openxmlformats.org/drawingml/2006/main">
               <a:ext uri="{FF2B5EF4-FFF2-40B4-BE49-F238E27FC236}">
-                <a16:creationId xmlns:a16="http://schemas.microsoft.com/office/drawing/2014/main" id="{ACA984A5-6BB8-4969-AFF4-29362C7A6896}"/>
+                <a16:creationId xmlns:a16="http://schemas.microsoft.com/office/drawing/2014/main" id="{7319EC1D-FBE2-43CE-833C-63718979088C}"/>
               </a:ext>
             </a:extLst>
           </p:cNvPr>
@@ -21695,7 +22019,7 @@
           <p:cNvPr id="7" name="">
             <a:extLst xmlns:a="http://schemas.openxmlformats.org/drawingml/2006/main">
               <a:ext uri="{FF2B5EF4-FFF2-40B4-BE49-F238E27FC236}">
-                <a16:creationId xmlns:a16="http://schemas.microsoft.com/office/drawing/2014/main" id="{8CCCF373-A08E-4A7A-84F2-4D84B3CE9CBF}"/>
+                <a16:creationId xmlns:a16="http://schemas.microsoft.com/office/drawing/2014/main" id="{DCAB88CD-7CB3-4198-B185-B5BC15030329}"/>
               </a:ext>
             </a:extLst>
           </p:cNvPr>
@@ -21852,7 +22176,7 @@
           <p:cNvPr id="8" name="">
             <a:extLst xmlns:a="http://schemas.openxmlformats.org/drawingml/2006/main">
               <a:ext uri="{FF2B5EF4-FFF2-40B4-BE49-F238E27FC236}">
-                <a16:creationId xmlns:a16="http://schemas.microsoft.com/office/drawing/2014/main" id="{CDC0990E-A3C6-4B75-8407-0B199DB0DB70}"/>
+                <a16:creationId xmlns:a16="http://schemas.microsoft.com/office/drawing/2014/main" id="{17359DD6-0057-46D6-B69C-67ACB106C963}"/>
               </a:ext>
             </a:extLst>
           </p:cNvPr>
@@ -22009,7 +22333,7 @@
           <p:cNvPr id="9" name="">
             <a:extLst xmlns:a="http://schemas.openxmlformats.org/drawingml/2006/main">
               <a:ext uri="{FF2B5EF4-FFF2-40B4-BE49-F238E27FC236}">
-                <a16:creationId xmlns:a16="http://schemas.microsoft.com/office/drawing/2014/main" id="{8EBFE011-8574-4640-9E7D-3B027C901091}"/>
+                <a16:creationId xmlns:a16="http://schemas.microsoft.com/office/drawing/2014/main" id="{E87B2721-2184-46F6-82B5-F8B83B88487C}"/>
               </a:ext>
             </a:extLst>
           </p:cNvPr>
@@ -22166,7 +22490,7 @@
           <p:cNvPr id="10" name="">
             <a:extLst xmlns:a="http://schemas.openxmlformats.org/drawingml/2006/main">
               <a:ext uri="{FF2B5EF4-FFF2-40B4-BE49-F238E27FC236}">
-                <a16:creationId xmlns:a16="http://schemas.microsoft.com/office/drawing/2014/main" id="{C872DD03-EB0C-43BA-9BD0-BBED421C6F03}"/>
+                <a16:creationId xmlns:a16="http://schemas.microsoft.com/office/drawing/2014/main" id="{BC454EA5-B495-4504-B854-1C28D49A4BF5}"/>
               </a:ext>
             </a:extLst>
           </p:cNvPr>
@@ -22321,7 +22645,7 @@
     </p:spTree>
     <p:extLst>
       <p:ext uri="{BB962C8B-B14F-4D97-AF65-F5344CB8AC3E}">
-        <p14:creationId xmlns:p14="http://schemas.microsoft.com/office/powerpoint/2010/main" val="1641263607"/>
+        <p14:creationId xmlns:p14="http://schemas.microsoft.com/office/powerpoint/2010/main" val="190757822"/>
       </p:ext>
     </p:extLst>
   </p:cSld>
@@ -22352,7 +22676,7 @@
           <p:cNvPr id="13" name="">
             <a:extLst xmlns:a="http://schemas.openxmlformats.org/drawingml/2006/main">
               <a:ext uri="{FF2B5EF4-FFF2-40B4-BE49-F238E27FC236}">
-                <a16:creationId xmlns:a16="http://schemas.microsoft.com/office/drawing/2014/main" id="{1C59CD64-E5BF-442E-9EE6-BEC04C39D744}"/>
+                <a16:creationId xmlns:a16="http://schemas.microsoft.com/office/drawing/2014/main" id="{3851D21B-2FBB-4AAC-AAD7-C6B3D0D41485}"/>
               </a:ext>
             </a:extLst>
           </p:cNvPr>
@@ -22509,7 +22833,7 @@
           <p:cNvPr id="2" name="">
             <a:extLst xmlns:a="http://schemas.openxmlformats.org/drawingml/2006/main">
               <a:ext uri="{FF2B5EF4-FFF2-40B4-BE49-F238E27FC236}">
-                <a16:creationId xmlns:a16="http://schemas.microsoft.com/office/drawing/2014/main" id="{6688AD64-25B6-42E5-893C-47F7B093E63C}"/>
+                <a16:creationId xmlns:a16="http://schemas.microsoft.com/office/drawing/2014/main" id="{202EEF7C-58F3-4899-844F-367F0EDDB7F5}"/>
               </a:ext>
             </a:extLst>
           </p:cNvPr>
@@ -22666,7 +22990,7 @@
           <p:cNvPr id="3" name="">
             <a:extLst xmlns:a="http://schemas.openxmlformats.org/drawingml/2006/main">
               <a:ext uri="{FF2B5EF4-FFF2-40B4-BE49-F238E27FC236}">
-                <a16:creationId xmlns:a16="http://schemas.microsoft.com/office/drawing/2014/main" id="{7F0F3204-49E5-407D-9AF1-DC6CE34DE355}"/>
+                <a16:creationId xmlns:a16="http://schemas.microsoft.com/office/drawing/2014/main" id="{9F19F2A6-8660-40EA-BE5A-7BE8A06A9B3E}"/>
               </a:ext>
             </a:extLst>
           </p:cNvPr>
@@ -22676,7 +23000,7 @@
           <p:nvPr/>
         </p:nvPicPr>
         <p:blipFill>
-          <a:blip xmlns:r="http://schemas.openxmlformats.org/officeDocument/2006/relationships" xmlns:a="http://schemas.openxmlformats.org/drawingml/2006/main" r:embed="R8b3510db196a414e"/>
+          <a:blip xmlns:r="http://schemas.openxmlformats.org/officeDocument/2006/relationships" xmlns:a="http://schemas.openxmlformats.org/drawingml/2006/main" r:embed="R9741586573564930"/>
           <a:stretch xmlns:a="http://schemas.openxmlformats.org/drawingml/2006/main"/>
         </p:blipFill>
         <p:spPr>
@@ -22694,7 +23018,7 @@
           <p:cNvPr id="4" name="">
             <a:extLst xmlns:a="http://schemas.openxmlformats.org/drawingml/2006/main">
               <a:ext uri="{FF2B5EF4-FFF2-40B4-BE49-F238E27FC236}">
-                <a16:creationId xmlns:a16="http://schemas.microsoft.com/office/drawing/2014/main" id="{26941831-D362-4120-9DF6-BA801BB76201}"/>
+                <a16:creationId xmlns:a16="http://schemas.microsoft.com/office/drawing/2014/main" id="{6E1905AE-23D9-4A67-8384-A82710902616}"/>
               </a:ext>
             </a:extLst>
           </p:cNvPr>
@@ -22851,7 +23175,7 @@
           <p:cNvPr id="5" name="">
             <a:extLst xmlns:a="http://schemas.openxmlformats.org/drawingml/2006/main">
               <a:ext uri="{FF2B5EF4-FFF2-40B4-BE49-F238E27FC236}">
-                <a16:creationId xmlns:a16="http://schemas.microsoft.com/office/drawing/2014/main" id="{858C2F8E-3A33-4032-9089-FE7914C8096A}"/>
+                <a16:creationId xmlns:a16="http://schemas.microsoft.com/office/drawing/2014/main" id="{BC7A865E-BAEE-440F-AFE5-FC1E44A3427F}"/>
               </a:ext>
             </a:extLst>
           </p:cNvPr>
@@ -23008,7 +23332,7 @@
           <p:cNvPr id="6" name="">
             <a:extLst xmlns:a="http://schemas.openxmlformats.org/drawingml/2006/main">
               <a:ext uri="{FF2B5EF4-FFF2-40B4-BE49-F238E27FC236}">
-                <a16:creationId xmlns:a16="http://schemas.microsoft.com/office/drawing/2014/main" id="{48F3F0B5-06A4-48A0-87F8-B4038D8EDF8C}"/>
+                <a16:creationId xmlns:a16="http://schemas.microsoft.com/office/drawing/2014/main" id="{E3A95AF3-398C-4BEB-B411-5CC849081454}"/>
               </a:ext>
             </a:extLst>
           </p:cNvPr>
@@ -23165,7 +23489,7 @@
           <p:cNvPr id="7" name="">
             <a:extLst xmlns:a="http://schemas.openxmlformats.org/drawingml/2006/main">
               <a:ext uri="{FF2B5EF4-FFF2-40B4-BE49-F238E27FC236}">
-                <a16:creationId xmlns:a16="http://schemas.microsoft.com/office/drawing/2014/main" id="{2DA6CFCF-07EE-46D2-A1DB-F0938FD031F0}"/>
+                <a16:creationId xmlns:a16="http://schemas.microsoft.com/office/drawing/2014/main" id="{7169295B-810E-438A-B34B-99DDD618864D}"/>
               </a:ext>
             </a:extLst>
           </p:cNvPr>
@@ -23322,7 +23646,7 @@
           <p:cNvPr id="8" name="">
             <a:extLst xmlns:a="http://schemas.openxmlformats.org/drawingml/2006/main">
               <a:ext uri="{FF2B5EF4-FFF2-40B4-BE49-F238E27FC236}">
-                <a16:creationId xmlns:a16="http://schemas.microsoft.com/office/drawing/2014/main" id="{EDF47A0B-0730-43A5-A298-A85ADFA37E01}"/>
+                <a16:creationId xmlns:a16="http://schemas.microsoft.com/office/drawing/2014/main" id="{28C7A4D3-FF9F-4B61-9725-D27D9491FC56}"/>
               </a:ext>
             </a:extLst>
           </p:cNvPr>
@@ -23479,7 +23803,7 @@
           <p:cNvPr id="9" name="">
             <a:extLst xmlns:a="http://schemas.openxmlformats.org/drawingml/2006/main">
               <a:ext uri="{FF2B5EF4-FFF2-40B4-BE49-F238E27FC236}">
-                <a16:creationId xmlns:a16="http://schemas.microsoft.com/office/drawing/2014/main" id="{3ECF5912-697E-47BE-93E2-4C4E80BF7895}"/>
+                <a16:creationId xmlns:a16="http://schemas.microsoft.com/office/drawing/2014/main" id="{1838C458-FB11-4D18-9BC5-8835CB45FCA4}"/>
               </a:ext>
             </a:extLst>
           </p:cNvPr>
@@ -23636,7 +23960,7 @@
           <p:cNvPr id="10" name="">
             <a:extLst xmlns:a="http://schemas.openxmlformats.org/drawingml/2006/main">
               <a:ext uri="{FF2B5EF4-FFF2-40B4-BE49-F238E27FC236}">
-                <a16:creationId xmlns:a16="http://schemas.microsoft.com/office/drawing/2014/main" id="{91DD8270-D4B2-46D1-B661-82642E87A0E0}"/>
+                <a16:creationId xmlns:a16="http://schemas.microsoft.com/office/drawing/2014/main" id="{9E8F7D4C-FE9A-40A7-BFB0-08DEF1150366}"/>
               </a:ext>
             </a:extLst>
           </p:cNvPr>
@@ -23793,7 +24117,7 @@
           <p:cNvPr id="11" name="">
             <a:extLst xmlns:a="http://schemas.openxmlformats.org/drawingml/2006/main">
               <a:ext uri="{FF2B5EF4-FFF2-40B4-BE49-F238E27FC236}">
-                <a16:creationId xmlns:a16="http://schemas.microsoft.com/office/drawing/2014/main" id="{D2172781-E6DC-447A-A7C7-366059D03029}"/>
+                <a16:creationId xmlns:a16="http://schemas.microsoft.com/office/drawing/2014/main" id="{EE9932F5-D854-4FDD-864D-04DE738A8AA6}"/>
               </a:ext>
             </a:extLst>
           </p:cNvPr>
@@ -23950,7 +24274,7 @@
           <p:cNvPr id="12" name="">
             <a:extLst xmlns:a="http://schemas.openxmlformats.org/drawingml/2006/main">
               <a:ext uri="{FF2B5EF4-FFF2-40B4-BE49-F238E27FC236}">
-                <a16:creationId xmlns:a16="http://schemas.microsoft.com/office/drawing/2014/main" id="{97A1CFAC-73E3-4C29-B6FF-71845EB84C7F}"/>
+                <a16:creationId xmlns:a16="http://schemas.microsoft.com/office/drawing/2014/main" id="{2A5AD15C-519A-4CF3-95F1-1A734A90E9D5}"/>
               </a:ext>
             </a:extLst>
           </p:cNvPr>
@@ -24105,7 +24429,7 @@
     </p:spTree>
     <p:extLst>
       <p:ext uri="{BB962C8B-B14F-4D97-AF65-F5344CB8AC3E}">
-        <p14:creationId xmlns:p14="http://schemas.microsoft.com/office/powerpoint/2010/main" val="1991077777"/>
+        <p14:creationId xmlns:p14="http://schemas.microsoft.com/office/powerpoint/2010/main" val="2125136443"/>
       </p:ext>
     </p:extLst>
   </p:cSld>

</xml_diff>

<commit_message>
fija cronograma exacto de diez minutos
</commit_message>
<xml_diff>
--- a/presentation/archivos/Sign_Language_MNIST_CNN_EP2.pptx
+++ b/presentation/archivos/Sign_Language_MNIST_CNN_EP2.pptx
@@ -2,22 +2,22 @@
 <file path=ppt/presentation.xml><?xml version="1.0" encoding="utf-8"?>
 <p:presentation xmlns:p="http://schemas.openxmlformats.org/presentationml/2006/main">
   <p:sldMasterIdLst>
-    <p:sldMasterId xmlns:r="http://schemas.openxmlformats.org/officeDocument/2006/relationships" id="2147483648" r:id="R90f979c29b7d4e92"/>
+    <p:sldMasterId xmlns:r="http://schemas.openxmlformats.org/officeDocument/2006/relationships" id="2147483648" r:id="R64f2d2f8c02e4060"/>
   </p:sldMasterIdLst>
   <p:notesMasterIdLst>
-    <p:notesMasterId xmlns:r="http://schemas.openxmlformats.org/officeDocument/2006/relationships" r:id="R741a856add254dde"/>
+    <p:notesMasterId xmlns:r="http://schemas.openxmlformats.org/officeDocument/2006/relationships" r:id="R151a1f1e11324ef3"/>
   </p:notesMasterIdLst>
   <p:sldIdLst>
-    <p:sldId xmlns:r="http://schemas.openxmlformats.org/officeDocument/2006/relationships" id="256" r:id="R60a4bb9e3a9441bf"/>
-    <p:sldId xmlns:r="http://schemas.openxmlformats.org/officeDocument/2006/relationships" id="257" r:id="R8daaa208960341ac"/>
-    <p:sldId xmlns:r="http://schemas.openxmlformats.org/officeDocument/2006/relationships" id="258" r:id="R3c8281954dc0414f"/>
-    <p:sldId xmlns:r="http://schemas.openxmlformats.org/officeDocument/2006/relationships" id="259" r:id="Ra699eb8221fa443f"/>
-    <p:sldId xmlns:r="http://schemas.openxmlformats.org/officeDocument/2006/relationships" id="260" r:id="Rcddd2d9b42524157"/>
-    <p:sldId xmlns:r="http://schemas.openxmlformats.org/officeDocument/2006/relationships" id="261" r:id="R97e23080d8114ab3"/>
-    <p:sldId xmlns:r="http://schemas.openxmlformats.org/officeDocument/2006/relationships" id="262" r:id="R5152a901ed324e61"/>
-    <p:sldId xmlns:r="http://schemas.openxmlformats.org/officeDocument/2006/relationships" id="263" r:id="Re48d762f43854370"/>
-    <p:sldId xmlns:r="http://schemas.openxmlformats.org/officeDocument/2006/relationships" id="264" r:id="R25ee2e3cf1b44449"/>
-    <p:sldId xmlns:r="http://schemas.openxmlformats.org/officeDocument/2006/relationships" id="265" r:id="R6d893923f4d34fb0"/>
+    <p:sldId xmlns:r="http://schemas.openxmlformats.org/officeDocument/2006/relationships" id="256" r:id="Re9ba9e694de74744"/>
+    <p:sldId xmlns:r="http://schemas.openxmlformats.org/officeDocument/2006/relationships" id="257" r:id="R4fd5e250d2db4cd9"/>
+    <p:sldId xmlns:r="http://schemas.openxmlformats.org/officeDocument/2006/relationships" id="258" r:id="Rcc7677dbf9064f12"/>
+    <p:sldId xmlns:r="http://schemas.openxmlformats.org/officeDocument/2006/relationships" id="259" r:id="Rb73464f90ebf47a6"/>
+    <p:sldId xmlns:r="http://schemas.openxmlformats.org/officeDocument/2006/relationships" id="260" r:id="Rcf2ebd3a25ee4299"/>
+    <p:sldId xmlns:r="http://schemas.openxmlformats.org/officeDocument/2006/relationships" id="261" r:id="R923aef2d41e24268"/>
+    <p:sldId xmlns:r="http://schemas.openxmlformats.org/officeDocument/2006/relationships" id="262" r:id="R77a73ff73d244967"/>
+    <p:sldId xmlns:r="http://schemas.openxmlformats.org/officeDocument/2006/relationships" id="263" r:id="R5bf540af11604e0b"/>
+    <p:sldId xmlns:r="http://schemas.openxmlformats.org/officeDocument/2006/relationships" id="264" r:id="Rc9d87da2f7bc4409"/>
+    <p:sldId xmlns:r="http://schemas.openxmlformats.org/officeDocument/2006/relationships" id="265" r:id="R1c31e984d5ba4399"/>
   </p:sldIdLst>
   <p:sldSz cx="12192000" cy="6858000"/>
   <p:notesSz cx="6858000" cy="9144000"/>
@@ -451,7 +451,7 @@
           <a:lstStyle xmlns:a="http://schemas.openxmlformats.org/drawingml/2006/main"/>
           <a:p xmlns:a="http://schemas.openxmlformats.org/drawingml/2006/main">
             <a:r>
-              <a:t>Gonzalo. 30 segundos.</a:t>
+              <a:t>Gonzalo. 00:00-00:35 (35 segundos).</a:t>
             </a:r>
           </a:p>
           <a:p xmlns:a="http://schemas.openxmlformats.org/drawingml/2006/main">
@@ -536,7 +536,7 @@
           <a:lstStyle xmlns:a="http://schemas.openxmlformats.org/drawingml/2006/main"/>
           <a:p xmlns:a="http://schemas.openxmlformats.org/drawingml/2006/main">
             <a:r>
-              <a:t>Jason. 50 segundos.</a:t>
+              <a:t>Jason. 09:10-10:00 (50 segundos). Terminar la última frase a los 10:00.</a:t>
             </a:r>
           </a:p>
           <a:p xmlns:a="http://schemas.openxmlformats.org/drawingml/2006/main">
@@ -621,7 +621,7 @@
           <a:lstStyle xmlns:a="http://schemas.openxmlformats.org/drawingml/2006/main"/>
           <a:p xmlns:a="http://schemas.openxmlformats.org/drawingml/2006/main">
             <a:r>
-              <a:t>Gonzalo. 55 segundos.</a:t>
+              <a:t>Gonzalo. 00:35-01:30 (55 segundos).</a:t>
             </a:r>
           </a:p>
           <a:p xmlns:a="http://schemas.openxmlformats.org/drawingml/2006/main">
@@ -706,7 +706,7 @@
           <a:lstStyle xmlns:a="http://schemas.openxmlformats.org/drawingml/2006/main"/>
           <a:p xmlns:a="http://schemas.openxmlformats.org/drawingml/2006/main">
             <a:r>
-              <a:t>Gonzalo. 75 segundos.</a:t>
+              <a:t>Gonzalo. 01:30-02:30 (60 segundos). Cambio a Jenaro: 02:30-02:40.</a:t>
             </a:r>
           </a:p>
           <a:p xmlns:a="http://schemas.openxmlformats.org/drawingml/2006/main">
@@ -791,7 +791,7 @@
           <a:lstStyle xmlns:a="http://schemas.openxmlformats.org/drawingml/2006/main"/>
           <a:p xmlns:a="http://schemas.openxmlformats.org/drawingml/2006/main">
             <a:r>
-              <a:t>Jenaro. 65 segundos.</a:t>
+              <a:t>Jenaro. 02:40-03:45 (65 segundos).</a:t>
             </a:r>
           </a:p>
           <a:p xmlns:a="http://schemas.openxmlformats.org/drawingml/2006/main">
@@ -876,7 +876,7 @@
           <a:lstStyle xmlns:a="http://schemas.openxmlformats.org/drawingml/2006/main"/>
           <a:p xmlns:a="http://schemas.openxmlformats.org/drawingml/2006/main">
             <a:r>
-              <a:t>Jenaro. 60 segundos.</a:t>
+              <a:t>Jenaro. 03:45-04:50 (65 segundos).</a:t>
             </a:r>
           </a:p>
           <a:p xmlns:a="http://schemas.openxmlformats.org/drawingml/2006/main">
@@ -961,7 +961,7 @@
           <a:lstStyle xmlns:a="http://schemas.openxmlformats.org/drawingml/2006/main"/>
           <a:p xmlns:a="http://schemas.openxmlformats.org/drawingml/2006/main">
             <a:r>
-              <a:t>Jenaro. 60 segundos.</a:t>
+              <a:t>Jenaro. 04:50-05:50 (60 segundos). Cambio a Jason: 05:50-06:00.</a:t>
             </a:r>
           </a:p>
           <a:p xmlns:a="http://schemas.openxmlformats.org/drawingml/2006/main">
@@ -1046,7 +1046,7 @@
           <a:lstStyle xmlns:a="http://schemas.openxmlformats.org/drawingml/2006/main"/>
           <a:p xmlns:a="http://schemas.openxmlformats.org/drawingml/2006/main">
             <a:r>
-              <a:t>Jason. 60 segundos.</a:t>
+              <a:t>Jason. 06:00-07:00 (60 segundos).</a:t>
             </a:r>
           </a:p>
           <a:p xmlns:a="http://schemas.openxmlformats.org/drawingml/2006/main">
@@ -1131,7 +1131,7 @@
           <a:lstStyle xmlns:a="http://schemas.openxmlformats.org/drawingml/2006/main"/>
           <a:p xmlns:a="http://schemas.openxmlformats.org/drawingml/2006/main">
             <a:r>
-              <a:t>Jason. 75 segundos.</a:t>
+              <a:t>Jason. 07:00-08:15 (75 segundos).</a:t>
             </a:r>
           </a:p>
           <a:p xmlns:a="http://schemas.openxmlformats.org/drawingml/2006/main">
@@ -1216,7 +1216,7 @@
           <a:lstStyle xmlns:a="http://schemas.openxmlformats.org/drawingml/2006/main"/>
           <a:p xmlns:a="http://schemas.openxmlformats.org/drawingml/2006/main">
             <a:r>
-              <a:t>Jason. 60 segundos.</a:t>
+              <a:t>Jason. 08:15-09:10 (55 segundos).</a:t>
             </a:r>
           </a:p>
           <a:p xmlns:a="http://schemas.openxmlformats.org/drawingml/2006/main">
@@ -1278,7 +1278,7 @@
           <p:cNvPr id="3" name="Title">
             <a:extLst xmlns:a="http://schemas.openxmlformats.org/drawingml/2006/main">
               <a:ext uri="{FF2B5EF4-FFF2-40B4-BE49-F238E27FC236}">
-                <a16:creationId xmlns:a16="http://schemas.microsoft.com/office/drawing/2014/main" id="{73D43AD6-F5F8-4B65-A409-164C0705205F}"/>
+                <a16:creationId xmlns:a16="http://schemas.microsoft.com/office/drawing/2014/main" id="{AED2E35F-A5AE-434E-A12F-02AAB48526BF}"/>
               </a:ext>
             </a:extLst>
           </p:cNvPr>
@@ -1507,7 +1507,7 @@
           <p:cNvPr id="2" name="Subtitle">
             <a:extLst xmlns:a="http://schemas.openxmlformats.org/drawingml/2006/main">
               <a:ext uri="{FF2B5EF4-FFF2-40B4-BE49-F238E27FC236}">
-                <a16:creationId xmlns:a16="http://schemas.microsoft.com/office/drawing/2014/main" id="{618B1D9A-16D7-46F4-81BA-C12001922008}"/>
+                <a16:creationId xmlns:a16="http://schemas.microsoft.com/office/drawing/2014/main" id="{1CA67E81-E854-493C-B437-252FA1DA3762}"/>
               </a:ext>
             </a:extLst>
           </p:cNvPr>
@@ -1753,7 +1753,7 @@
           <p:cNvPr id="2" name="Section title">
             <a:extLst xmlns:a="http://schemas.openxmlformats.org/drawingml/2006/main">
               <a:ext uri="{FF2B5EF4-FFF2-40B4-BE49-F238E27FC236}">
-                <a16:creationId xmlns:a16="http://schemas.microsoft.com/office/drawing/2014/main" id="{705822C6-50C0-458F-8E23-5FF6398986C9}"/>
+                <a16:creationId xmlns:a16="http://schemas.microsoft.com/office/drawing/2014/main" id="{35CDDC2F-5079-47C5-8F08-FB32EC8E95B8}"/>
               </a:ext>
             </a:extLst>
           </p:cNvPr>
@@ -1999,7 +1999,7 @@
           <p:cNvPr id="3" name="Title">
             <a:extLst xmlns:a="http://schemas.openxmlformats.org/drawingml/2006/main">
               <a:ext uri="{FF2B5EF4-FFF2-40B4-BE49-F238E27FC236}">
-                <a16:creationId xmlns:a16="http://schemas.microsoft.com/office/drawing/2014/main" id="{44ABDE50-7014-4AE1-AC4D-19AE36946870}"/>
+                <a16:creationId xmlns:a16="http://schemas.microsoft.com/office/drawing/2014/main" id="{ECAD0534-871B-4A59-80D8-6FEEC95A0F7B}"/>
               </a:ext>
             </a:extLst>
           </p:cNvPr>
@@ -2228,7 +2228,7 @@
           <p:cNvPr id="2" name="Body">
             <a:extLst xmlns:a="http://schemas.openxmlformats.org/drawingml/2006/main">
               <a:ext uri="{FF2B5EF4-FFF2-40B4-BE49-F238E27FC236}">
-                <a16:creationId xmlns:a16="http://schemas.microsoft.com/office/drawing/2014/main" id="{C25CDDEB-091E-4D44-B821-F08F7CA13FE2}"/>
+                <a16:creationId xmlns:a16="http://schemas.microsoft.com/office/drawing/2014/main" id="{C0506865-9E7D-460C-AB71-3ABD3B1140A9}"/>
               </a:ext>
             </a:extLst>
           </p:cNvPr>
@@ -2474,7 +2474,7 @@
           <p:cNvPr id="4" name="Title">
             <a:extLst xmlns:a="http://schemas.openxmlformats.org/drawingml/2006/main">
               <a:ext uri="{FF2B5EF4-FFF2-40B4-BE49-F238E27FC236}">
-                <a16:creationId xmlns:a16="http://schemas.microsoft.com/office/drawing/2014/main" id="{E443357B-CC19-4452-85D5-4B66BCF50769}"/>
+                <a16:creationId xmlns:a16="http://schemas.microsoft.com/office/drawing/2014/main" id="{048D9C75-1046-4CE5-8497-817EF267BC1D}"/>
               </a:ext>
             </a:extLst>
           </p:cNvPr>
@@ -2703,7 +2703,7 @@
           <p:cNvPr id="2" name="Left column">
             <a:extLst xmlns:a="http://schemas.openxmlformats.org/drawingml/2006/main">
               <a:ext uri="{FF2B5EF4-FFF2-40B4-BE49-F238E27FC236}">
-                <a16:creationId xmlns:a16="http://schemas.microsoft.com/office/drawing/2014/main" id="{0C636B71-192B-4CE8-BB9B-05D28D659E29}"/>
+                <a16:creationId xmlns:a16="http://schemas.microsoft.com/office/drawing/2014/main" id="{5C8E08D7-27DF-4F44-A0F2-4566797FD54C}"/>
               </a:ext>
             </a:extLst>
           </p:cNvPr>
@@ -2932,7 +2932,7 @@
           <p:cNvPr id="3" name="Right column">
             <a:extLst xmlns:a="http://schemas.openxmlformats.org/drawingml/2006/main">
               <a:ext uri="{FF2B5EF4-FFF2-40B4-BE49-F238E27FC236}">
-                <a16:creationId xmlns:a16="http://schemas.microsoft.com/office/drawing/2014/main" id="{80F44569-F286-4ED3-BACD-31D9B99C6F54}"/>
+                <a16:creationId xmlns:a16="http://schemas.microsoft.com/office/drawing/2014/main" id="{00173CFE-12CA-4548-9152-B640ED47D1F1}"/>
               </a:ext>
             </a:extLst>
           </p:cNvPr>
@@ -3178,7 +3178,7 @@
           <p:cNvPr id="3" name="Title">
             <a:extLst xmlns:a="http://schemas.openxmlformats.org/drawingml/2006/main">
               <a:ext uri="{FF2B5EF4-FFF2-40B4-BE49-F238E27FC236}">
-                <a16:creationId xmlns:a16="http://schemas.microsoft.com/office/drawing/2014/main" id="{C8D62547-AFCE-4301-BA62-08B153AD7B72}"/>
+                <a16:creationId xmlns:a16="http://schemas.microsoft.com/office/drawing/2014/main" id="{4C957040-FF61-4736-88E5-1B460D4E0286}"/>
               </a:ext>
             </a:extLst>
           </p:cNvPr>
@@ -3407,7 +3407,7 @@
           <p:cNvPr id="2" name="Left column">
             <a:extLst xmlns:a="http://schemas.openxmlformats.org/drawingml/2006/main">
               <a:ext uri="{FF2B5EF4-FFF2-40B4-BE49-F238E27FC236}">
-                <a16:creationId xmlns:a16="http://schemas.microsoft.com/office/drawing/2014/main" id="{77F9E21A-9C68-4176-AB65-47EF295EE01B}"/>
+                <a16:creationId xmlns:a16="http://schemas.microsoft.com/office/drawing/2014/main" id="{EFB58E13-99CA-4EF8-ABE8-67EEB4C24E37}"/>
               </a:ext>
             </a:extLst>
           </p:cNvPr>
@@ -3674,12 +3674,12 @@
   </p:cSld>
   <p:clrMap bg1="lt1" tx1="dk1" bg2="lt2" tx2="dk2" accent1="accent1" accent2="accent2" accent3="accent3" accent4="accent4" accent5="accent5" accent6="accent6" hlink="hlink" folHlink="folHlink"/>
   <p:sldLayoutIdLst>
-    <p:sldLayoutId xmlns:r="http://schemas.openxmlformats.org/officeDocument/2006/relationships" id="2147483649" r:id="Rc329850a4720445e"/>
-    <p:sldLayoutId xmlns:r="http://schemas.openxmlformats.org/officeDocument/2006/relationships" id="2147483650" r:id="R9537d23e761b4bda"/>
-    <p:sldLayoutId xmlns:r="http://schemas.openxmlformats.org/officeDocument/2006/relationships" id="2147483651" r:id="R19e835686b3f4e36"/>
-    <p:sldLayoutId xmlns:r="http://schemas.openxmlformats.org/officeDocument/2006/relationships" id="2147483652" r:id="R7e9ae8918fd24bd4"/>
-    <p:sldLayoutId xmlns:r="http://schemas.openxmlformats.org/officeDocument/2006/relationships" id="2147483653" r:id="R93f53d45171445b9"/>
-    <p:sldLayoutId xmlns:r="http://schemas.openxmlformats.org/officeDocument/2006/relationships" id="2147483654" r:id="R34b12a2e1a984aad"/>
+    <p:sldLayoutId xmlns:r="http://schemas.openxmlformats.org/officeDocument/2006/relationships" id="2147483649" r:id="Rfdb9852fd91f4415"/>
+    <p:sldLayoutId xmlns:r="http://schemas.openxmlformats.org/officeDocument/2006/relationships" id="2147483650" r:id="Rcb0a469b65284736"/>
+    <p:sldLayoutId xmlns:r="http://schemas.openxmlformats.org/officeDocument/2006/relationships" id="2147483651" r:id="R2da5889ad3824dce"/>
+    <p:sldLayoutId xmlns:r="http://schemas.openxmlformats.org/officeDocument/2006/relationships" id="2147483652" r:id="R9ddac537471147dd"/>
+    <p:sldLayoutId xmlns:r="http://schemas.openxmlformats.org/officeDocument/2006/relationships" id="2147483653" r:id="R675aeb810c8d415f"/>
+    <p:sldLayoutId xmlns:r="http://schemas.openxmlformats.org/officeDocument/2006/relationships" id="2147483654" r:id="R1e0a665965f6436d"/>
   </p:sldLayoutIdLst>
   <p:txStyles>
     <p:titleStyle>
@@ -4487,7 +4487,7 @@
           <p:cNvPr id="6" name="">
             <a:extLst xmlns:a="http://schemas.openxmlformats.org/drawingml/2006/main">
               <a:ext uri="{FF2B5EF4-FFF2-40B4-BE49-F238E27FC236}">
-                <a16:creationId xmlns:a16="http://schemas.microsoft.com/office/drawing/2014/main" id="{BFAB79D3-46A7-4721-96B0-B6435D6E429A}"/>
+                <a16:creationId xmlns:a16="http://schemas.microsoft.com/office/drawing/2014/main" id="{4B02B94E-5B97-4B79-BC6C-F7A585C876EE}"/>
               </a:ext>
             </a:extLst>
           </p:cNvPr>
@@ -4667,7 +4667,7 @@
           <p:cNvPr id="2" name="">
             <a:extLst xmlns:a="http://schemas.openxmlformats.org/drawingml/2006/main">
               <a:ext uri="{FF2B5EF4-FFF2-40B4-BE49-F238E27FC236}">
-                <a16:creationId xmlns:a16="http://schemas.microsoft.com/office/drawing/2014/main" id="{BA559C2C-5153-49BC-9DE8-DD804E9564D0}"/>
+                <a16:creationId xmlns:a16="http://schemas.microsoft.com/office/drawing/2014/main" id="{0B41E4D0-99C1-45C3-A8AA-C82C04AC6396}"/>
               </a:ext>
             </a:extLst>
           </p:cNvPr>
@@ -4824,7 +4824,7 @@
           <p:cNvPr id="3" name="">
             <a:extLst xmlns:a="http://schemas.openxmlformats.org/drawingml/2006/main">
               <a:ext uri="{FF2B5EF4-FFF2-40B4-BE49-F238E27FC236}">
-                <a16:creationId xmlns:a16="http://schemas.microsoft.com/office/drawing/2014/main" id="{71C709C3-7D58-4F09-975B-55C330F8D60B}"/>
+                <a16:creationId xmlns:a16="http://schemas.microsoft.com/office/drawing/2014/main" id="{F557FC91-6367-4B8C-9619-043CF73BA1C9}"/>
               </a:ext>
             </a:extLst>
           </p:cNvPr>
@@ -4981,7 +4981,7 @@
           <p:cNvPr id="4" name="">
             <a:extLst xmlns:a="http://schemas.openxmlformats.org/drawingml/2006/main">
               <a:ext uri="{FF2B5EF4-FFF2-40B4-BE49-F238E27FC236}">
-                <a16:creationId xmlns:a16="http://schemas.microsoft.com/office/drawing/2014/main" id="{7C38D848-FF71-4C44-945A-B2976EA0DE28}"/>
+                <a16:creationId xmlns:a16="http://schemas.microsoft.com/office/drawing/2014/main" id="{1253FD5B-EFF5-4536-882D-A92E89103DB1}"/>
               </a:ext>
             </a:extLst>
           </p:cNvPr>
@@ -5161,7 +5161,7 @@
           <p:cNvPr id="5" name="">
             <a:extLst xmlns:a="http://schemas.openxmlformats.org/drawingml/2006/main">
               <a:ext uri="{FF2B5EF4-FFF2-40B4-BE49-F238E27FC236}">
-                <a16:creationId xmlns:a16="http://schemas.microsoft.com/office/drawing/2014/main" id="{4D46B760-F9BD-4FF1-AA46-F0BF0DC3CAEC}"/>
+                <a16:creationId xmlns:a16="http://schemas.microsoft.com/office/drawing/2014/main" id="{A77D31E8-34BC-4458-B73A-C164A3A65E04}"/>
               </a:ext>
             </a:extLst>
           </p:cNvPr>
@@ -5171,7 +5171,7 @@
           <p:nvPr/>
         </p:nvPicPr>
         <p:blipFill>
-          <a:blip xmlns:r="http://schemas.openxmlformats.org/officeDocument/2006/relationships" xmlns:a="http://schemas.openxmlformats.org/drawingml/2006/main" r:embed="R3772c06fdd0e4774"/>
+          <a:blip xmlns:r="http://schemas.openxmlformats.org/officeDocument/2006/relationships" xmlns:a="http://schemas.openxmlformats.org/drawingml/2006/main" r:embed="R7704821f73154d67"/>
           <a:stretch xmlns:a="http://schemas.openxmlformats.org/drawingml/2006/main"/>
         </p:blipFill>
         <p:spPr>
@@ -5187,7 +5187,7 @@
     </p:spTree>
     <p:extLst>
       <p:ext uri="{BB962C8B-B14F-4D97-AF65-F5344CB8AC3E}">
-        <p14:creationId xmlns:p14="http://schemas.microsoft.com/office/powerpoint/2010/main" val="807841116"/>
+        <p14:creationId xmlns:p14="http://schemas.microsoft.com/office/powerpoint/2010/main" val="1991988616"/>
       </p:ext>
     </p:extLst>
   </p:cSld>
@@ -5218,7 +5218,7 @@
           <p:cNvPr id="12" name="">
             <a:extLst xmlns:a="http://schemas.openxmlformats.org/drawingml/2006/main">
               <a:ext uri="{FF2B5EF4-FFF2-40B4-BE49-F238E27FC236}">
-                <a16:creationId xmlns:a16="http://schemas.microsoft.com/office/drawing/2014/main" id="{1A5E7B50-9759-4DC8-B258-90E47128F320}"/>
+                <a16:creationId xmlns:a16="http://schemas.microsoft.com/office/drawing/2014/main" id="{D2A7E75E-292A-4649-883B-AEC4FE54CE7C}"/>
               </a:ext>
             </a:extLst>
           </p:cNvPr>
@@ -5375,7 +5375,7 @@
           <p:cNvPr id="2" name="">
             <a:extLst xmlns:a="http://schemas.openxmlformats.org/drawingml/2006/main">
               <a:ext uri="{FF2B5EF4-FFF2-40B4-BE49-F238E27FC236}">
-                <a16:creationId xmlns:a16="http://schemas.microsoft.com/office/drawing/2014/main" id="{FB2D3488-F602-4C92-BA7D-0D0C213BCCC7}"/>
+                <a16:creationId xmlns:a16="http://schemas.microsoft.com/office/drawing/2014/main" id="{833EFB81-2619-462A-B745-C100F2CBAD95}"/>
               </a:ext>
             </a:extLst>
           </p:cNvPr>
@@ -5532,7 +5532,7 @@
           <p:cNvPr id="3" name="">
             <a:extLst xmlns:a="http://schemas.openxmlformats.org/drawingml/2006/main">
               <a:ext uri="{FF2B5EF4-FFF2-40B4-BE49-F238E27FC236}">
-                <a16:creationId xmlns:a16="http://schemas.microsoft.com/office/drawing/2014/main" id="{158B07D6-5EF0-42D6-8943-29DA9943B37F}"/>
+                <a16:creationId xmlns:a16="http://schemas.microsoft.com/office/drawing/2014/main" id="{56772341-9C3C-41D8-B454-8AA73034B547}"/>
               </a:ext>
             </a:extLst>
           </p:cNvPr>
@@ -5689,7 +5689,7 @@
           <p:cNvPr id="4" name="">
             <a:extLst xmlns:a="http://schemas.openxmlformats.org/drawingml/2006/main">
               <a:ext uri="{FF2B5EF4-FFF2-40B4-BE49-F238E27FC236}">
-                <a16:creationId xmlns:a16="http://schemas.microsoft.com/office/drawing/2014/main" id="{CAC77E63-2DD7-44D7-9EF9-9E53F929600C}"/>
+                <a16:creationId xmlns:a16="http://schemas.microsoft.com/office/drawing/2014/main" id="{30E16E37-4587-4CC2-BACB-DFEBF11EDC74}"/>
               </a:ext>
             </a:extLst>
           </p:cNvPr>
@@ -5846,7 +5846,7 @@
           <p:cNvPr id="5" name="">
             <a:extLst xmlns:a="http://schemas.openxmlformats.org/drawingml/2006/main">
               <a:ext uri="{FF2B5EF4-FFF2-40B4-BE49-F238E27FC236}">
-                <a16:creationId xmlns:a16="http://schemas.microsoft.com/office/drawing/2014/main" id="{EA4A9F26-AD39-4A0D-A854-B81ED4E7DC97}"/>
+                <a16:creationId xmlns:a16="http://schemas.microsoft.com/office/drawing/2014/main" id="{03227325-834B-49AC-9CAF-02C30A15A8D6}"/>
               </a:ext>
             </a:extLst>
           </p:cNvPr>
@@ -6003,7 +6003,7 @@
           <p:cNvPr id="6" name="">
             <a:extLst xmlns:a="http://schemas.openxmlformats.org/drawingml/2006/main">
               <a:ext uri="{FF2B5EF4-FFF2-40B4-BE49-F238E27FC236}">
-                <a16:creationId xmlns:a16="http://schemas.microsoft.com/office/drawing/2014/main" id="{A4179F7C-473A-4BF9-B9E6-6B70E7803D0A}"/>
+                <a16:creationId xmlns:a16="http://schemas.microsoft.com/office/drawing/2014/main" id="{42E0429F-8701-4EB8-8AF1-67D8011A9AA2}"/>
               </a:ext>
             </a:extLst>
           </p:cNvPr>
@@ -6160,7 +6160,7 @@
           <p:cNvPr id="7" name="">
             <a:extLst xmlns:a="http://schemas.openxmlformats.org/drawingml/2006/main">
               <a:ext uri="{FF2B5EF4-FFF2-40B4-BE49-F238E27FC236}">
-                <a16:creationId xmlns:a16="http://schemas.microsoft.com/office/drawing/2014/main" id="{CB418C18-1AE5-4827-9ABF-FC2F3A46AC56}"/>
+                <a16:creationId xmlns:a16="http://schemas.microsoft.com/office/drawing/2014/main" id="{F3A41523-292B-47E2-B5D6-66EAFBAB8645}"/>
               </a:ext>
             </a:extLst>
           </p:cNvPr>
@@ -6317,7 +6317,7 @@
           <p:cNvPr id="8" name="">
             <a:extLst xmlns:a="http://schemas.openxmlformats.org/drawingml/2006/main">
               <a:ext uri="{FF2B5EF4-FFF2-40B4-BE49-F238E27FC236}">
-                <a16:creationId xmlns:a16="http://schemas.microsoft.com/office/drawing/2014/main" id="{62D30A11-48B4-4E71-A3BC-03EA66105172}"/>
+                <a16:creationId xmlns:a16="http://schemas.microsoft.com/office/drawing/2014/main" id="{B267C934-4C3F-46B2-8B47-F601460BF466}"/>
               </a:ext>
             </a:extLst>
           </p:cNvPr>
@@ -6474,7 +6474,7 @@
           <p:cNvPr id="9" name="">
             <a:extLst xmlns:a="http://schemas.openxmlformats.org/drawingml/2006/main">
               <a:ext uri="{FF2B5EF4-FFF2-40B4-BE49-F238E27FC236}">
-                <a16:creationId xmlns:a16="http://schemas.microsoft.com/office/drawing/2014/main" id="{D482CB0C-E667-420D-92EB-8D1F92716E2B}"/>
+                <a16:creationId xmlns:a16="http://schemas.microsoft.com/office/drawing/2014/main" id="{24919573-F7CD-4423-AF7A-1EFB3942F4F3}"/>
               </a:ext>
             </a:extLst>
           </p:cNvPr>
@@ -6631,7 +6631,7 @@
           <p:cNvPr id="10" name="">
             <a:extLst xmlns:a="http://schemas.openxmlformats.org/drawingml/2006/main">
               <a:ext uri="{FF2B5EF4-FFF2-40B4-BE49-F238E27FC236}">
-                <a16:creationId xmlns:a16="http://schemas.microsoft.com/office/drawing/2014/main" id="{28240B3E-E583-43BA-A579-E21C69031ADE}"/>
+                <a16:creationId xmlns:a16="http://schemas.microsoft.com/office/drawing/2014/main" id="{CB9A9202-B7DC-4566-8E7F-9F4B927592FF}"/>
               </a:ext>
             </a:extLst>
           </p:cNvPr>
@@ -6788,7 +6788,7 @@
           <p:cNvPr id="11" name="">
             <a:extLst xmlns:a="http://schemas.openxmlformats.org/drawingml/2006/main">
               <a:ext uri="{FF2B5EF4-FFF2-40B4-BE49-F238E27FC236}">
-                <a16:creationId xmlns:a16="http://schemas.microsoft.com/office/drawing/2014/main" id="{BF51E7C5-B97B-4FB9-A78D-8BBE094C4E93}"/>
+                <a16:creationId xmlns:a16="http://schemas.microsoft.com/office/drawing/2014/main" id="{3941627F-5949-469F-9A02-A7ED4D13B2A7}"/>
               </a:ext>
             </a:extLst>
           </p:cNvPr>
@@ -6943,7 +6943,7 @@
     </p:spTree>
     <p:extLst>
       <p:ext uri="{BB962C8B-B14F-4D97-AF65-F5344CB8AC3E}">
-        <p14:creationId xmlns:p14="http://schemas.microsoft.com/office/powerpoint/2010/main" val="1237155959"/>
+        <p14:creationId xmlns:p14="http://schemas.microsoft.com/office/powerpoint/2010/main" val="1708830013"/>
       </p:ext>
     </p:extLst>
   </p:cSld>
@@ -6974,7 +6974,7 @@
           <p:cNvPr id="16" name="">
             <a:extLst xmlns:a="http://schemas.openxmlformats.org/drawingml/2006/main">
               <a:ext uri="{FF2B5EF4-FFF2-40B4-BE49-F238E27FC236}">
-                <a16:creationId xmlns:a16="http://schemas.microsoft.com/office/drawing/2014/main" id="{AFF56531-D9AA-4340-9F15-3D49661A2B28}"/>
+                <a16:creationId xmlns:a16="http://schemas.microsoft.com/office/drawing/2014/main" id="{AD064196-99D9-4C08-93A3-9AC78382D4E1}"/>
               </a:ext>
             </a:extLst>
           </p:cNvPr>
@@ -7131,7 +7131,7 @@
           <p:cNvPr id="2" name="">
             <a:extLst xmlns:a="http://schemas.openxmlformats.org/drawingml/2006/main">
               <a:ext uri="{FF2B5EF4-FFF2-40B4-BE49-F238E27FC236}">
-                <a16:creationId xmlns:a16="http://schemas.microsoft.com/office/drawing/2014/main" id="{E474FA56-60C9-46E8-874B-EC348ABDD1CC}"/>
+                <a16:creationId xmlns:a16="http://schemas.microsoft.com/office/drawing/2014/main" id="{076A6009-2E2C-4D59-9C5B-9ECFA9BF875C}"/>
               </a:ext>
             </a:extLst>
           </p:cNvPr>
@@ -7288,7 +7288,7 @@
           <p:cNvPr id="3" name="">
             <a:extLst xmlns:a="http://schemas.openxmlformats.org/drawingml/2006/main">
               <a:ext uri="{FF2B5EF4-FFF2-40B4-BE49-F238E27FC236}">
-                <a16:creationId xmlns:a16="http://schemas.microsoft.com/office/drawing/2014/main" id="{F11BE22D-E703-438C-B36F-5AA1348930F4}"/>
+                <a16:creationId xmlns:a16="http://schemas.microsoft.com/office/drawing/2014/main" id="{B2FB71AE-AF9A-4A82-B560-A77191C47616}"/>
               </a:ext>
             </a:extLst>
           </p:cNvPr>
@@ -7323,7 +7323,7 @@
           <p:cNvPr id="4" name="">
             <a:extLst xmlns:a="http://schemas.openxmlformats.org/drawingml/2006/main">
               <a:ext uri="{FF2B5EF4-FFF2-40B4-BE49-F238E27FC236}">
-                <a16:creationId xmlns:a16="http://schemas.microsoft.com/office/drawing/2014/main" id="{E21CC061-17B1-4C00-AFC9-90BE70DA6AB2}"/>
+                <a16:creationId xmlns:a16="http://schemas.microsoft.com/office/drawing/2014/main" id="{1CC72931-D10C-4EC1-854A-BF637B72AEE6}"/>
               </a:ext>
             </a:extLst>
           </p:cNvPr>
@@ -7480,7 +7480,7 @@
           <p:cNvPr id="5" name="">
             <a:extLst xmlns:a="http://schemas.openxmlformats.org/drawingml/2006/main">
               <a:ext uri="{FF2B5EF4-FFF2-40B4-BE49-F238E27FC236}">
-                <a16:creationId xmlns:a16="http://schemas.microsoft.com/office/drawing/2014/main" id="{C9763FD7-FF05-4A3E-A421-98A09547D320}"/>
+                <a16:creationId xmlns:a16="http://schemas.microsoft.com/office/drawing/2014/main" id="{C7121106-3F89-4EF3-8484-9F005C791C02}"/>
               </a:ext>
             </a:extLst>
           </p:cNvPr>
@@ -7683,7 +7683,7 @@
           <p:cNvPr id="6" name="">
             <a:extLst xmlns:a="http://schemas.openxmlformats.org/drawingml/2006/main">
               <a:ext uri="{FF2B5EF4-FFF2-40B4-BE49-F238E27FC236}">
-                <a16:creationId xmlns:a16="http://schemas.microsoft.com/office/drawing/2014/main" id="{F2143735-1CBE-446B-8A11-7D52A61F13F5}"/>
+                <a16:creationId xmlns:a16="http://schemas.microsoft.com/office/drawing/2014/main" id="{F0C9704C-5406-442E-9E83-CCBAA1B0B3F6}"/>
               </a:ext>
             </a:extLst>
           </p:cNvPr>
@@ -7716,7 +7716,7 @@
           <p:cNvPr id="7" name="">
             <a:extLst xmlns:a="http://schemas.openxmlformats.org/drawingml/2006/main">
               <a:ext uri="{FF2B5EF4-FFF2-40B4-BE49-F238E27FC236}">
-                <a16:creationId xmlns:a16="http://schemas.microsoft.com/office/drawing/2014/main" id="{AD1181C5-1031-4728-B9A2-B76343C3186A}"/>
+                <a16:creationId xmlns:a16="http://schemas.microsoft.com/office/drawing/2014/main" id="{E058FD46-ED79-4365-ACEF-5AE271CB04B1}"/>
               </a:ext>
             </a:extLst>
           </p:cNvPr>
@@ -7873,7 +7873,7 @@
           <p:cNvPr id="8" name="">
             <a:extLst xmlns:a="http://schemas.openxmlformats.org/drawingml/2006/main">
               <a:ext uri="{FF2B5EF4-FFF2-40B4-BE49-F238E27FC236}">
-                <a16:creationId xmlns:a16="http://schemas.microsoft.com/office/drawing/2014/main" id="{6C69CCC7-10D9-42AD-B0FE-57C2C7712D66}"/>
+                <a16:creationId xmlns:a16="http://schemas.microsoft.com/office/drawing/2014/main" id="{9A1DA899-EDFF-418F-A1F9-CCC71C1B059F}"/>
               </a:ext>
             </a:extLst>
           </p:cNvPr>
@@ -7908,7 +7908,7 @@
           <p:cNvPr id="9" name="">
             <a:extLst xmlns:a="http://schemas.openxmlformats.org/drawingml/2006/main">
               <a:ext uri="{FF2B5EF4-FFF2-40B4-BE49-F238E27FC236}">
-                <a16:creationId xmlns:a16="http://schemas.microsoft.com/office/drawing/2014/main" id="{7C818D29-82F9-4B84-AFB4-1C8544B90283}"/>
+                <a16:creationId xmlns:a16="http://schemas.microsoft.com/office/drawing/2014/main" id="{D1206335-DE97-4F44-B41A-CDFBC14F19D1}"/>
               </a:ext>
             </a:extLst>
           </p:cNvPr>
@@ -8065,7 +8065,7 @@
           <p:cNvPr id="10" name="">
             <a:extLst xmlns:a="http://schemas.openxmlformats.org/drawingml/2006/main">
               <a:ext uri="{FF2B5EF4-FFF2-40B4-BE49-F238E27FC236}">
-                <a16:creationId xmlns:a16="http://schemas.microsoft.com/office/drawing/2014/main" id="{02A33488-27D6-4826-97E4-89666FCB8931}"/>
+                <a16:creationId xmlns:a16="http://schemas.microsoft.com/office/drawing/2014/main" id="{ABBFADC5-D147-4643-AA65-98A584CD11B6}"/>
               </a:ext>
             </a:extLst>
           </p:cNvPr>
@@ -8268,7 +8268,7 @@
           <p:cNvPr id="11" name="">
             <a:extLst xmlns:a="http://schemas.openxmlformats.org/drawingml/2006/main">
               <a:ext uri="{FF2B5EF4-FFF2-40B4-BE49-F238E27FC236}">
-                <a16:creationId xmlns:a16="http://schemas.microsoft.com/office/drawing/2014/main" id="{291EB380-D2C1-44BD-990C-A1C1F0B417B3}"/>
+                <a16:creationId xmlns:a16="http://schemas.microsoft.com/office/drawing/2014/main" id="{EEB365A8-6109-45F2-A229-C1A3E564FAC5}"/>
               </a:ext>
             </a:extLst>
           </p:cNvPr>
@@ -8425,7 +8425,7 @@
           <p:cNvPr id="12" name="">
             <a:extLst xmlns:a="http://schemas.openxmlformats.org/drawingml/2006/main">
               <a:ext uri="{FF2B5EF4-FFF2-40B4-BE49-F238E27FC236}">
-                <a16:creationId xmlns:a16="http://schemas.microsoft.com/office/drawing/2014/main" id="{606484A0-8804-4CE6-B0B3-0822B780180B}"/>
+                <a16:creationId xmlns:a16="http://schemas.microsoft.com/office/drawing/2014/main" id="{8FDAE007-18BC-43D0-A080-284B2EB48E7B}"/>
               </a:ext>
             </a:extLst>
           </p:cNvPr>
@@ -8582,7 +8582,7 @@
           <p:cNvPr id="13" name="">
             <a:extLst xmlns:a="http://schemas.openxmlformats.org/drawingml/2006/main">
               <a:ext uri="{FF2B5EF4-FFF2-40B4-BE49-F238E27FC236}">
-                <a16:creationId xmlns:a16="http://schemas.microsoft.com/office/drawing/2014/main" id="{F3BED4C2-FBB0-431E-9B47-C87A283C8D31}"/>
+                <a16:creationId xmlns:a16="http://schemas.microsoft.com/office/drawing/2014/main" id="{6AB42048-96BB-4A02-BB6A-B1371C8B6818}"/>
               </a:ext>
             </a:extLst>
           </p:cNvPr>
@@ -8739,7 +8739,7 @@
           <p:cNvPr id="14" name="">
             <a:extLst xmlns:a="http://schemas.openxmlformats.org/drawingml/2006/main">
               <a:ext uri="{FF2B5EF4-FFF2-40B4-BE49-F238E27FC236}">
-                <a16:creationId xmlns:a16="http://schemas.microsoft.com/office/drawing/2014/main" id="{34174A67-341E-426E-A18D-EB81A08695F6}"/>
+                <a16:creationId xmlns:a16="http://schemas.microsoft.com/office/drawing/2014/main" id="{2DDDE840-0AAF-42D2-9FFD-D7440D0E7A3D}"/>
               </a:ext>
             </a:extLst>
           </p:cNvPr>
@@ -8896,7 +8896,7 @@
           <p:cNvPr id="15" name="">
             <a:extLst xmlns:a="http://schemas.openxmlformats.org/drawingml/2006/main">
               <a:ext uri="{FF2B5EF4-FFF2-40B4-BE49-F238E27FC236}">
-                <a16:creationId xmlns:a16="http://schemas.microsoft.com/office/drawing/2014/main" id="{3C2C9CAA-7266-4173-98DF-EC67B9F0C882}"/>
+                <a16:creationId xmlns:a16="http://schemas.microsoft.com/office/drawing/2014/main" id="{067EBE0F-771E-40B1-844C-4C977C68EE2D}"/>
               </a:ext>
             </a:extLst>
           </p:cNvPr>
@@ -9051,7 +9051,7 @@
     </p:spTree>
     <p:extLst>
       <p:ext uri="{BB962C8B-B14F-4D97-AF65-F5344CB8AC3E}">
-        <p14:creationId xmlns:p14="http://schemas.microsoft.com/office/powerpoint/2010/main" val="1560982674"/>
+        <p14:creationId xmlns:p14="http://schemas.microsoft.com/office/powerpoint/2010/main" val="1797717878"/>
       </p:ext>
     </p:extLst>
   </p:cSld>
@@ -9082,7 +9082,7 @@
           <p:cNvPr id="26" name="">
             <a:extLst xmlns:a="http://schemas.openxmlformats.org/drawingml/2006/main">
               <a:ext uri="{FF2B5EF4-FFF2-40B4-BE49-F238E27FC236}">
-                <a16:creationId xmlns:a16="http://schemas.microsoft.com/office/drawing/2014/main" id="{2CFAED93-9780-4E02-B058-F3EA05749D65}"/>
+                <a16:creationId xmlns:a16="http://schemas.microsoft.com/office/drawing/2014/main" id="{37D1E5CD-987D-4DB4-B538-726D4D51957C}"/>
               </a:ext>
             </a:extLst>
           </p:cNvPr>
@@ -9239,7 +9239,7 @@
           <p:cNvPr id="2" name="">
             <a:extLst xmlns:a="http://schemas.openxmlformats.org/drawingml/2006/main">
               <a:ext uri="{FF2B5EF4-FFF2-40B4-BE49-F238E27FC236}">
-                <a16:creationId xmlns:a16="http://schemas.microsoft.com/office/drawing/2014/main" id="{63735E4E-B532-4F9B-A19E-D7F22EE3BF3A}"/>
+                <a16:creationId xmlns:a16="http://schemas.microsoft.com/office/drawing/2014/main" id="{CC140B8B-CF98-4F7E-BBD0-5A56E52A2C78}"/>
               </a:ext>
             </a:extLst>
           </p:cNvPr>
@@ -9396,7 +9396,7 @@
           <p:cNvPr id="3" name="">
             <a:extLst xmlns:a="http://schemas.openxmlformats.org/drawingml/2006/main">
               <a:ext uri="{FF2B5EF4-FFF2-40B4-BE49-F238E27FC236}">
-                <a16:creationId xmlns:a16="http://schemas.microsoft.com/office/drawing/2014/main" id="{1A79FDEB-F8E1-4D9B-BD96-B6C8D1D29838}"/>
+                <a16:creationId xmlns:a16="http://schemas.microsoft.com/office/drawing/2014/main" id="{26FE8CCA-62CC-4050-B173-36585ABD1394}"/>
               </a:ext>
             </a:extLst>
           </p:cNvPr>
@@ -9431,7 +9431,7 @@
           <p:cNvPr id="4" name="">
             <a:extLst xmlns:a="http://schemas.openxmlformats.org/drawingml/2006/main">
               <a:ext uri="{FF2B5EF4-FFF2-40B4-BE49-F238E27FC236}">
-                <a16:creationId xmlns:a16="http://schemas.microsoft.com/office/drawing/2014/main" id="{9AF8D49A-D217-4113-87B7-E107367CECD0}"/>
+                <a16:creationId xmlns:a16="http://schemas.microsoft.com/office/drawing/2014/main" id="{34CC2C00-0AC7-4AD9-86B1-0265BC8ED58A}"/>
               </a:ext>
             </a:extLst>
           </p:cNvPr>
@@ -9588,7 +9588,7 @@
           <p:cNvPr id="5" name="">
             <a:extLst xmlns:a="http://schemas.openxmlformats.org/drawingml/2006/main">
               <a:ext uri="{FF2B5EF4-FFF2-40B4-BE49-F238E27FC236}">
-                <a16:creationId xmlns:a16="http://schemas.microsoft.com/office/drawing/2014/main" id="{CAE50F5F-05D4-4D64-B99D-F397C5DCC816}"/>
+                <a16:creationId xmlns:a16="http://schemas.microsoft.com/office/drawing/2014/main" id="{C5E29E26-808C-40D5-86C4-F2A70F50CA98}"/>
               </a:ext>
             </a:extLst>
           </p:cNvPr>
@@ -9745,7 +9745,7 @@
           <p:cNvPr id="6" name="">
             <a:extLst xmlns:a="http://schemas.openxmlformats.org/drawingml/2006/main">
               <a:ext uri="{FF2B5EF4-FFF2-40B4-BE49-F238E27FC236}">
-                <a16:creationId xmlns:a16="http://schemas.microsoft.com/office/drawing/2014/main" id="{0753400B-204D-4108-8FFE-4606A7C45CFF}"/>
+                <a16:creationId xmlns:a16="http://schemas.microsoft.com/office/drawing/2014/main" id="{F03D5C79-5E58-448C-B001-5E8115AC1984}"/>
               </a:ext>
             </a:extLst>
           </p:cNvPr>
@@ -9778,7 +9778,7 @@
           <p:cNvPr id="7" name="">
             <a:extLst xmlns:a="http://schemas.openxmlformats.org/drawingml/2006/main">
               <a:ext uri="{FF2B5EF4-FFF2-40B4-BE49-F238E27FC236}">
-                <a16:creationId xmlns:a16="http://schemas.microsoft.com/office/drawing/2014/main" id="{64574DF3-769B-4DA5-BD61-95DD51E8D699}"/>
+                <a16:creationId xmlns:a16="http://schemas.microsoft.com/office/drawing/2014/main" id="{DA41327E-043C-4544-86AC-E3CBAFE81263}"/>
               </a:ext>
             </a:extLst>
           </p:cNvPr>
@@ -9813,7 +9813,7 @@
           <p:cNvPr id="8" name="">
             <a:extLst xmlns:a="http://schemas.openxmlformats.org/drawingml/2006/main">
               <a:ext uri="{FF2B5EF4-FFF2-40B4-BE49-F238E27FC236}">
-                <a16:creationId xmlns:a16="http://schemas.microsoft.com/office/drawing/2014/main" id="{EB13C8FD-2448-44D8-88AE-F6299B6AA219}"/>
+                <a16:creationId xmlns:a16="http://schemas.microsoft.com/office/drawing/2014/main" id="{2856D1F4-1BFA-481A-8A64-BE2543A824A8}"/>
               </a:ext>
             </a:extLst>
           </p:cNvPr>
@@ -9970,7 +9970,7 @@
           <p:cNvPr id="9" name="">
             <a:extLst xmlns:a="http://schemas.openxmlformats.org/drawingml/2006/main">
               <a:ext uri="{FF2B5EF4-FFF2-40B4-BE49-F238E27FC236}">
-                <a16:creationId xmlns:a16="http://schemas.microsoft.com/office/drawing/2014/main" id="{1D7A3A71-04FA-4439-8BBF-FCB36D32D4E1}"/>
+                <a16:creationId xmlns:a16="http://schemas.microsoft.com/office/drawing/2014/main" id="{2DD5AF83-C963-43CA-A448-70D5C8E137B8}"/>
               </a:ext>
             </a:extLst>
           </p:cNvPr>
@@ -10150,7 +10150,7 @@
           <p:cNvPr id="10" name="">
             <a:extLst xmlns:a="http://schemas.openxmlformats.org/drawingml/2006/main">
               <a:ext uri="{FF2B5EF4-FFF2-40B4-BE49-F238E27FC236}">
-                <a16:creationId xmlns:a16="http://schemas.microsoft.com/office/drawing/2014/main" id="{DB2FDDCD-148C-4FD6-B19F-D2E1F1EFB67B}"/>
+                <a16:creationId xmlns:a16="http://schemas.microsoft.com/office/drawing/2014/main" id="{25ABA941-3065-4D8E-94EC-D7BAF9B0F9A6}"/>
               </a:ext>
             </a:extLst>
           </p:cNvPr>
@@ -10183,7 +10183,7 @@
           <p:cNvPr id="11" name="">
             <a:extLst xmlns:a="http://schemas.openxmlformats.org/drawingml/2006/main">
               <a:ext uri="{FF2B5EF4-FFF2-40B4-BE49-F238E27FC236}">
-                <a16:creationId xmlns:a16="http://schemas.microsoft.com/office/drawing/2014/main" id="{7BB35D6D-DEA8-49DF-AAC7-99D377925EBB}"/>
+                <a16:creationId xmlns:a16="http://schemas.microsoft.com/office/drawing/2014/main" id="{3F874B48-57F4-4B4E-9D9A-4EAC10B5331D}"/>
               </a:ext>
             </a:extLst>
           </p:cNvPr>
@@ -10218,7 +10218,7 @@
           <p:cNvPr id="12" name="">
             <a:extLst xmlns:a="http://schemas.openxmlformats.org/drawingml/2006/main">
               <a:ext uri="{FF2B5EF4-FFF2-40B4-BE49-F238E27FC236}">
-                <a16:creationId xmlns:a16="http://schemas.microsoft.com/office/drawing/2014/main" id="{C87CFD5C-0773-41B9-9328-B620D5AFA46B}"/>
+                <a16:creationId xmlns:a16="http://schemas.microsoft.com/office/drawing/2014/main" id="{433F04C0-D097-49E2-8BF7-0D270F3B5610}"/>
               </a:ext>
             </a:extLst>
           </p:cNvPr>
@@ -10375,7 +10375,7 @@
           <p:cNvPr id="13" name="">
             <a:extLst xmlns:a="http://schemas.openxmlformats.org/drawingml/2006/main">
               <a:ext uri="{FF2B5EF4-FFF2-40B4-BE49-F238E27FC236}">
-                <a16:creationId xmlns:a16="http://schemas.microsoft.com/office/drawing/2014/main" id="{94FE65D1-D4E4-41CA-95A0-D6AB6C592883}"/>
+                <a16:creationId xmlns:a16="http://schemas.microsoft.com/office/drawing/2014/main" id="{673B222F-8E70-49A9-88A6-DB58D6E9BC38}"/>
               </a:ext>
             </a:extLst>
           </p:cNvPr>
@@ -10532,7 +10532,7 @@
           <p:cNvPr id="14" name="">
             <a:extLst xmlns:a="http://schemas.openxmlformats.org/drawingml/2006/main">
               <a:ext uri="{FF2B5EF4-FFF2-40B4-BE49-F238E27FC236}">
-                <a16:creationId xmlns:a16="http://schemas.microsoft.com/office/drawing/2014/main" id="{B7792E35-135D-4F35-B7F5-C7F68481FB16}"/>
+                <a16:creationId xmlns:a16="http://schemas.microsoft.com/office/drawing/2014/main" id="{57DA87F1-1E48-47BE-BFC0-419AABA5A7E2}"/>
               </a:ext>
             </a:extLst>
           </p:cNvPr>
@@ -10565,7 +10565,7 @@
           <p:cNvPr id="15" name="">
             <a:extLst xmlns:a="http://schemas.openxmlformats.org/drawingml/2006/main">
               <a:ext uri="{FF2B5EF4-FFF2-40B4-BE49-F238E27FC236}">
-                <a16:creationId xmlns:a16="http://schemas.microsoft.com/office/drawing/2014/main" id="{5125E27C-1D87-484A-A372-23D65206E343}"/>
+                <a16:creationId xmlns:a16="http://schemas.microsoft.com/office/drawing/2014/main" id="{BA0FB011-A822-4AC9-BCF9-6317F0DE4A89}"/>
               </a:ext>
             </a:extLst>
           </p:cNvPr>
@@ -10600,7 +10600,7 @@
           <p:cNvPr id="16" name="">
             <a:extLst xmlns:a="http://schemas.openxmlformats.org/drawingml/2006/main">
               <a:ext uri="{FF2B5EF4-FFF2-40B4-BE49-F238E27FC236}">
-                <a16:creationId xmlns:a16="http://schemas.microsoft.com/office/drawing/2014/main" id="{5FB53C19-526D-475C-920B-83A1CA39B480}"/>
+                <a16:creationId xmlns:a16="http://schemas.microsoft.com/office/drawing/2014/main" id="{92E3E49C-C97D-4C73-8FB0-9C3DA18E85EA}"/>
               </a:ext>
             </a:extLst>
           </p:cNvPr>
@@ -10757,7 +10757,7 @@
           <p:cNvPr id="17" name="">
             <a:extLst xmlns:a="http://schemas.openxmlformats.org/drawingml/2006/main">
               <a:ext uri="{FF2B5EF4-FFF2-40B4-BE49-F238E27FC236}">
-                <a16:creationId xmlns:a16="http://schemas.microsoft.com/office/drawing/2014/main" id="{F3AD7250-D8CC-4F8F-A4A5-BB9EA1FEE103}"/>
+                <a16:creationId xmlns:a16="http://schemas.microsoft.com/office/drawing/2014/main" id="{95A60FF6-5C97-4D5D-B843-933D8064AF7D}"/>
               </a:ext>
             </a:extLst>
           </p:cNvPr>
@@ -10914,7 +10914,7 @@
           <p:cNvPr id="18" name="">
             <a:extLst xmlns:a="http://schemas.openxmlformats.org/drawingml/2006/main">
               <a:ext uri="{FF2B5EF4-FFF2-40B4-BE49-F238E27FC236}">
-                <a16:creationId xmlns:a16="http://schemas.microsoft.com/office/drawing/2014/main" id="{1D531879-EB35-4784-A7D2-F6969094B13A}"/>
+                <a16:creationId xmlns:a16="http://schemas.microsoft.com/office/drawing/2014/main" id="{4A06FB08-60D1-4789-9389-7C155C193A4B}"/>
               </a:ext>
             </a:extLst>
           </p:cNvPr>
@@ -11071,7 +11071,7 @@
           <p:cNvPr id="19" name="">
             <a:extLst xmlns:a="http://schemas.openxmlformats.org/drawingml/2006/main">
               <a:ext uri="{FF2B5EF4-FFF2-40B4-BE49-F238E27FC236}">
-                <a16:creationId xmlns:a16="http://schemas.microsoft.com/office/drawing/2014/main" id="{4BE06FBA-4B09-4CF0-A90E-47E59C2B97E8}"/>
+                <a16:creationId xmlns:a16="http://schemas.microsoft.com/office/drawing/2014/main" id="{56BB4FB4-78E9-423E-ABFA-2E86BA0A5DCB}"/>
               </a:ext>
             </a:extLst>
           </p:cNvPr>
@@ -11228,7 +11228,7 @@
           <p:cNvPr id="20" name="">
             <a:extLst xmlns:a="http://schemas.openxmlformats.org/drawingml/2006/main">
               <a:ext uri="{FF2B5EF4-FFF2-40B4-BE49-F238E27FC236}">
-                <a16:creationId xmlns:a16="http://schemas.microsoft.com/office/drawing/2014/main" id="{53028720-0F60-4A57-A367-F113D7FF085A}"/>
+                <a16:creationId xmlns:a16="http://schemas.microsoft.com/office/drawing/2014/main" id="{CD2D7A3C-ABFF-4E24-B58F-47BC8DCD05B4}"/>
               </a:ext>
             </a:extLst>
           </p:cNvPr>
@@ -11385,7 +11385,7 @@
           <p:cNvPr id="21" name="">
             <a:extLst xmlns:a="http://schemas.openxmlformats.org/drawingml/2006/main">
               <a:ext uri="{FF2B5EF4-FFF2-40B4-BE49-F238E27FC236}">
-                <a16:creationId xmlns:a16="http://schemas.microsoft.com/office/drawing/2014/main" id="{5B82760D-6127-40CA-8C33-94469D8ABE68}"/>
+                <a16:creationId xmlns:a16="http://schemas.microsoft.com/office/drawing/2014/main" id="{4E20782B-54D2-4926-9A8D-C9946272AEB5}"/>
               </a:ext>
             </a:extLst>
           </p:cNvPr>
@@ -11542,7 +11542,7 @@
           <p:cNvPr id="22" name="">
             <a:extLst xmlns:a="http://schemas.openxmlformats.org/drawingml/2006/main">
               <a:ext uri="{FF2B5EF4-FFF2-40B4-BE49-F238E27FC236}">
-                <a16:creationId xmlns:a16="http://schemas.microsoft.com/office/drawing/2014/main" id="{B172924C-BEB0-4186-B5D8-DD495B1B40E7}"/>
+                <a16:creationId xmlns:a16="http://schemas.microsoft.com/office/drawing/2014/main" id="{1D8BF9F5-9E1D-44D5-8A6A-1EB68F2D3CC4}"/>
               </a:ext>
             </a:extLst>
           </p:cNvPr>
@@ -11699,7 +11699,7 @@
           <p:cNvPr id="23" name="">
             <a:extLst xmlns:a="http://schemas.openxmlformats.org/drawingml/2006/main">
               <a:ext uri="{FF2B5EF4-FFF2-40B4-BE49-F238E27FC236}">
-                <a16:creationId xmlns:a16="http://schemas.microsoft.com/office/drawing/2014/main" id="{19CE26F1-74C3-4C26-8844-6369C0AA40C0}"/>
+                <a16:creationId xmlns:a16="http://schemas.microsoft.com/office/drawing/2014/main" id="{1D09C851-EDBA-42AA-B5DC-F68A095E1ED5}"/>
               </a:ext>
             </a:extLst>
           </p:cNvPr>
@@ -11856,7 +11856,7 @@
           <p:cNvPr id="24" name="">
             <a:extLst xmlns:a="http://schemas.openxmlformats.org/drawingml/2006/main">
               <a:ext uri="{FF2B5EF4-FFF2-40B4-BE49-F238E27FC236}">
-                <a16:creationId xmlns:a16="http://schemas.microsoft.com/office/drawing/2014/main" id="{C433A1A0-5677-440B-9BA9-947FAB7892D9}"/>
+                <a16:creationId xmlns:a16="http://schemas.microsoft.com/office/drawing/2014/main" id="{D1802FC5-E3EC-4F15-83FA-1CC28514B8B6}"/>
               </a:ext>
             </a:extLst>
           </p:cNvPr>
@@ -12013,7 +12013,7 @@
           <p:cNvPr id="25" name="">
             <a:extLst xmlns:a="http://schemas.openxmlformats.org/drawingml/2006/main">
               <a:ext uri="{FF2B5EF4-FFF2-40B4-BE49-F238E27FC236}">
-                <a16:creationId xmlns:a16="http://schemas.microsoft.com/office/drawing/2014/main" id="{CAC887EE-A97A-4669-A121-89F9C1710054}"/>
+                <a16:creationId xmlns:a16="http://schemas.microsoft.com/office/drawing/2014/main" id="{673896F8-3574-4ADD-A96C-795DE69ABC0A}"/>
               </a:ext>
             </a:extLst>
           </p:cNvPr>
@@ -12168,7 +12168,7 @@
     </p:spTree>
     <p:extLst>
       <p:ext uri="{BB962C8B-B14F-4D97-AF65-F5344CB8AC3E}">
-        <p14:creationId xmlns:p14="http://schemas.microsoft.com/office/powerpoint/2010/main" val="1325095495"/>
+        <p14:creationId xmlns:p14="http://schemas.microsoft.com/office/powerpoint/2010/main" val="1143056818"/>
       </p:ext>
     </p:extLst>
   </p:cSld>
@@ -12199,7 +12199,7 @@
           <p:cNvPr id="32" name="">
             <a:extLst xmlns:a="http://schemas.openxmlformats.org/drawingml/2006/main">
               <a:ext uri="{FF2B5EF4-FFF2-40B4-BE49-F238E27FC236}">
-                <a16:creationId xmlns:a16="http://schemas.microsoft.com/office/drawing/2014/main" id="{2530F363-BDD6-4A1F-B625-92B27DDCC304}"/>
+                <a16:creationId xmlns:a16="http://schemas.microsoft.com/office/drawing/2014/main" id="{07AE3BCB-B01B-425E-A569-3035DD12DA2D}"/>
               </a:ext>
             </a:extLst>
           </p:cNvPr>
@@ -12356,7 +12356,7 @@
           <p:cNvPr id="2" name="">
             <a:extLst xmlns:a="http://schemas.openxmlformats.org/drawingml/2006/main">
               <a:ext uri="{FF2B5EF4-FFF2-40B4-BE49-F238E27FC236}">
-                <a16:creationId xmlns:a16="http://schemas.microsoft.com/office/drawing/2014/main" id="{355C2A52-CCF6-4622-9F92-71A09FA0C396}"/>
+                <a16:creationId xmlns:a16="http://schemas.microsoft.com/office/drawing/2014/main" id="{959069BE-0739-4970-A7F6-1D17D5F048BB}"/>
               </a:ext>
             </a:extLst>
           </p:cNvPr>
@@ -12513,7 +12513,7 @@
           <p:cNvPr id="3" name="">
             <a:extLst xmlns:a="http://schemas.openxmlformats.org/drawingml/2006/main">
               <a:ext uri="{FF2B5EF4-FFF2-40B4-BE49-F238E27FC236}">
-                <a16:creationId xmlns:a16="http://schemas.microsoft.com/office/drawing/2014/main" id="{DBF6EEBD-20EA-43E7-A8F3-B411521025DD}"/>
+                <a16:creationId xmlns:a16="http://schemas.microsoft.com/office/drawing/2014/main" id="{B3370A88-6F4B-4AEE-B795-9DE39992A967}"/>
               </a:ext>
             </a:extLst>
           </p:cNvPr>
@@ -12548,7 +12548,7 @@
           <p:cNvPr id="4" name="">
             <a:extLst xmlns:a="http://schemas.openxmlformats.org/drawingml/2006/main">
               <a:ext uri="{FF2B5EF4-FFF2-40B4-BE49-F238E27FC236}">
-                <a16:creationId xmlns:a16="http://schemas.microsoft.com/office/drawing/2014/main" id="{7C1C8F23-13FE-4387-9805-5155BB7EF712}"/>
+                <a16:creationId xmlns:a16="http://schemas.microsoft.com/office/drawing/2014/main" id="{91DB2DA7-0551-4FC8-99E1-893E9CCDDD52}"/>
               </a:ext>
             </a:extLst>
           </p:cNvPr>
@@ -12705,7 +12705,7 @@
           <p:cNvPr id="5" name="">
             <a:extLst xmlns:a="http://schemas.openxmlformats.org/drawingml/2006/main">
               <a:ext uri="{FF2B5EF4-FFF2-40B4-BE49-F238E27FC236}">
-                <a16:creationId xmlns:a16="http://schemas.microsoft.com/office/drawing/2014/main" id="{BB63866F-E67E-4445-9FF9-A9C52321EFAD}"/>
+                <a16:creationId xmlns:a16="http://schemas.microsoft.com/office/drawing/2014/main" id="{82E851AC-CC2E-4683-A554-3070BC411284}"/>
               </a:ext>
             </a:extLst>
           </p:cNvPr>
@@ -12862,7 +12862,7 @@
           <p:cNvPr id="6" name="">
             <a:extLst xmlns:a="http://schemas.openxmlformats.org/drawingml/2006/main">
               <a:ext uri="{FF2B5EF4-FFF2-40B4-BE49-F238E27FC236}">
-                <a16:creationId xmlns:a16="http://schemas.microsoft.com/office/drawing/2014/main" id="{2A0F9593-2C86-490B-AF37-99B64C477013}"/>
+                <a16:creationId xmlns:a16="http://schemas.microsoft.com/office/drawing/2014/main" id="{B5935AD9-773B-46B3-951E-671523D7839F}"/>
               </a:ext>
             </a:extLst>
           </p:cNvPr>
@@ -12895,7 +12895,7 @@
           <p:cNvPr id="7" name="">
             <a:extLst xmlns:a="http://schemas.openxmlformats.org/drawingml/2006/main">
               <a:ext uri="{FF2B5EF4-FFF2-40B4-BE49-F238E27FC236}">
-                <a16:creationId xmlns:a16="http://schemas.microsoft.com/office/drawing/2014/main" id="{D5B0F51D-8009-489F-A09E-92DA24865AA5}"/>
+                <a16:creationId xmlns:a16="http://schemas.microsoft.com/office/drawing/2014/main" id="{BE59C2B6-72F4-4B15-91A7-ACC2B3CC98C9}"/>
               </a:ext>
             </a:extLst>
           </p:cNvPr>
@@ -12930,7 +12930,7 @@
           <p:cNvPr id="8" name="">
             <a:extLst xmlns:a="http://schemas.openxmlformats.org/drawingml/2006/main">
               <a:ext uri="{FF2B5EF4-FFF2-40B4-BE49-F238E27FC236}">
-                <a16:creationId xmlns:a16="http://schemas.microsoft.com/office/drawing/2014/main" id="{42A8B7DF-D06F-460C-BF82-47634F26B978}"/>
+                <a16:creationId xmlns:a16="http://schemas.microsoft.com/office/drawing/2014/main" id="{7D1756D0-4C5D-4242-A5D7-FFD46ABA93CF}"/>
               </a:ext>
             </a:extLst>
           </p:cNvPr>
@@ -13087,7 +13087,7 @@
           <p:cNvPr id="9" name="">
             <a:extLst xmlns:a="http://schemas.openxmlformats.org/drawingml/2006/main">
               <a:ext uri="{FF2B5EF4-FFF2-40B4-BE49-F238E27FC236}">
-                <a16:creationId xmlns:a16="http://schemas.microsoft.com/office/drawing/2014/main" id="{68E7148B-4994-4F5E-88CF-1574EE6CB957}"/>
+                <a16:creationId xmlns:a16="http://schemas.microsoft.com/office/drawing/2014/main" id="{F52FA569-2002-4B1F-BD31-9C1E4FF2AE0F}"/>
               </a:ext>
             </a:extLst>
           </p:cNvPr>
@@ -13244,7 +13244,7 @@
           <p:cNvPr id="10" name="">
             <a:extLst xmlns:a="http://schemas.openxmlformats.org/drawingml/2006/main">
               <a:ext uri="{FF2B5EF4-FFF2-40B4-BE49-F238E27FC236}">
-                <a16:creationId xmlns:a16="http://schemas.microsoft.com/office/drawing/2014/main" id="{834D9ACA-F177-4D45-A7C6-9D9203C924B4}"/>
+                <a16:creationId xmlns:a16="http://schemas.microsoft.com/office/drawing/2014/main" id="{E65375B3-FD38-4F8C-B335-AEAE2BB84129}"/>
               </a:ext>
             </a:extLst>
           </p:cNvPr>
@@ -13277,7 +13277,7 @@
           <p:cNvPr id="11" name="">
             <a:extLst xmlns:a="http://schemas.openxmlformats.org/drawingml/2006/main">
               <a:ext uri="{FF2B5EF4-FFF2-40B4-BE49-F238E27FC236}">
-                <a16:creationId xmlns:a16="http://schemas.microsoft.com/office/drawing/2014/main" id="{EC925FE0-EE3E-4270-8B68-DC8E089AD77A}"/>
+                <a16:creationId xmlns:a16="http://schemas.microsoft.com/office/drawing/2014/main" id="{0AC2D058-CCDF-49B7-8AE7-813989075F17}"/>
               </a:ext>
             </a:extLst>
           </p:cNvPr>
@@ -13312,7 +13312,7 @@
           <p:cNvPr id="12" name="">
             <a:extLst xmlns:a="http://schemas.openxmlformats.org/drawingml/2006/main">
               <a:ext uri="{FF2B5EF4-FFF2-40B4-BE49-F238E27FC236}">
-                <a16:creationId xmlns:a16="http://schemas.microsoft.com/office/drawing/2014/main" id="{00E854B2-34C4-440A-B931-87F827CCB648}"/>
+                <a16:creationId xmlns:a16="http://schemas.microsoft.com/office/drawing/2014/main" id="{43646CC4-AC15-4721-B1D0-3A545BB7D855}"/>
               </a:ext>
             </a:extLst>
           </p:cNvPr>
@@ -13469,7 +13469,7 @@
           <p:cNvPr id="13" name="">
             <a:extLst xmlns:a="http://schemas.openxmlformats.org/drawingml/2006/main">
               <a:ext uri="{FF2B5EF4-FFF2-40B4-BE49-F238E27FC236}">
-                <a16:creationId xmlns:a16="http://schemas.microsoft.com/office/drawing/2014/main" id="{3467282E-F235-4237-92B1-5A3DDE504201}"/>
+                <a16:creationId xmlns:a16="http://schemas.microsoft.com/office/drawing/2014/main" id="{C94A1EBC-A950-4E21-9207-D0078E1B8530}"/>
               </a:ext>
             </a:extLst>
           </p:cNvPr>
@@ -13626,7 +13626,7 @@
           <p:cNvPr id="14" name="">
             <a:extLst xmlns:a="http://schemas.openxmlformats.org/drawingml/2006/main">
               <a:ext uri="{FF2B5EF4-FFF2-40B4-BE49-F238E27FC236}">
-                <a16:creationId xmlns:a16="http://schemas.microsoft.com/office/drawing/2014/main" id="{9C8B109C-EF8F-44EC-BECC-65198763654D}"/>
+                <a16:creationId xmlns:a16="http://schemas.microsoft.com/office/drawing/2014/main" id="{31C48FD8-B7A0-47A2-ABA4-55C6AE752B3B}"/>
               </a:ext>
             </a:extLst>
           </p:cNvPr>
@@ -13659,7 +13659,7 @@
           <p:cNvPr id="15" name="">
             <a:extLst xmlns:a="http://schemas.openxmlformats.org/drawingml/2006/main">
               <a:ext uri="{FF2B5EF4-FFF2-40B4-BE49-F238E27FC236}">
-                <a16:creationId xmlns:a16="http://schemas.microsoft.com/office/drawing/2014/main" id="{1DC147AE-8D59-4A18-96DC-38022DBCBFBA}"/>
+                <a16:creationId xmlns:a16="http://schemas.microsoft.com/office/drawing/2014/main" id="{E1427553-6B7B-480D-9955-89F4EF294BCF}"/>
               </a:ext>
             </a:extLst>
           </p:cNvPr>
@@ -13694,7 +13694,7 @@
           <p:cNvPr id="16" name="">
             <a:extLst xmlns:a="http://schemas.openxmlformats.org/drawingml/2006/main">
               <a:ext uri="{FF2B5EF4-FFF2-40B4-BE49-F238E27FC236}">
-                <a16:creationId xmlns:a16="http://schemas.microsoft.com/office/drawing/2014/main" id="{3DF1A389-345A-4344-AB4A-3FB5AB45CA93}"/>
+                <a16:creationId xmlns:a16="http://schemas.microsoft.com/office/drawing/2014/main" id="{DE018A41-8BB6-43E3-B062-7E9AD6157179}"/>
               </a:ext>
             </a:extLst>
           </p:cNvPr>
@@ -13851,7 +13851,7 @@
           <p:cNvPr id="17" name="">
             <a:extLst xmlns:a="http://schemas.openxmlformats.org/drawingml/2006/main">
               <a:ext uri="{FF2B5EF4-FFF2-40B4-BE49-F238E27FC236}">
-                <a16:creationId xmlns:a16="http://schemas.microsoft.com/office/drawing/2014/main" id="{D209D6E9-0638-4EC5-9162-32C7FAF6968E}"/>
+                <a16:creationId xmlns:a16="http://schemas.microsoft.com/office/drawing/2014/main" id="{103FA89A-B9C1-4435-9F32-365A822386D3}"/>
               </a:ext>
             </a:extLst>
           </p:cNvPr>
@@ -14008,7 +14008,7 @@
           <p:cNvPr id="18" name="">
             <a:extLst xmlns:a="http://schemas.openxmlformats.org/drawingml/2006/main">
               <a:ext uri="{FF2B5EF4-FFF2-40B4-BE49-F238E27FC236}">
-                <a16:creationId xmlns:a16="http://schemas.microsoft.com/office/drawing/2014/main" id="{1EF510B6-5AA7-4C3B-92BE-17027ADDD3E8}"/>
+                <a16:creationId xmlns:a16="http://schemas.microsoft.com/office/drawing/2014/main" id="{F76F539A-481D-4F49-A865-1D70047E4BC4}"/>
               </a:ext>
             </a:extLst>
           </p:cNvPr>
@@ -14041,7 +14041,7 @@
           <p:cNvPr id="19" name="">
             <a:extLst xmlns:a="http://schemas.openxmlformats.org/drawingml/2006/main">
               <a:ext uri="{FF2B5EF4-FFF2-40B4-BE49-F238E27FC236}">
-                <a16:creationId xmlns:a16="http://schemas.microsoft.com/office/drawing/2014/main" id="{CA861775-0909-4119-A12C-6456C76E9196}"/>
+                <a16:creationId xmlns:a16="http://schemas.microsoft.com/office/drawing/2014/main" id="{BAFC8F60-59AC-4D1E-8373-C0B125837D05}"/>
               </a:ext>
             </a:extLst>
           </p:cNvPr>
@@ -14076,7 +14076,7 @@
           <p:cNvPr id="20" name="">
             <a:extLst xmlns:a="http://schemas.openxmlformats.org/drawingml/2006/main">
               <a:ext uri="{FF2B5EF4-FFF2-40B4-BE49-F238E27FC236}">
-                <a16:creationId xmlns:a16="http://schemas.microsoft.com/office/drawing/2014/main" id="{3ED563BA-6F2A-414E-8B95-5377F2518388}"/>
+                <a16:creationId xmlns:a16="http://schemas.microsoft.com/office/drawing/2014/main" id="{DF144CC7-F5EC-40D7-BF32-A63E65C9B34A}"/>
               </a:ext>
             </a:extLst>
           </p:cNvPr>
@@ -14233,7 +14233,7 @@
           <p:cNvPr id="21" name="">
             <a:extLst xmlns:a="http://schemas.openxmlformats.org/drawingml/2006/main">
               <a:ext uri="{FF2B5EF4-FFF2-40B4-BE49-F238E27FC236}">
-                <a16:creationId xmlns:a16="http://schemas.microsoft.com/office/drawing/2014/main" id="{EFCAF635-91C2-48A9-9FF1-7277DA4F475A}"/>
+                <a16:creationId xmlns:a16="http://schemas.microsoft.com/office/drawing/2014/main" id="{D1AAD590-B2C8-451D-B4F5-3F92D1493E35}"/>
               </a:ext>
             </a:extLst>
           </p:cNvPr>
@@ -14390,7 +14390,7 @@
           <p:cNvPr id="22" name="">
             <a:extLst xmlns:a="http://schemas.openxmlformats.org/drawingml/2006/main">
               <a:ext uri="{FF2B5EF4-FFF2-40B4-BE49-F238E27FC236}">
-                <a16:creationId xmlns:a16="http://schemas.microsoft.com/office/drawing/2014/main" id="{B809B52B-3756-42C7-AE14-6FF609A4FC93}"/>
+                <a16:creationId xmlns:a16="http://schemas.microsoft.com/office/drawing/2014/main" id="{F86E9ECA-53A4-4265-BB6A-2731A917E1B3}"/>
               </a:ext>
             </a:extLst>
           </p:cNvPr>
@@ -14547,7 +14547,7 @@
           <p:cNvPr id="23" name="">
             <a:extLst xmlns:a="http://schemas.openxmlformats.org/drawingml/2006/main">
               <a:ext uri="{FF2B5EF4-FFF2-40B4-BE49-F238E27FC236}">
-                <a16:creationId xmlns:a16="http://schemas.microsoft.com/office/drawing/2014/main" id="{6DE8DB35-DF6D-46B4-952E-749222A686E4}"/>
+                <a16:creationId xmlns:a16="http://schemas.microsoft.com/office/drawing/2014/main" id="{14E5CC6C-AB59-4F5E-9998-241CD908EDBA}"/>
               </a:ext>
             </a:extLst>
           </p:cNvPr>
@@ -14704,7 +14704,7 @@
           <p:cNvPr id="24" name="">
             <a:extLst xmlns:a="http://schemas.openxmlformats.org/drawingml/2006/main">
               <a:ext uri="{FF2B5EF4-FFF2-40B4-BE49-F238E27FC236}">
-                <a16:creationId xmlns:a16="http://schemas.microsoft.com/office/drawing/2014/main" id="{966B0AF3-7C75-4CA6-A565-2F083DD99B52}"/>
+                <a16:creationId xmlns:a16="http://schemas.microsoft.com/office/drawing/2014/main" id="{C40E8E8D-DDCD-42EC-9578-EDF423C9E457}"/>
               </a:ext>
             </a:extLst>
           </p:cNvPr>
@@ -14861,7 +14861,7 @@
           <p:cNvPr id="25" name="">
             <a:extLst xmlns:a="http://schemas.openxmlformats.org/drawingml/2006/main">
               <a:ext uri="{FF2B5EF4-FFF2-40B4-BE49-F238E27FC236}">
-                <a16:creationId xmlns:a16="http://schemas.microsoft.com/office/drawing/2014/main" id="{F00E4EF8-48C5-40CA-A2E9-EC06F6724446}"/>
+                <a16:creationId xmlns:a16="http://schemas.microsoft.com/office/drawing/2014/main" id="{551D4B52-1605-464B-BC5E-FC7DA7321D73}"/>
               </a:ext>
             </a:extLst>
           </p:cNvPr>
@@ -15018,7 +15018,7 @@
           <p:cNvPr id="26" name="">
             <a:extLst xmlns:a="http://schemas.openxmlformats.org/drawingml/2006/main">
               <a:ext uri="{FF2B5EF4-FFF2-40B4-BE49-F238E27FC236}">
-                <a16:creationId xmlns:a16="http://schemas.microsoft.com/office/drawing/2014/main" id="{5A9B218E-1F19-4D9C-84CA-F8AF7B797D55}"/>
+                <a16:creationId xmlns:a16="http://schemas.microsoft.com/office/drawing/2014/main" id="{8A08B678-6C3D-432F-A478-FD277F900D7F}"/>
               </a:ext>
             </a:extLst>
           </p:cNvPr>
@@ -15175,7 +15175,7 @@
           <p:cNvPr id="27" name="">
             <a:extLst xmlns:a="http://schemas.openxmlformats.org/drawingml/2006/main">
               <a:ext uri="{FF2B5EF4-FFF2-40B4-BE49-F238E27FC236}">
-                <a16:creationId xmlns:a16="http://schemas.microsoft.com/office/drawing/2014/main" id="{DA253CEC-E73E-4F14-9096-B28743FAC2E4}"/>
+                <a16:creationId xmlns:a16="http://schemas.microsoft.com/office/drawing/2014/main" id="{78888C99-E5EE-487A-8751-31F3C8B640B9}"/>
               </a:ext>
             </a:extLst>
           </p:cNvPr>
@@ -15332,7 +15332,7 @@
           <p:cNvPr id="28" name="">
             <a:extLst xmlns:a="http://schemas.openxmlformats.org/drawingml/2006/main">
               <a:ext uri="{FF2B5EF4-FFF2-40B4-BE49-F238E27FC236}">
-                <a16:creationId xmlns:a16="http://schemas.microsoft.com/office/drawing/2014/main" id="{1455B637-C3F5-44F2-A051-41A498A71E84}"/>
+                <a16:creationId xmlns:a16="http://schemas.microsoft.com/office/drawing/2014/main" id="{A4179EAF-5C18-4C80-81F7-3152AAC2217B}"/>
               </a:ext>
             </a:extLst>
           </p:cNvPr>
@@ -15489,7 +15489,7 @@
           <p:cNvPr id="29" name="">
             <a:extLst xmlns:a="http://schemas.openxmlformats.org/drawingml/2006/main">
               <a:ext uri="{FF2B5EF4-FFF2-40B4-BE49-F238E27FC236}">
-                <a16:creationId xmlns:a16="http://schemas.microsoft.com/office/drawing/2014/main" id="{D48EB9AB-4D3D-464B-B142-BFD9B759FE41}"/>
+                <a16:creationId xmlns:a16="http://schemas.microsoft.com/office/drawing/2014/main" id="{F986B783-75BC-4994-93FB-CBB3010BD9C1}"/>
               </a:ext>
             </a:extLst>
           </p:cNvPr>
@@ -15646,7 +15646,7 @@
           <p:cNvPr id="30" name="">
             <a:extLst xmlns:a="http://schemas.openxmlformats.org/drawingml/2006/main">
               <a:ext uri="{FF2B5EF4-FFF2-40B4-BE49-F238E27FC236}">
-                <a16:creationId xmlns:a16="http://schemas.microsoft.com/office/drawing/2014/main" id="{D45505E5-9FD4-462D-9915-9267E756178D}"/>
+                <a16:creationId xmlns:a16="http://schemas.microsoft.com/office/drawing/2014/main" id="{8E089E4C-4C2C-4CEE-B188-B7212AB530BD}"/>
               </a:ext>
             </a:extLst>
           </p:cNvPr>
@@ -15803,7 +15803,7 @@
           <p:cNvPr id="31" name="">
             <a:extLst xmlns:a="http://schemas.openxmlformats.org/drawingml/2006/main">
               <a:ext uri="{FF2B5EF4-FFF2-40B4-BE49-F238E27FC236}">
-                <a16:creationId xmlns:a16="http://schemas.microsoft.com/office/drawing/2014/main" id="{4E5B16A3-E343-433F-BDF0-43CDDFA486CB}"/>
+                <a16:creationId xmlns:a16="http://schemas.microsoft.com/office/drawing/2014/main" id="{45BEA95C-83BA-42FD-82CA-B83DDD07FDE5}"/>
               </a:ext>
             </a:extLst>
           </p:cNvPr>
@@ -15958,7 +15958,7 @@
     </p:spTree>
     <p:extLst>
       <p:ext uri="{BB962C8B-B14F-4D97-AF65-F5344CB8AC3E}">
-        <p14:creationId xmlns:p14="http://schemas.microsoft.com/office/powerpoint/2010/main" val="56622113"/>
+        <p14:creationId xmlns:p14="http://schemas.microsoft.com/office/powerpoint/2010/main" val="1918491577"/>
       </p:ext>
     </p:extLst>
   </p:cSld>
@@ -15989,7 +15989,7 @@
           <p:cNvPr id="18" name="">
             <a:extLst xmlns:a="http://schemas.openxmlformats.org/drawingml/2006/main">
               <a:ext uri="{FF2B5EF4-FFF2-40B4-BE49-F238E27FC236}">
-                <a16:creationId xmlns:a16="http://schemas.microsoft.com/office/drawing/2014/main" id="{B6471F43-02A4-4CC9-BBF6-D0C852B03CA2}"/>
+                <a16:creationId xmlns:a16="http://schemas.microsoft.com/office/drawing/2014/main" id="{2AC4A14C-5789-44EF-A08F-2ED0A4DFAD08}"/>
               </a:ext>
             </a:extLst>
           </p:cNvPr>
@@ -16146,7 +16146,7 @@
           <p:cNvPr id="2" name="">
             <a:extLst xmlns:a="http://schemas.openxmlformats.org/drawingml/2006/main">
               <a:ext uri="{FF2B5EF4-FFF2-40B4-BE49-F238E27FC236}">
-                <a16:creationId xmlns:a16="http://schemas.microsoft.com/office/drawing/2014/main" id="{2891E86A-D63E-4F6E-AC53-F9BD2AD0EEBE}"/>
+                <a16:creationId xmlns:a16="http://schemas.microsoft.com/office/drawing/2014/main" id="{9081B3FB-2BE3-4202-9335-B68B62BE6518}"/>
               </a:ext>
             </a:extLst>
           </p:cNvPr>
@@ -16303,7 +16303,7 @@
           <p:cNvPr id="3" name="">
             <a:extLst xmlns:a="http://schemas.openxmlformats.org/drawingml/2006/main">
               <a:ext uri="{FF2B5EF4-FFF2-40B4-BE49-F238E27FC236}">
-                <a16:creationId xmlns:a16="http://schemas.microsoft.com/office/drawing/2014/main" id="{3ECEC092-1A64-429A-8145-559E9641D997}"/>
+                <a16:creationId xmlns:a16="http://schemas.microsoft.com/office/drawing/2014/main" id="{401595A1-BF47-4868-8330-1014219AEF09}"/>
               </a:ext>
             </a:extLst>
           </p:cNvPr>
@@ -16460,7 +16460,7 @@
           <p:cNvPr id="4" name="">
             <a:extLst xmlns:a="http://schemas.openxmlformats.org/drawingml/2006/main">
               <a:ext uri="{FF2B5EF4-FFF2-40B4-BE49-F238E27FC236}">
-                <a16:creationId xmlns:a16="http://schemas.microsoft.com/office/drawing/2014/main" id="{1F45D0AD-31BD-4942-8DE4-08F4CAA85A35}"/>
+                <a16:creationId xmlns:a16="http://schemas.microsoft.com/office/drawing/2014/main" id="{ABF0CB79-3E1D-447F-A714-8496468E2069}"/>
               </a:ext>
             </a:extLst>
           </p:cNvPr>
@@ -16617,7 +16617,7 @@
           <p:cNvPr id="5" name="">
             <a:extLst xmlns:a="http://schemas.openxmlformats.org/drawingml/2006/main">
               <a:ext uri="{FF2B5EF4-FFF2-40B4-BE49-F238E27FC236}">
-                <a16:creationId xmlns:a16="http://schemas.microsoft.com/office/drawing/2014/main" id="{A165BFDA-4E0A-4524-A9BC-5EFFEA56E7B6}"/>
+                <a16:creationId xmlns:a16="http://schemas.microsoft.com/office/drawing/2014/main" id="{6B28A185-431F-42EA-A8E4-FBDF20312A2C}"/>
               </a:ext>
             </a:extLst>
           </p:cNvPr>
@@ -16774,7 +16774,7 @@
           <p:cNvPr id="6" name="">
             <a:extLst xmlns:a="http://schemas.openxmlformats.org/drawingml/2006/main">
               <a:ext uri="{FF2B5EF4-FFF2-40B4-BE49-F238E27FC236}">
-                <a16:creationId xmlns:a16="http://schemas.microsoft.com/office/drawing/2014/main" id="{9E45B62A-695B-42D1-BC85-8EF5085B02A2}"/>
+                <a16:creationId xmlns:a16="http://schemas.microsoft.com/office/drawing/2014/main" id="{D382BF01-A9EC-4E81-B9F0-C38B695DC01C}"/>
               </a:ext>
             </a:extLst>
           </p:cNvPr>
@@ -16931,7 +16931,7 @@
           <p:cNvPr id="7" name="">
             <a:extLst xmlns:a="http://schemas.openxmlformats.org/drawingml/2006/main">
               <a:ext uri="{FF2B5EF4-FFF2-40B4-BE49-F238E27FC236}">
-                <a16:creationId xmlns:a16="http://schemas.microsoft.com/office/drawing/2014/main" id="{DD520F66-5A15-4DFC-B686-19A0B343FCB2}"/>
+                <a16:creationId xmlns:a16="http://schemas.microsoft.com/office/drawing/2014/main" id="{D772DD24-2B33-4639-9A7F-E8EBDACC68E0}"/>
               </a:ext>
             </a:extLst>
           </p:cNvPr>
@@ -17088,7 +17088,7 @@
           <p:cNvPr id="8" name="">
             <a:extLst xmlns:a="http://schemas.openxmlformats.org/drawingml/2006/main">
               <a:ext uri="{FF2B5EF4-FFF2-40B4-BE49-F238E27FC236}">
-                <a16:creationId xmlns:a16="http://schemas.microsoft.com/office/drawing/2014/main" id="{49470566-8EB3-4261-B7F3-54398462AA6E}"/>
+                <a16:creationId xmlns:a16="http://schemas.microsoft.com/office/drawing/2014/main" id="{4D71D8A6-97CB-4072-B53C-11B7A4A0666B}"/>
               </a:ext>
             </a:extLst>
           </p:cNvPr>
@@ -17245,7 +17245,7 @@
           <p:cNvPr id="9" name="">
             <a:extLst xmlns:a="http://schemas.openxmlformats.org/drawingml/2006/main">
               <a:ext uri="{FF2B5EF4-FFF2-40B4-BE49-F238E27FC236}">
-                <a16:creationId xmlns:a16="http://schemas.microsoft.com/office/drawing/2014/main" id="{99DAC7AA-BB74-4E6D-960E-DEFEFF061402}"/>
+                <a16:creationId xmlns:a16="http://schemas.microsoft.com/office/drawing/2014/main" id="{4714AA2F-04EA-4ADE-B93E-8E526BC1A011}"/>
               </a:ext>
             </a:extLst>
           </p:cNvPr>
@@ -17402,7 +17402,7 @@
           <p:cNvPr id="10" name="">
             <a:extLst xmlns:a="http://schemas.openxmlformats.org/drawingml/2006/main">
               <a:ext uri="{FF2B5EF4-FFF2-40B4-BE49-F238E27FC236}">
-                <a16:creationId xmlns:a16="http://schemas.microsoft.com/office/drawing/2014/main" id="{CFDB70C9-1379-43A2-A346-0E6B266DD200}"/>
+                <a16:creationId xmlns:a16="http://schemas.microsoft.com/office/drawing/2014/main" id="{35278C19-7175-4709-A7EE-2B58E686A1B5}"/>
               </a:ext>
             </a:extLst>
           </p:cNvPr>
@@ -17559,7 +17559,7 @@
           <p:cNvPr id="11" name="">
             <a:extLst xmlns:a="http://schemas.openxmlformats.org/drawingml/2006/main">
               <a:ext uri="{FF2B5EF4-FFF2-40B4-BE49-F238E27FC236}">
-                <a16:creationId xmlns:a16="http://schemas.microsoft.com/office/drawing/2014/main" id="{5EDB5393-07FF-4800-A6D2-814C393ACE5F}"/>
+                <a16:creationId xmlns:a16="http://schemas.microsoft.com/office/drawing/2014/main" id="{F96904A1-1BA6-4B8A-B327-50C000B177E0}"/>
               </a:ext>
             </a:extLst>
           </p:cNvPr>
@@ -17716,7 +17716,7 @@
           <p:cNvPr id="12" name="">
             <a:extLst xmlns:a="http://schemas.openxmlformats.org/drawingml/2006/main">
               <a:ext uri="{FF2B5EF4-FFF2-40B4-BE49-F238E27FC236}">
-                <a16:creationId xmlns:a16="http://schemas.microsoft.com/office/drawing/2014/main" id="{DFEB366C-B677-4917-9110-D7756A449AB8}"/>
+                <a16:creationId xmlns:a16="http://schemas.microsoft.com/office/drawing/2014/main" id="{F1E45964-D2B6-45FC-89F3-5EFDC51BC4BA}"/>
               </a:ext>
             </a:extLst>
           </p:cNvPr>
@@ -17873,7 +17873,7 @@
           <p:cNvPr id="13" name="">
             <a:extLst xmlns:a="http://schemas.openxmlformats.org/drawingml/2006/main">
               <a:ext uri="{FF2B5EF4-FFF2-40B4-BE49-F238E27FC236}">
-                <a16:creationId xmlns:a16="http://schemas.microsoft.com/office/drawing/2014/main" id="{E5B917C9-C127-41B7-87A8-9F24B895C212}"/>
+                <a16:creationId xmlns:a16="http://schemas.microsoft.com/office/drawing/2014/main" id="{F84BCA1B-C679-479D-9ED6-37DF8EEE056B}"/>
               </a:ext>
             </a:extLst>
           </p:cNvPr>
@@ -18030,7 +18030,7 @@
           <p:cNvPr id="14" name="">
             <a:extLst xmlns:a="http://schemas.openxmlformats.org/drawingml/2006/main">
               <a:ext uri="{FF2B5EF4-FFF2-40B4-BE49-F238E27FC236}">
-                <a16:creationId xmlns:a16="http://schemas.microsoft.com/office/drawing/2014/main" id="{0078F6A6-85E8-4A62-98CD-1AEDEDDCBC63}"/>
+                <a16:creationId xmlns:a16="http://schemas.microsoft.com/office/drawing/2014/main" id="{B841BE02-6DDF-42F3-935F-F4D3AACA1961}"/>
               </a:ext>
             </a:extLst>
           </p:cNvPr>
@@ -18187,7 +18187,7 @@
           <p:cNvPr id="15" name="">
             <a:extLst xmlns:a="http://schemas.openxmlformats.org/drawingml/2006/main">
               <a:ext uri="{FF2B5EF4-FFF2-40B4-BE49-F238E27FC236}">
-                <a16:creationId xmlns:a16="http://schemas.microsoft.com/office/drawing/2014/main" id="{01CDD737-06A8-41FB-AAD9-2E470B351784}"/>
+                <a16:creationId xmlns:a16="http://schemas.microsoft.com/office/drawing/2014/main" id="{7F31D138-7D8E-4CFF-9089-F10C9DBB3333}"/>
               </a:ext>
             </a:extLst>
           </p:cNvPr>
@@ -18344,7 +18344,7 @@
           <p:cNvPr id="16" name="">
             <a:extLst xmlns:a="http://schemas.openxmlformats.org/drawingml/2006/main">
               <a:ext uri="{FF2B5EF4-FFF2-40B4-BE49-F238E27FC236}">
-                <a16:creationId xmlns:a16="http://schemas.microsoft.com/office/drawing/2014/main" id="{754018F2-9AF2-4830-BB6B-68DF356DCB3D}"/>
+                <a16:creationId xmlns:a16="http://schemas.microsoft.com/office/drawing/2014/main" id="{31B7EF90-CCC3-43A2-8326-495D3B93D428}"/>
               </a:ext>
             </a:extLst>
           </p:cNvPr>
@@ -18354,7 +18354,7 @@
           <p:nvPr/>
         </p:nvPicPr>
         <p:blipFill>
-          <a:blip xmlns:r="http://schemas.openxmlformats.org/officeDocument/2006/relationships" xmlns:a="http://schemas.openxmlformats.org/drawingml/2006/main" r:embed="Rbaa982961a304481"/>
+          <a:blip xmlns:r="http://schemas.openxmlformats.org/officeDocument/2006/relationships" xmlns:a="http://schemas.openxmlformats.org/drawingml/2006/main" r:embed="Rd7a63b0498b447ab"/>
           <a:stretch xmlns:a="http://schemas.openxmlformats.org/drawingml/2006/main"/>
         </p:blipFill>
         <p:spPr>
@@ -18372,7 +18372,7 @@
           <p:cNvPr id="17" name="">
             <a:extLst xmlns:a="http://schemas.openxmlformats.org/drawingml/2006/main">
               <a:ext uri="{FF2B5EF4-FFF2-40B4-BE49-F238E27FC236}">
-                <a16:creationId xmlns:a16="http://schemas.microsoft.com/office/drawing/2014/main" id="{62F15BA2-C8D9-4A18-A748-F5C1F20E3A00}"/>
+                <a16:creationId xmlns:a16="http://schemas.microsoft.com/office/drawing/2014/main" id="{4F781AE0-56FD-451D-96D1-5938ECA33A87}"/>
               </a:ext>
             </a:extLst>
           </p:cNvPr>
@@ -18527,7 +18527,7 @@
     </p:spTree>
     <p:extLst>
       <p:ext uri="{BB962C8B-B14F-4D97-AF65-F5344CB8AC3E}">
-        <p14:creationId xmlns:p14="http://schemas.microsoft.com/office/powerpoint/2010/main" val="1392106558"/>
+        <p14:creationId xmlns:p14="http://schemas.microsoft.com/office/powerpoint/2010/main" val="259837809"/>
       </p:ext>
     </p:extLst>
   </p:cSld>
@@ -18558,7 +18558,7 @@
           <p:cNvPr id="9" name="">
             <a:extLst xmlns:a="http://schemas.openxmlformats.org/drawingml/2006/main">
               <a:ext uri="{FF2B5EF4-FFF2-40B4-BE49-F238E27FC236}">
-                <a16:creationId xmlns:a16="http://schemas.microsoft.com/office/drawing/2014/main" id="{2BBFBC78-D227-463B-B449-CB94FF3E41D5}"/>
+                <a16:creationId xmlns:a16="http://schemas.microsoft.com/office/drawing/2014/main" id="{6F16E1D3-C809-4274-B53F-F69009968CF5}"/>
               </a:ext>
             </a:extLst>
           </p:cNvPr>
@@ -18715,7 +18715,7 @@
           <p:cNvPr id="2" name="">
             <a:extLst xmlns:a="http://schemas.openxmlformats.org/drawingml/2006/main">
               <a:ext uri="{FF2B5EF4-FFF2-40B4-BE49-F238E27FC236}">
-                <a16:creationId xmlns:a16="http://schemas.microsoft.com/office/drawing/2014/main" id="{681CBF01-CFCC-4AB5-A1E1-EAC2603241DE}"/>
+                <a16:creationId xmlns:a16="http://schemas.microsoft.com/office/drawing/2014/main" id="{BF7098E0-944F-4AF4-814D-2B280B6D2BBA}"/>
               </a:ext>
             </a:extLst>
           </p:cNvPr>
@@ -18872,7 +18872,7 @@
           <p:cNvPr id="3" name="">
             <a:extLst xmlns:a="http://schemas.openxmlformats.org/drawingml/2006/main">
               <a:ext uri="{FF2B5EF4-FFF2-40B4-BE49-F238E27FC236}">
-                <a16:creationId xmlns:a16="http://schemas.microsoft.com/office/drawing/2014/main" id="{B6A4AB0C-808E-4C0E-B93D-7CD8E7FD4EB5}"/>
+                <a16:creationId xmlns:a16="http://schemas.microsoft.com/office/drawing/2014/main" id="{2CF3DBF6-9FF4-4D12-B0B2-6D2A4C3F9284}"/>
               </a:ext>
             </a:extLst>
           </p:cNvPr>
@@ -19029,7 +19029,7 @@
           <p:cNvPr id="4" name="">
             <a:extLst xmlns:a="http://schemas.openxmlformats.org/drawingml/2006/main">
               <a:ext uri="{FF2B5EF4-FFF2-40B4-BE49-F238E27FC236}">
-                <a16:creationId xmlns:a16="http://schemas.microsoft.com/office/drawing/2014/main" id="{F309DF86-E890-4B4F-84C9-A65707D37435}"/>
+                <a16:creationId xmlns:a16="http://schemas.microsoft.com/office/drawing/2014/main" id="{76E5E154-8580-4B26-BAD7-8C07CDF7BAB7}"/>
               </a:ext>
             </a:extLst>
           </p:cNvPr>
@@ -19186,7 +19186,7 @@
           <p:cNvPr id="5" name="">
             <a:extLst xmlns:a="http://schemas.openxmlformats.org/drawingml/2006/main">
               <a:ext uri="{FF2B5EF4-FFF2-40B4-BE49-F238E27FC236}">
-                <a16:creationId xmlns:a16="http://schemas.microsoft.com/office/drawing/2014/main" id="{C855D823-A554-4C1E-B9A2-E0A5D5ECB3DF}"/>
+                <a16:creationId xmlns:a16="http://schemas.microsoft.com/office/drawing/2014/main" id="{7F454C8E-63A9-4C67-9EE5-02D2FE8BE05F}"/>
               </a:ext>
             </a:extLst>
           </p:cNvPr>
@@ -19196,7 +19196,7 @@
           <p:nvPr/>
         </p:nvPicPr>
         <p:blipFill>
-          <a:blip xmlns:r="http://schemas.openxmlformats.org/officeDocument/2006/relationships" xmlns:a="http://schemas.openxmlformats.org/drawingml/2006/main" r:embed="Rb5710d7498914ad3"/>
+          <a:blip xmlns:r="http://schemas.openxmlformats.org/officeDocument/2006/relationships" xmlns:a="http://schemas.openxmlformats.org/drawingml/2006/main" r:embed="R1f98e29b9ac8440d"/>
           <a:stretch xmlns:a="http://schemas.openxmlformats.org/drawingml/2006/main"/>
         </p:blipFill>
         <p:spPr>
@@ -19214,7 +19214,7 @@
           <p:cNvPr id="6" name="">
             <a:extLst xmlns:a="http://schemas.openxmlformats.org/drawingml/2006/main">
               <a:ext uri="{FF2B5EF4-FFF2-40B4-BE49-F238E27FC236}">
-                <a16:creationId xmlns:a16="http://schemas.microsoft.com/office/drawing/2014/main" id="{13380C24-140A-487F-B389-BAB2291CB19D}"/>
+                <a16:creationId xmlns:a16="http://schemas.microsoft.com/office/drawing/2014/main" id="{1B1F49F6-F129-4777-AF0B-56C94B789ACC}"/>
               </a:ext>
             </a:extLst>
           </p:cNvPr>
@@ -19224,7 +19224,7 @@
           <p:nvPr/>
         </p:nvPicPr>
         <p:blipFill>
-          <a:blip xmlns:r="http://schemas.openxmlformats.org/officeDocument/2006/relationships" xmlns:a="http://schemas.openxmlformats.org/drawingml/2006/main" r:embed="R4d0088472051417e"/>
+          <a:blip xmlns:r="http://schemas.openxmlformats.org/officeDocument/2006/relationships" xmlns:a="http://schemas.openxmlformats.org/drawingml/2006/main" r:embed="R31229f9563aa4535"/>
           <a:stretch xmlns:a="http://schemas.openxmlformats.org/drawingml/2006/main"/>
         </p:blipFill>
         <p:spPr>
@@ -19242,7 +19242,7 @@
           <p:cNvPr id="7" name="">
             <a:extLst xmlns:a="http://schemas.openxmlformats.org/drawingml/2006/main">
               <a:ext uri="{FF2B5EF4-FFF2-40B4-BE49-F238E27FC236}">
-                <a16:creationId xmlns:a16="http://schemas.microsoft.com/office/drawing/2014/main" id="{BAFAA046-24DB-46DD-8BD1-0DFC43AD0216}"/>
+                <a16:creationId xmlns:a16="http://schemas.microsoft.com/office/drawing/2014/main" id="{496B8A24-7FC1-4867-AF10-DAE679DCE54F}"/>
               </a:ext>
             </a:extLst>
           </p:cNvPr>
@@ -19399,7 +19399,7 @@
           <p:cNvPr id="8" name="">
             <a:extLst xmlns:a="http://schemas.openxmlformats.org/drawingml/2006/main">
               <a:ext uri="{FF2B5EF4-FFF2-40B4-BE49-F238E27FC236}">
-                <a16:creationId xmlns:a16="http://schemas.microsoft.com/office/drawing/2014/main" id="{507276D6-3082-47C9-9A90-AF497BA9A24A}"/>
+                <a16:creationId xmlns:a16="http://schemas.microsoft.com/office/drawing/2014/main" id="{036433FD-C4E3-4B52-B2CC-BC84149401AA}"/>
               </a:ext>
             </a:extLst>
           </p:cNvPr>
@@ -19554,7 +19554,7 @@
     </p:spTree>
     <p:extLst>
       <p:ext uri="{BB962C8B-B14F-4D97-AF65-F5344CB8AC3E}">
-        <p14:creationId xmlns:p14="http://schemas.microsoft.com/office/powerpoint/2010/main" val="1066894043"/>
+        <p14:creationId xmlns:p14="http://schemas.microsoft.com/office/powerpoint/2010/main" val="1112209790"/>
       </p:ext>
     </p:extLst>
   </p:cSld>
@@ -19585,7 +19585,7 @@
           <p:cNvPr id="12" name="">
             <a:extLst xmlns:a="http://schemas.openxmlformats.org/drawingml/2006/main">
               <a:ext uri="{FF2B5EF4-FFF2-40B4-BE49-F238E27FC236}">
-                <a16:creationId xmlns:a16="http://schemas.microsoft.com/office/drawing/2014/main" id="{3F3E2544-E2BD-4D7F-BB31-749FD57EB520}"/>
+                <a16:creationId xmlns:a16="http://schemas.microsoft.com/office/drawing/2014/main" id="{CDC11615-6179-40AF-9C6D-0B5CD03C4B86}"/>
               </a:ext>
             </a:extLst>
           </p:cNvPr>
@@ -19742,7 +19742,7 @@
           <p:cNvPr id="2" name="">
             <a:extLst xmlns:a="http://schemas.openxmlformats.org/drawingml/2006/main">
               <a:ext uri="{FF2B5EF4-FFF2-40B4-BE49-F238E27FC236}">
-                <a16:creationId xmlns:a16="http://schemas.microsoft.com/office/drawing/2014/main" id="{82468884-93C4-4DEF-915C-BE68C543809A}"/>
+                <a16:creationId xmlns:a16="http://schemas.microsoft.com/office/drawing/2014/main" id="{214DBA04-8152-4CA5-9C86-A9F74FA0F547}"/>
               </a:ext>
             </a:extLst>
           </p:cNvPr>
@@ -19899,7 +19899,7 @@
           <p:cNvPr id="3" name="">
             <a:extLst xmlns:a="http://schemas.openxmlformats.org/drawingml/2006/main">
               <a:ext uri="{FF2B5EF4-FFF2-40B4-BE49-F238E27FC236}">
-                <a16:creationId xmlns:a16="http://schemas.microsoft.com/office/drawing/2014/main" id="{63B1BF14-83AE-4867-B4BC-6B413104E6EE}"/>
+                <a16:creationId xmlns:a16="http://schemas.microsoft.com/office/drawing/2014/main" id="{D7F7042F-BFA2-4140-9CF9-19D315372BBB}"/>
               </a:ext>
             </a:extLst>
           </p:cNvPr>
@@ -20056,7 +20056,7 @@
           <p:cNvPr id="4" name="">
             <a:extLst xmlns:a="http://schemas.openxmlformats.org/drawingml/2006/main">
               <a:ext uri="{FF2B5EF4-FFF2-40B4-BE49-F238E27FC236}">
-                <a16:creationId xmlns:a16="http://schemas.microsoft.com/office/drawing/2014/main" id="{C6ED73CD-E66F-4893-8EC2-2E382692A95A}"/>
+                <a16:creationId xmlns:a16="http://schemas.microsoft.com/office/drawing/2014/main" id="{3094C02E-0F18-4771-AC99-06D2CD89FD3D}"/>
               </a:ext>
             </a:extLst>
           </p:cNvPr>
@@ -20213,7 +20213,7 @@
           <p:cNvPr id="5" name="">
             <a:extLst xmlns:a="http://schemas.openxmlformats.org/drawingml/2006/main">
               <a:ext uri="{FF2B5EF4-FFF2-40B4-BE49-F238E27FC236}">
-                <a16:creationId xmlns:a16="http://schemas.microsoft.com/office/drawing/2014/main" id="{2F397CC0-EF5E-40C2-947A-E6F6949ADD48}"/>
+                <a16:creationId xmlns:a16="http://schemas.microsoft.com/office/drawing/2014/main" id="{ABCED778-F1DA-486F-A6AE-D54CC2469B29}"/>
               </a:ext>
             </a:extLst>
           </p:cNvPr>
@@ -20370,7 +20370,7 @@
           <p:cNvPr id="6" name="">
             <a:extLst xmlns:a="http://schemas.openxmlformats.org/drawingml/2006/main">
               <a:ext uri="{FF2B5EF4-FFF2-40B4-BE49-F238E27FC236}">
-                <a16:creationId xmlns:a16="http://schemas.microsoft.com/office/drawing/2014/main" id="{E3EE1829-084B-4EBE-8747-5DA5523B0F28}"/>
+                <a16:creationId xmlns:a16="http://schemas.microsoft.com/office/drawing/2014/main" id="{E8CB0BA3-9200-4F8A-A60B-E712D7AAFC45}"/>
               </a:ext>
             </a:extLst>
           </p:cNvPr>
@@ -20527,7 +20527,7 @@
           <p:cNvPr id="7" name="">
             <a:extLst xmlns:a="http://schemas.openxmlformats.org/drawingml/2006/main">
               <a:ext uri="{FF2B5EF4-FFF2-40B4-BE49-F238E27FC236}">
-                <a16:creationId xmlns:a16="http://schemas.microsoft.com/office/drawing/2014/main" id="{3AA52AE3-5661-43DC-B118-CD25F3E624F7}"/>
+                <a16:creationId xmlns:a16="http://schemas.microsoft.com/office/drawing/2014/main" id="{F688535D-2265-479F-B1F8-28C86CFF65F5}"/>
               </a:ext>
             </a:extLst>
           </p:cNvPr>
@@ -20684,7 +20684,7 @@
           <p:cNvPr id="8" name="">
             <a:extLst xmlns:a="http://schemas.openxmlformats.org/drawingml/2006/main">
               <a:ext uri="{FF2B5EF4-FFF2-40B4-BE49-F238E27FC236}">
-                <a16:creationId xmlns:a16="http://schemas.microsoft.com/office/drawing/2014/main" id="{DA5AEDD2-D2BE-4D05-A3FA-776B612FC793}"/>
+                <a16:creationId xmlns:a16="http://schemas.microsoft.com/office/drawing/2014/main" id="{D33DAE8E-64DD-4299-A940-64FF3EF819F8}"/>
               </a:ext>
             </a:extLst>
           </p:cNvPr>
@@ -20841,7 +20841,7 @@
           <p:cNvPr id="9" name="">
             <a:extLst xmlns:a="http://schemas.openxmlformats.org/drawingml/2006/main">
               <a:ext uri="{FF2B5EF4-FFF2-40B4-BE49-F238E27FC236}">
-                <a16:creationId xmlns:a16="http://schemas.microsoft.com/office/drawing/2014/main" id="{F5E965AF-20BA-4B75-A409-1E4B56C2E285}"/>
+                <a16:creationId xmlns:a16="http://schemas.microsoft.com/office/drawing/2014/main" id="{0E40266D-4E1A-48D7-9780-3D33E1236DCE}"/>
               </a:ext>
             </a:extLst>
           </p:cNvPr>
@@ -20998,7 +20998,7 @@
           <p:cNvPr id="10" name="">
             <a:extLst xmlns:a="http://schemas.openxmlformats.org/drawingml/2006/main">
               <a:ext uri="{FF2B5EF4-FFF2-40B4-BE49-F238E27FC236}">
-                <a16:creationId xmlns:a16="http://schemas.microsoft.com/office/drawing/2014/main" id="{0B9641CA-B9F4-4E39-BA2F-E25D2D1C1EC0}"/>
+                <a16:creationId xmlns:a16="http://schemas.microsoft.com/office/drawing/2014/main" id="{DE5BD29A-0146-4E9C-A32E-45C87FAF5B4B}"/>
               </a:ext>
             </a:extLst>
           </p:cNvPr>
@@ -21155,7 +21155,7 @@
           <p:cNvPr id="11" name="">
             <a:extLst xmlns:a="http://schemas.openxmlformats.org/drawingml/2006/main">
               <a:ext uri="{FF2B5EF4-FFF2-40B4-BE49-F238E27FC236}">
-                <a16:creationId xmlns:a16="http://schemas.microsoft.com/office/drawing/2014/main" id="{1636B3A1-3706-4C72-8D5E-CA2B87AE5AE3}"/>
+                <a16:creationId xmlns:a16="http://schemas.microsoft.com/office/drawing/2014/main" id="{051074BE-1EA9-4420-A4E0-82EED8C519DD}"/>
               </a:ext>
             </a:extLst>
           </p:cNvPr>
@@ -21165,7 +21165,7 @@
           <p:nvPr/>
         </p:nvPicPr>
         <p:blipFill>
-          <a:blip xmlns:r="http://schemas.openxmlformats.org/officeDocument/2006/relationships" xmlns:a="http://schemas.openxmlformats.org/drawingml/2006/main" r:embed="Re694ee3e95f742fd"/>
+          <a:blip xmlns:r="http://schemas.openxmlformats.org/officeDocument/2006/relationships" xmlns:a="http://schemas.openxmlformats.org/drawingml/2006/main" r:embed="R4b27a6e42f374974"/>
           <a:stretch xmlns:a="http://schemas.openxmlformats.org/drawingml/2006/main"/>
         </p:blipFill>
         <p:spPr>
@@ -21181,7 +21181,7 @@
     </p:spTree>
     <p:extLst>
       <p:ext uri="{BB962C8B-B14F-4D97-AF65-F5344CB8AC3E}">
-        <p14:creationId xmlns:p14="http://schemas.microsoft.com/office/powerpoint/2010/main" val="1808816140"/>
+        <p14:creationId xmlns:p14="http://schemas.microsoft.com/office/powerpoint/2010/main" val="1322826503"/>
       </p:ext>
     </p:extLst>
   </p:cSld>
@@ -21212,7 +21212,7 @@
           <p:cNvPr id="11" name="">
             <a:extLst xmlns:a="http://schemas.openxmlformats.org/drawingml/2006/main">
               <a:ext uri="{FF2B5EF4-FFF2-40B4-BE49-F238E27FC236}">
-                <a16:creationId xmlns:a16="http://schemas.microsoft.com/office/drawing/2014/main" id="{480FB5E4-7DC1-4B01-B003-B0C8C4CA2372}"/>
+                <a16:creationId xmlns:a16="http://schemas.microsoft.com/office/drawing/2014/main" id="{2084BE4B-7CC1-47AE-A5C8-C6A1A121AC64}"/>
               </a:ext>
             </a:extLst>
           </p:cNvPr>
@@ -21369,7 +21369,7 @@
           <p:cNvPr id="2" name="">
             <a:extLst xmlns:a="http://schemas.openxmlformats.org/drawingml/2006/main">
               <a:ext uri="{FF2B5EF4-FFF2-40B4-BE49-F238E27FC236}">
-                <a16:creationId xmlns:a16="http://schemas.microsoft.com/office/drawing/2014/main" id="{3E6E054D-FFC3-427F-B2B9-BBBCD1F633CE}"/>
+                <a16:creationId xmlns:a16="http://schemas.microsoft.com/office/drawing/2014/main" id="{105664F6-104D-4313-B44E-08CEA98E724D}"/>
               </a:ext>
             </a:extLst>
           </p:cNvPr>
@@ -21526,7 +21526,7 @@
           <p:cNvPr id="3" name="Chart">
             <a:extLst xmlns:a="http://schemas.openxmlformats.org/drawingml/2006/main">
               <a:ext uri="{FF2B5EF4-FFF2-40B4-BE49-F238E27FC236}">
-                <a16:creationId xmlns:a16="http://schemas.microsoft.com/office/drawing/2014/main" id="{95772FE4-C47A-494B-ACB0-4326733BD9FD}"/>
+                <a16:creationId xmlns:a16="http://schemas.microsoft.com/office/drawing/2014/main" id="{739C46F8-8765-48B2-90AC-76DE2EA3A1BE}"/>
               </a:ext>
             </a:extLst>
           </p:cNvPr>
@@ -21539,7 +21539,7 @@
         </p:xfrm>
         <a:graphic xmlns:a="http://schemas.openxmlformats.org/drawingml/2006/main">
           <a:graphicData uri="http://schemas.openxmlformats.org/drawingml/2006/chart">
-            <c:chart xmlns:r="http://schemas.openxmlformats.org/officeDocument/2006/relationships" xmlns:c="http://schemas.openxmlformats.org/drawingml/2006/chart" r:id="Rfee5a25c1ebd4dea"/>
+            <c:chart xmlns:r="http://schemas.openxmlformats.org/officeDocument/2006/relationships" xmlns:c="http://schemas.openxmlformats.org/drawingml/2006/chart" r:id="R0223d16e4e5b4520"/>
           </a:graphicData>
         </a:graphic>
       </p:graphicFrame>
@@ -21548,7 +21548,7 @@
           <p:cNvPr id="4" name="">
             <a:extLst xmlns:a="http://schemas.openxmlformats.org/drawingml/2006/main">
               <a:ext uri="{FF2B5EF4-FFF2-40B4-BE49-F238E27FC236}">
-                <a16:creationId xmlns:a16="http://schemas.microsoft.com/office/drawing/2014/main" id="{13D9CDF9-A96A-4BD7-AE76-B434B68EEB58}"/>
+                <a16:creationId xmlns:a16="http://schemas.microsoft.com/office/drawing/2014/main" id="{AF007C5E-C845-4894-B1D4-7391B51302BF}"/>
               </a:ext>
             </a:extLst>
           </p:cNvPr>
@@ -21705,7 +21705,7 @@
           <p:cNvPr id="5" name="">
             <a:extLst xmlns:a="http://schemas.openxmlformats.org/drawingml/2006/main">
               <a:ext uri="{FF2B5EF4-FFF2-40B4-BE49-F238E27FC236}">
-                <a16:creationId xmlns:a16="http://schemas.microsoft.com/office/drawing/2014/main" id="{61F14133-0457-4897-9830-9883E7D95224}"/>
+                <a16:creationId xmlns:a16="http://schemas.microsoft.com/office/drawing/2014/main" id="{5C995626-F305-4913-AE39-82E09257FE32}"/>
               </a:ext>
             </a:extLst>
           </p:cNvPr>
@@ -21862,7 +21862,7 @@
           <p:cNvPr id="6" name="">
             <a:extLst xmlns:a="http://schemas.openxmlformats.org/drawingml/2006/main">
               <a:ext uri="{FF2B5EF4-FFF2-40B4-BE49-F238E27FC236}">
-                <a16:creationId xmlns:a16="http://schemas.microsoft.com/office/drawing/2014/main" id="{7319EC1D-FBE2-43CE-833C-63718979088C}"/>
+                <a16:creationId xmlns:a16="http://schemas.microsoft.com/office/drawing/2014/main" id="{6F784187-39EA-4ED3-B969-F46D03016AF5}"/>
               </a:ext>
             </a:extLst>
           </p:cNvPr>
@@ -22019,7 +22019,7 @@
           <p:cNvPr id="7" name="">
             <a:extLst xmlns:a="http://schemas.openxmlformats.org/drawingml/2006/main">
               <a:ext uri="{FF2B5EF4-FFF2-40B4-BE49-F238E27FC236}">
-                <a16:creationId xmlns:a16="http://schemas.microsoft.com/office/drawing/2014/main" id="{DCAB88CD-7CB3-4198-B185-B5BC15030329}"/>
+                <a16:creationId xmlns:a16="http://schemas.microsoft.com/office/drawing/2014/main" id="{8AB84A62-324E-4508-AEF3-1A66ED5811E9}"/>
               </a:ext>
             </a:extLst>
           </p:cNvPr>
@@ -22176,7 +22176,7 @@
           <p:cNvPr id="8" name="">
             <a:extLst xmlns:a="http://schemas.openxmlformats.org/drawingml/2006/main">
               <a:ext uri="{FF2B5EF4-FFF2-40B4-BE49-F238E27FC236}">
-                <a16:creationId xmlns:a16="http://schemas.microsoft.com/office/drawing/2014/main" id="{17359DD6-0057-46D6-B69C-67ACB106C963}"/>
+                <a16:creationId xmlns:a16="http://schemas.microsoft.com/office/drawing/2014/main" id="{7B90C5F8-D298-4820-B1F0-333C92C376A0}"/>
               </a:ext>
             </a:extLst>
           </p:cNvPr>
@@ -22333,7 +22333,7 @@
           <p:cNvPr id="9" name="">
             <a:extLst xmlns:a="http://schemas.openxmlformats.org/drawingml/2006/main">
               <a:ext uri="{FF2B5EF4-FFF2-40B4-BE49-F238E27FC236}">
-                <a16:creationId xmlns:a16="http://schemas.microsoft.com/office/drawing/2014/main" id="{E87B2721-2184-46F6-82B5-F8B83B88487C}"/>
+                <a16:creationId xmlns:a16="http://schemas.microsoft.com/office/drawing/2014/main" id="{FCF6A643-E815-436C-AD99-7DE1E7044484}"/>
               </a:ext>
             </a:extLst>
           </p:cNvPr>
@@ -22490,7 +22490,7 @@
           <p:cNvPr id="10" name="">
             <a:extLst xmlns:a="http://schemas.openxmlformats.org/drawingml/2006/main">
               <a:ext uri="{FF2B5EF4-FFF2-40B4-BE49-F238E27FC236}">
-                <a16:creationId xmlns:a16="http://schemas.microsoft.com/office/drawing/2014/main" id="{BC454EA5-B495-4504-B854-1C28D49A4BF5}"/>
+                <a16:creationId xmlns:a16="http://schemas.microsoft.com/office/drawing/2014/main" id="{97A4D2D3-C8D3-4FD3-AB3F-20211ABE6BC7}"/>
               </a:ext>
             </a:extLst>
           </p:cNvPr>
@@ -22645,7 +22645,7 @@
     </p:spTree>
     <p:extLst>
       <p:ext uri="{BB962C8B-B14F-4D97-AF65-F5344CB8AC3E}">
-        <p14:creationId xmlns:p14="http://schemas.microsoft.com/office/powerpoint/2010/main" val="190757822"/>
+        <p14:creationId xmlns:p14="http://schemas.microsoft.com/office/powerpoint/2010/main" val="203776769"/>
       </p:ext>
     </p:extLst>
   </p:cSld>
@@ -22676,7 +22676,7 @@
           <p:cNvPr id="13" name="">
             <a:extLst xmlns:a="http://schemas.openxmlformats.org/drawingml/2006/main">
               <a:ext uri="{FF2B5EF4-FFF2-40B4-BE49-F238E27FC236}">
-                <a16:creationId xmlns:a16="http://schemas.microsoft.com/office/drawing/2014/main" id="{3851D21B-2FBB-4AAC-AAD7-C6B3D0D41485}"/>
+                <a16:creationId xmlns:a16="http://schemas.microsoft.com/office/drawing/2014/main" id="{FFDAEAD3-51E0-4BC5-A732-0304C17F3703}"/>
               </a:ext>
             </a:extLst>
           </p:cNvPr>
@@ -22833,7 +22833,7 @@
           <p:cNvPr id="2" name="">
             <a:extLst xmlns:a="http://schemas.openxmlformats.org/drawingml/2006/main">
               <a:ext uri="{FF2B5EF4-FFF2-40B4-BE49-F238E27FC236}">
-                <a16:creationId xmlns:a16="http://schemas.microsoft.com/office/drawing/2014/main" id="{202EEF7C-58F3-4899-844F-367F0EDDB7F5}"/>
+                <a16:creationId xmlns:a16="http://schemas.microsoft.com/office/drawing/2014/main" id="{8C5781CF-1A51-403F-AC00-CF3930C6E054}"/>
               </a:ext>
             </a:extLst>
           </p:cNvPr>
@@ -22990,7 +22990,7 @@
           <p:cNvPr id="3" name="">
             <a:extLst xmlns:a="http://schemas.openxmlformats.org/drawingml/2006/main">
               <a:ext uri="{FF2B5EF4-FFF2-40B4-BE49-F238E27FC236}">
-                <a16:creationId xmlns:a16="http://schemas.microsoft.com/office/drawing/2014/main" id="{9F19F2A6-8660-40EA-BE5A-7BE8A06A9B3E}"/>
+                <a16:creationId xmlns:a16="http://schemas.microsoft.com/office/drawing/2014/main" id="{083E749F-A1F5-49A2-9C17-83ED79C71CC6}"/>
               </a:ext>
             </a:extLst>
           </p:cNvPr>
@@ -23000,7 +23000,7 @@
           <p:nvPr/>
         </p:nvPicPr>
         <p:blipFill>
-          <a:blip xmlns:r="http://schemas.openxmlformats.org/officeDocument/2006/relationships" xmlns:a="http://schemas.openxmlformats.org/drawingml/2006/main" r:embed="R9741586573564930"/>
+          <a:blip xmlns:r="http://schemas.openxmlformats.org/officeDocument/2006/relationships" xmlns:a="http://schemas.openxmlformats.org/drawingml/2006/main" r:embed="R8cb08d71654a4d44"/>
           <a:stretch xmlns:a="http://schemas.openxmlformats.org/drawingml/2006/main"/>
         </p:blipFill>
         <p:spPr>
@@ -23018,7 +23018,7 @@
           <p:cNvPr id="4" name="">
             <a:extLst xmlns:a="http://schemas.openxmlformats.org/drawingml/2006/main">
               <a:ext uri="{FF2B5EF4-FFF2-40B4-BE49-F238E27FC236}">
-                <a16:creationId xmlns:a16="http://schemas.microsoft.com/office/drawing/2014/main" id="{6E1905AE-23D9-4A67-8384-A82710902616}"/>
+                <a16:creationId xmlns:a16="http://schemas.microsoft.com/office/drawing/2014/main" id="{81C0A27B-76D7-4222-9E68-D61A93EC8510}"/>
               </a:ext>
             </a:extLst>
           </p:cNvPr>
@@ -23175,7 +23175,7 @@
           <p:cNvPr id="5" name="">
             <a:extLst xmlns:a="http://schemas.openxmlformats.org/drawingml/2006/main">
               <a:ext uri="{FF2B5EF4-FFF2-40B4-BE49-F238E27FC236}">
-                <a16:creationId xmlns:a16="http://schemas.microsoft.com/office/drawing/2014/main" id="{BC7A865E-BAEE-440F-AFE5-FC1E44A3427F}"/>
+                <a16:creationId xmlns:a16="http://schemas.microsoft.com/office/drawing/2014/main" id="{4472052A-D42F-4132-BD0A-B9DA4D701047}"/>
               </a:ext>
             </a:extLst>
           </p:cNvPr>
@@ -23332,7 +23332,7 @@
           <p:cNvPr id="6" name="">
             <a:extLst xmlns:a="http://schemas.openxmlformats.org/drawingml/2006/main">
               <a:ext uri="{FF2B5EF4-FFF2-40B4-BE49-F238E27FC236}">
-                <a16:creationId xmlns:a16="http://schemas.microsoft.com/office/drawing/2014/main" id="{E3A95AF3-398C-4BEB-B411-5CC849081454}"/>
+                <a16:creationId xmlns:a16="http://schemas.microsoft.com/office/drawing/2014/main" id="{E1A5A828-9016-46E1-8B62-44582660761D}"/>
               </a:ext>
             </a:extLst>
           </p:cNvPr>
@@ -23489,7 +23489,7 @@
           <p:cNvPr id="7" name="">
             <a:extLst xmlns:a="http://schemas.openxmlformats.org/drawingml/2006/main">
               <a:ext uri="{FF2B5EF4-FFF2-40B4-BE49-F238E27FC236}">
-                <a16:creationId xmlns:a16="http://schemas.microsoft.com/office/drawing/2014/main" id="{7169295B-810E-438A-B34B-99DDD618864D}"/>
+                <a16:creationId xmlns:a16="http://schemas.microsoft.com/office/drawing/2014/main" id="{81882263-10EB-4D1F-A5A7-18238B5BF2C6}"/>
               </a:ext>
             </a:extLst>
           </p:cNvPr>
@@ -23646,7 +23646,7 @@
           <p:cNvPr id="8" name="">
             <a:extLst xmlns:a="http://schemas.openxmlformats.org/drawingml/2006/main">
               <a:ext uri="{FF2B5EF4-FFF2-40B4-BE49-F238E27FC236}">
-                <a16:creationId xmlns:a16="http://schemas.microsoft.com/office/drawing/2014/main" id="{28C7A4D3-FF9F-4B61-9725-D27D9491FC56}"/>
+                <a16:creationId xmlns:a16="http://schemas.microsoft.com/office/drawing/2014/main" id="{A5C50BAC-EB2C-4475-8D6C-B24514EF0879}"/>
               </a:ext>
             </a:extLst>
           </p:cNvPr>
@@ -23803,7 +23803,7 @@
           <p:cNvPr id="9" name="">
             <a:extLst xmlns:a="http://schemas.openxmlformats.org/drawingml/2006/main">
               <a:ext uri="{FF2B5EF4-FFF2-40B4-BE49-F238E27FC236}">
-                <a16:creationId xmlns:a16="http://schemas.microsoft.com/office/drawing/2014/main" id="{1838C458-FB11-4D18-9BC5-8835CB45FCA4}"/>
+                <a16:creationId xmlns:a16="http://schemas.microsoft.com/office/drawing/2014/main" id="{20A45DBB-13C0-424C-9E30-84905ADECB6E}"/>
               </a:ext>
             </a:extLst>
           </p:cNvPr>
@@ -23960,7 +23960,7 @@
           <p:cNvPr id="10" name="">
             <a:extLst xmlns:a="http://schemas.openxmlformats.org/drawingml/2006/main">
               <a:ext uri="{FF2B5EF4-FFF2-40B4-BE49-F238E27FC236}">
-                <a16:creationId xmlns:a16="http://schemas.microsoft.com/office/drawing/2014/main" id="{9E8F7D4C-FE9A-40A7-BFB0-08DEF1150366}"/>
+                <a16:creationId xmlns:a16="http://schemas.microsoft.com/office/drawing/2014/main" id="{C30377FE-EBD2-44CB-96C9-03F64D61BF18}"/>
               </a:ext>
             </a:extLst>
           </p:cNvPr>
@@ -24117,7 +24117,7 @@
           <p:cNvPr id="11" name="">
             <a:extLst xmlns:a="http://schemas.openxmlformats.org/drawingml/2006/main">
               <a:ext uri="{FF2B5EF4-FFF2-40B4-BE49-F238E27FC236}">
-                <a16:creationId xmlns:a16="http://schemas.microsoft.com/office/drawing/2014/main" id="{EE9932F5-D854-4FDD-864D-04DE738A8AA6}"/>
+                <a16:creationId xmlns:a16="http://schemas.microsoft.com/office/drawing/2014/main" id="{DA1F003F-9645-477A-90D3-32768E5EA849}"/>
               </a:ext>
             </a:extLst>
           </p:cNvPr>
@@ -24274,7 +24274,7 @@
           <p:cNvPr id="12" name="">
             <a:extLst xmlns:a="http://schemas.openxmlformats.org/drawingml/2006/main">
               <a:ext uri="{FF2B5EF4-FFF2-40B4-BE49-F238E27FC236}">
-                <a16:creationId xmlns:a16="http://schemas.microsoft.com/office/drawing/2014/main" id="{2A5AD15C-519A-4CF3-95F1-1A734A90E9D5}"/>
+                <a16:creationId xmlns:a16="http://schemas.microsoft.com/office/drawing/2014/main" id="{1D1D7C27-7AA9-4D81-8C55-EDC88166F66F}"/>
               </a:ext>
             </a:extLst>
           </p:cNvPr>
@@ -24429,7 +24429,7 @@
     </p:spTree>
     <p:extLst>
       <p:ext uri="{BB962C8B-B14F-4D97-AF65-F5344CB8AC3E}">
-        <p14:creationId xmlns:p14="http://schemas.microsoft.com/office/powerpoint/2010/main" val="2125136443"/>
+        <p14:creationId xmlns:p14="http://schemas.microsoft.com/office/powerpoint/2010/main" val="1990395751"/>
       </p:ext>
     </p:extLst>
   </p:cSld>

</xml_diff>